<commit_message>
remove unnecessary files and re-order power bi
</commit_message>
<xml_diff>
--- a/Abschlusspräsentation_MySQL_Frank_Wünsch.pptx
+++ b/Abschlusspräsentation_MySQL_Frank_Wünsch.pptx
@@ -217,7 +217,7 @@
           <a:p>
             <a:fld id="{588604D7-B149-4CBE-B78F-4BADEB5073F2}" type="datetimeFigureOut">
               <a:rPr lang="de-DE" smtClean="0"/>
-              <a:t>30.01.2026</a:t>
+              <a:t>31.01.2026</a:t>
             </a:fld>
             <a:endParaRPr lang="de-DE"/>
           </a:p>
@@ -631,7 +631,7 @@
           <a:p>
             <a:fld id="{9B7052B1-BD61-421F-A1DA-FDD7F43536D7}" type="datetime1">
               <a:rPr lang="de-DE" smtClean="0"/>
-              <a:t>30.01.2026</a:t>
+              <a:t>31.01.2026</a:t>
             </a:fld>
             <a:endParaRPr lang="en-US"/>
           </a:p>
@@ -832,7 +832,7 @@
           <a:p>
             <a:fld id="{CD6BEBE4-4FCC-4EA8-BDD5-5B3DAC9ABBD4}" type="datetime1">
               <a:rPr lang="de-DE" smtClean="0"/>
-              <a:t>30.01.2026</a:t>
+              <a:t>31.01.2026</a:t>
             </a:fld>
             <a:endParaRPr lang="en-US"/>
           </a:p>
@@ -1043,7 +1043,7 @@
           <a:p>
             <a:fld id="{9F49CD70-EED3-455B-8CC4-948292EB368F}" type="datetime1">
               <a:rPr lang="de-DE" smtClean="0"/>
-              <a:t>30.01.2026</a:t>
+              <a:t>31.01.2026</a:t>
             </a:fld>
             <a:endParaRPr lang="en-US"/>
           </a:p>
@@ -1244,7 +1244,7 @@
           <a:p>
             <a:fld id="{979AD6E7-A48C-4424-B592-37C7B13B8FC0}" type="datetime1">
               <a:rPr lang="de-DE" smtClean="0"/>
-              <a:t>30.01.2026</a:t>
+              <a:t>31.01.2026</a:t>
             </a:fld>
             <a:endParaRPr lang="en-US"/>
           </a:p>
@@ -1522,7 +1522,7 @@
           <a:p>
             <a:fld id="{ACB38205-406A-4507-9625-45CB6BE1106E}" type="datetime1">
               <a:rPr lang="de-DE" smtClean="0"/>
-              <a:t>30.01.2026</a:t>
+              <a:t>31.01.2026</a:t>
             </a:fld>
             <a:endParaRPr lang="en-US"/>
           </a:p>
@@ -1790,7 +1790,7 @@
           <a:p>
             <a:fld id="{BD5A8128-4535-4048-83F7-BDA6F1969AC1}" type="datetime1">
               <a:rPr lang="de-DE" smtClean="0"/>
-              <a:t>30.01.2026</a:t>
+              <a:t>31.01.2026</a:t>
             </a:fld>
             <a:endParaRPr lang="en-US"/>
           </a:p>
@@ -2205,7 +2205,7 @@
           <a:p>
             <a:fld id="{5042F379-9101-4C9D-88C3-C7F8A5AF0689}" type="datetime1">
               <a:rPr lang="de-DE" smtClean="0"/>
-              <a:t>30.01.2026</a:t>
+              <a:t>31.01.2026</a:t>
             </a:fld>
             <a:endParaRPr lang="en-US"/>
           </a:p>
@@ -2349,7 +2349,7 @@
           <a:p>
             <a:fld id="{1655DBDF-0D89-4019-8FD6-4FC0A4BF2CB6}" type="datetime1">
               <a:rPr lang="de-DE" smtClean="0"/>
-              <a:t>30.01.2026</a:t>
+              <a:t>31.01.2026</a:t>
             </a:fld>
             <a:endParaRPr lang="en-US"/>
           </a:p>
@@ -2465,7 +2465,7 @@
           <a:p>
             <a:fld id="{36A35928-6455-4327-9B81-75CC8615A8CE}" type="datetime1">
               <a:rPr lang="de-DE" smtClean="0"/>
-              <a:t>30.01.2026</a:t>
+              <a:t>31.01.2026</a:t>
             </a:fld>
             <a:endParaRPr lang="en-US"/>
           </a:p>
@@ -2779,7 +2779,7 @@
           <a:p>
             <a:fld id="{F77A4E6B-3535-47A9-9B19-077E52398501}" type="datetime1">
               <a:rPr lang="de-DE" smtClean="0"/>
-              <a:t>30.01.2026</a:t>
+              <a:t>31.01.2026</a:t>
             </a:fld>
             <a:endParaRPr lang="en-US"/>
           </a:p>
@@ -3070,7 +3070,7 @@
           <a:p>
             <a:fld id="{64E1626F-68EC-4B02-AD8D-2E5F851E62A0}" type="datetime1">
               <a:rPr lang="de-DE" smtClean="0"/>
-              <a:t>30.01.2026</a:t>
+              <a:t>31.01.2026</a:t>
             </a:fld>
             <a:endParaRPr lang="en-US"/>
           </a:p>
@@ -3314,7 +3314,7 @@
           <a:p>
             <a:fld id="{B53B0A0C-0502-4005-9A69-FFD78D14F989}" type="datetime1">
               <a:rPr lang="de-DE" smtClean="0"/>
-              <a:t>30.01.2026</a:t>
+              <a:t>31.01.2026</a:t>
             </a:fld>
             <a:endParaRPr lang="en-US"/>
           </a:p>
@@ -4078,7 +4078,7 @@
           <a:p>
             <a:fld id="{979AD6E7-A48C-4424-B592-37C7B13B8FC0}" type="datetime1">
               <a:rPr lang="de-DE" smtClean="0"/>
-              <a:t>30.01.2026</a:t>
+              <a:t>31.01.2026</a:t>
             </a:fld>
             <a:endParaRPr lang="en-US"/>
           </a:p>
@@ -4313,7 +4313,7 @@
           <a:p>
             <a:fld id="{3B7D17E4-C383-4D8C-9298-0702EEB52F70}" type="datetime1">
               <a:rPr lang="de-DE" smtClean="0"/>
-              <a:t>30.01.2026</a:t>
+              <a:t>31.01.2026</a:t>
             </a:fld>
             <a:endParaRPr lang="en-US"/>
           </a:p>
@@ -4559,7 +4559,7 @@
           <a:p>
             <a:fld id="{979AD6E7-A48C-4424-B592-37C7B13B8FC0}" type="datetime1">
               <a:rPr lang="de-DE" smtClean="0"/>
-              <a:t>30.01.2026</a:t>
+              <a:t>31.01.2026</a:t>
             </a:fld>
             <a:endParaRPr lang="en-US"/>
           </a:p>
@@ -4740,7 +4740,7 @@
           <a:p>
             <a:fld id="{979AD6E7-A48C-4424-B592-37C7B13B8FC0}" type="datetime1">
               <a:rPr lang="de-DE" smtClean="0"/>
-              <a:t>30.01.2026</a:t>
+              <a:t>31.01.2026</a:t>
             </a:fld>
             <a:endParaRPr lang="en-US"/>
           </a:p>
@@ -5354,7 +5354,7 @@
           <a:p>
             <a:fld id="{979AD6E7-A48C-4424-B592-37C7B13B8FC0}" type="datetime1">
               <a:rPr lang="de-DE" smtClean="0"/>
-              <a:t>30.01.2026</a:t>
+              <a:t>31.01.2026</a:t>
             </a:fld>
             <a:endParaRPr lang="en-US"/>
           </a:p>
@@ -5593,7 +5593,7 @@
           <a:p>
             <a:fld id="{979AD6E7-A48C-4424-B592-37C7B13B8FC0}" type="datetime1">
               <a:rPr lang="de-DE" smtClean="0"/>
-              <a:t>30.01.2026</a:t>
+              <a:t>31.01.2026</a:t>
             </a:fld>
             <a:endParaRPr lang="en-US"/>
           </a:p>
@@ -5762,7 +5762,7 @@
           <a:p>
             <a:fld id="{979AD6E7-A48C-4424-B592-37C7B13B8FC0}" type="datetime1">
               <a:rPr lang="de-DE" smtClean="0"/>
-              <a:t>30.01.2026</a:t>
+              <a:t>31.01.2026</a:t>
             </a:fld>
             <a:endParaRPr lang="en-US"/>
           </a:p>
@@ -5931,7 +5931,7 @@
           <a:p>
             <a:fld id="{979AD6E7-A48C-4424-B592-37C7B13B8FC0}" type="datetime1">
               <a:rPr lang="de-DE" smtClean="0"/>
-              <a:t>30.01.2026</a:t>
+              <a:t>31.01.2026</a:t>
             </a:fld>
             <a:endParaRPr lang="en-US"/>
           </a:p>
@@ -6715,14 +6715,14 @@
     <we:property name="Microsoft.Office.CampaignId" value="&quot;none&quot;"/>
     <we:property name="artifactViewState" value="&quot;live&quot;"/>
     <we:property name="backgroundColor" value="&quot;#FFFFFF&quot;"/>
-    <we:property name="bookmark" value="&quot;H4sIAAAAAAAAA+VY32/bNhD+Vwo9rYAxSKJ+mH1L3LQPy4JgGfoyBMaJPMksaFGgqMRO4P99R8pZU6+tmwxuk+yNPB3v7ruPJx55G0nVdxrWZ7DE6E10ij3eoBILbF8l0SRqRzGrY8iSLJdQCJaImIs0pa+mc8q0ffTmNnJgG3QfVD+A9rZI+NflJAKtz6Hxsxp0j5OoQ9ubFrS6wVGZPjk74GYS4arTxoI3eeHAoTd7Reo0pxCSXxl5BOHUFV6gcKOU5SnyuGJ5lZScs0TyOia1flQIkX1RxZsO7memdaBacuNlaQIMY1FNqxxQsCkkce3lvWobvQ3409o/151PjsOVq8zK56P6SI69pc2GAAkex6XAmpVxncWFmPJE+tW10m7rsFqfrDpLuaIMjtZmhLwxVgnyFHJisR9TcBvNjB6WYXTymfzCDFbgHxhiPWmdcmuy1FVqLszQOquwn18rt5jXg9bzNE7zyMd3bg3REXRHvXUQL8z1zCKFQcHGm0uSfBM+3AwWf4fuc/x3VJGPj/fI2KJbB8Q/As5lYALSuuA1j3khqoynpUSJe5k4klfQCsrCLg1HTWOxAbednvwEjt4N7bYE0kdQJsDKXbqMlWiPR2LeKntXYelkB8dTA+8ZnkRlXuZc8jyv6jxh2TSd8vrZEexwSUNwVE9zgbpXQ7+DN/nBZJ+Br+HR8Ay0GPQ/STmFthno104eJPif3/2V0fHp0dlvv7wm8fZgea9ROWzJ7au3lKdFLxatci66I5BL5GWdQMZZxmvBK14UL5BA9mIJzDMpi4KxDMsyFQXUU/78frH7CcxeLIEZdXUFi3lesCSrGeNZmj07ArURwec8NK7/y5NyTwpGsiUrRV6kGaO2FPI0F3nGngzZSTzX5hp7N79XjwTbWC2vlcRdxHDVzJeqvaf9leKN/70DJgdqvB+K4T804JquLzM99EQcyjHSmVlWZrYA675z8yYH3ryHpHRzeZjLxuMpHC8dIkHgION0mtDNT/gqmz6lGluoZvFARmC1n5Ev9KgHLLKHgfjJVXboI+KgpB6wzB5L4lhnvM5KRteFPKc7vkymMqkh2vdoAyH+48E5im/n5SZY/SSJlmib0MuawfUdCDyHFgPaboxKYdCj7QzUX8nt2IYmjXouO/r/AHrwrsNLWBScUEiq0rhngX8fi0JYHvDmb5Spky60EwAA&quot;"/>
+    <we:property name="bookmark" value="&quot;H4sIAAAAAAAAA+VY32/cNgz+Vwo/bcBhsC3/Ut+Sa7aHZUGwDH0ZggMtUT4VOtuQ5SSX4P73UfJlTW9tb8lwbZK9STRF8uMnWpTuIqmH3sD6DFYYvY1OccBb1GKJ7ZskmkXtJM4rWWEqK6jzBFSmVFohfe16p7t2iN7eRQ5sg+69HkYw3hYJ/7ycRWDMOTR+psAMOIt6tEPXgtG3OCnTJ2dH3MwivOlNZ8GbvHDg0Ju9InWaUwjJT4w8gnD6Ci9QuEnK8hR5XLO8TkrOWSK5ikltmBRCZJ9V8aaD+3nXOtAtufGyNAGGsairOgcUrIIkVl4+6LYx24A/rv1j3fvkOLxxdXfj81F/IMfe0mZDgASP41KgYmWssrgQFU+kX620cVuH9frkpreUK8rgZG1OyJvOakGeQk4sDlMK7qJ5Z8ZVGJ18Ir/oRivwdwyxnrROuzVZ6mu9EN3YOqtxWFxrt1yo0ZhFGqd55OM7tx3REXQnvXUQL7vruUUKg4KNN5ck+Sp8uB0t/gb9p/jvqSIfHx6QsUW3Doi/BZzLwASkquCKx7wQdcbTUqLEvUwcyStoBWVhl4ajprHYgNtOT74DRz+P7bYE0idQJsDKXbo6K9EeT8S80/a+wtLZDo7nBt4zPIvKvMy55HleqzxhWZVWXL04gh2uaAiO6mkh0Ax6HHbwJt+Y7DPwNTwZnoMRo/k7KafQNiP92smDBP/ze7gyOj49Ovv1hx9JvD1YfjGoHbbk9s07ytNyEMtWOxfdE8gl8lIlkHGWcSV4zYviFRLIXi2BeSZlUTCWYVmmogBV8Zf3i91PYPZqCcxiLgoW87xgSaYY41mavTgCTSeCz0VoXP+XJ+WeFExkS1aKvEgzRm0p5Gku8ow9G7KTeGG6axzc4kE9EuzOGnmtJe4ihqtmsdLtA+0vFG/8zx0wO1Dj/VgM/6EBN3R9mZtxIOJQTpHOu1XdzZdg3b/cvMmBN+8hKd1cHuay8XQKp0uHSBA4yDitErr5CV9l1XOqsaVulo9kBG72M/KZHvWARfY4EN+5yg59RByU1AOW2VNJnOqMq6xkdF3Ic7rjy6SSiYJo36MNhPiPR+covp2Xm2D1oyRaoW1CL9uNbuhB4Dm0GND2U1Qagx5tZ6D+Sm7HNjRp1HPZyf97MKN3HV7CouCEQtK1wT0L/PtYFMLygDd/AfgszyG0EwAA&quot;"/>
     <we:property name="creatorSessionId" value="&quot;3750dfa8-a1bf-4a49-9af8-ead35b5efc5d&quot;"/>
     <we:property name="creatorTenantId" value="&quot;7db25319-c04d-4699-88f4-84306cdd3f56&quot;"/>
     <we:property name="creatorUserId" value="&quot;1003200552DD16A3&quot;"/>
     <we:property name="datasetId" value="&quot;a4825fab-f32a-4358-aacf-34a6b7aed4a1&quot;"/>
     <we:property name="design" value="{&quot;border&quot;:{&quot;isActive&quot;:true,&quot;color&quot;:&quot;#808080&quot;,&quot;width&quot;:1,&quot;transparency&quot;:0,&quot;dash&quot;:&quot;solid&quot;}}"/>
     <we:property name="embedUrl" value="&quot;/reportEmbed?reportId=6cc6ad6e-eac0-4d54-981a-d449ef8bdc94&amp;config=eyJjbHVzdGVyVXJsIjoiaHR0cHM6Ly9XQUJJLUdFUk1BTlktV0VTVC1DRU5UUkFMLVBSSU1BUlktcmVkaXJlY3QuYW5hbHlzaXMud2luZG93cy5uZXQiLCJlbWJlZEZlYXR1cmVzIjp7InVzYWdlTWV0cmljc1ZOZXh0Ijp0cnVlfX0%3D&amp;disableSensitivityBanner=true&amp;storytellingChangeViewModeShortcutKeys=true&quot;"/>
-    <we:property name="initialStateBookmark" value="&quot;H4sIAAAAAAAAA+VYTW/cNhD9K4FOLbAIRFFfzM3eODnUNYw4yKUwhBE50jLgigJF2bs29r93JK0bZ5t2Yxeb2O5NGo1m3pvHEYe6DZTuWgPrM1hi8CY4xQ5vUMsFNq9YMAuayYw8jZApkTIQuVQlCzNOT23rtW264M1t4MHV6D/prgczxCLjH5ezAIw5h3q4q8B0OAtadJ1twOgbnJzpkXc9bmYBrlpjHQwhLzx4HMJekTvdEwT2esgI0usrvEDpJytPIhRhyZOSZUJwgliF5NZNDiOyb7oMocf0c9t40A2lGWwRA46hLPMyAZQ8BxZWg73TTW22gL+8+3HdDsXxuPKlXQ31KD9T4iHSZkOEpAjDTGLFs7CKw1Tmgqnh7Uobv01Yrk9WraNaUQWnaHNiXlunJWUaa+Kwm0pwG8yt6Zfj1clX9gvbO4kfcMR60njt1xSpLXUhbd94p7ErrrVfFFVvTBGFURIM+M6dJTlG38lvPZoX9nrukGAQ2HBzSZZ/pQ83vcPfof2a/51UlOPzPTG27NYj4x9B53JUAqIqFZUIRSrLWESZQoV7lThSV9BIqsKuDEd17bAGv709+QkaveubbQtEj5BMglO7clmn0B1PwrzV7q7DotkOj6dGflB4FmRJlgglkqSsEsbjPMpF9ewE9rikS/DUT4VE0+m+2+HLfrDYZzD08BR4Dkb25q+inEJT9/RppwwKho/f/TeD49Ojs99++ZXM243lvUHtsaG0r95SnRadXDTa++BOQKFQZBWDWPBYVFKUIk1foID8xQqYxEqlKecxZlkkU6hy8fw+sfsFjF+sgHEoZMpDkaScxRXnIo7iZyegsXLMWYyD6/9yp9xTgklsxTOZpFHMaSyFJEpkEvMnIzYLC2OvsfPFvX4k2tYZda0V7jKGq7pY6uae9z80b/j3FTA70OD9UA7/YQA3dHyZm74j4VBNSOd2Wdr5Apz/zsXLDrx4Dynp5vIwh43HSzgdOiRDEKDCKGd08pNDl+VPqccWul48UBFY7VfkGzPqAZvsYSR+cpcdeos4qKgHbLPHijj1majijNNxIUnojK9YrlgFwb6fNjDiP+69J3w7f27GqF8swRJdPc6ytvddCxLPocGRbTuh0jj60XIGmq/U9tqNQxrNXG7K/wlMP/4vcv3AiXIQIl0a/E7/ie/mT0jYcS2zEwAA&quot;"/>
+    <we:property name="initialStateBookmark" value="&quot;H4sIAAAAAAAAA+VY32/cNgz+Vwo/bcChsCz/Ut+Sa9qHZUHQFH0ZAoOWaJ8KnWXIcnKX4P730fZlTW/drslwbZK9STRN8uMnSpRuA6W71sD6DJYYvAlOscMb1HKBzSsWzIJmEmMYqyphKZOVYCJKZBrl9NW2XtumC97cBh5cjf6T7nowgy0S/nE5C8CYc6iHWQWmw1nQoutsA0bf4KRMn7zrcTMLcNUa62AweeHB42D2itRpTiGw15w8gvT6Ci9Q+knKkwhFWPKkZJkQnClRhaTWTQpjZN9UGUyP7ue28aAbcjPIIgYcQ1nmZQIoeQ4srAZ5p5vabAP+8u/HdTskx+PKl3Y15KP8TI4HS5sNAZIiDDOJFc/CKg5TmQumhr8rbfzWYbk+WbWOckUZnKzNCXltnZbkacyJw25KwW0wt6ZfjqOTr+QXtncSP+AY60njtV+TpbbUhbR9453GrrjWflFUvTFFFEZJMMR37izRMepOeutRvLDXc4cUBgUbbi5J8q/w4aZ3+Du0X+O/o4p8fL5HxhbdekT8I+BcjkxAVKWiEqFIZRmLKFOocC8TR+oKGklZ2KXhqK4d1uC305OfwNG7vtmWQPQIyiQ4tUuXdQrd8UTMW+3uKiya7eB4auAHhmdBlmSJUCJJStqmeJxHuaieHcEelzQET/VUSDSd7rsdvOwHk30GQw1PhudgZG/+SsopNHVPWzt5UDBsfvf/DI5Pj85+++VXEm8PlvcGtceG3L56S3ladHLRaO+DOwKFQpFVDGLBY1FJUYo0fYEE8hdLYBIrlaacx5hlkUyhysXz22L3Exi/WALjUMiUhyJJOYsrzkUcxc+OQGPl6LMYG9f/5Um5JwUT2YpnMkmjmFNbCgk19EnMnwzZLCyMvcbOF/fqkWBbZ9S1VriLGK7qYqmbe9r/ULzh31fA7ECN90Mx/IcG3ND1ZW76johDNUU6t8vSzhfg/HcuXnbgxXtISjeXh7lsPJ7C6dIhGYIAFUY5o5ufHKosf0o1ttD14oGMwGo/I9/oUQ9YZA8D8ZOr7NBHxEFJPWCZPZbEqc5EFWecrgtJQnd8xXLFKgj2PdrAGP9x7z3Ft/NyM1r9IgmW6Oqxl7W971qQeA4NjmjbKSqNox4tZ6D+Sm3HbmzSqOdyk/9PYPrxvcj1AybyQRHp0uB36k94N38CJXKryrMTAAA=&quot;"/>
     <we:property name="isFiltersActionButtonVisible" value="true"/>
     <we:property name="isVisualContainerHeaderHidden" value="false"/>
     <we:property name="pageDisplayName" value="&quot;Weltweit&quot;"/>
@@ -6738,21 +6738,21 @@
 </file>
 
 <file path=customXml/item1.xml><?xml version="1.0" encoding="utf-8"?>
+<p:properties xmlns:p="http://schemas.microsoft.com/office/2006/metadata/properties" xmlns:xsi="http://www.w3.org/2001/XMLSchema-instance" xmlns:pc="http://schemas.microsoft.com/office/infopath/2007/PartnerControls">
+  <documentManagement>
+    <Document_x0020_Purpose xmlns="f577acbf-5b0b-4b4f-9948-268e97f8d3a4">Informational</Document_x0020_Purpose>
+    <Initiatives xmlns="f577acbf-5b0b-4b4f-9948-268e97f8d3a4"/>
+  </documentManagement>
+</p:properties>
+</file>
+
+<file path=customXml/item2.xml><?xml version="1.0" encoding="utf-8"?>
 <?mso-contentType ?>
 <FormTemplates xmlns="http://schemas.microsoft.com/sharepoint/v3/contenttype/forms">
   <Display>DocumentLibraryForm</Display>
   <Edit>DocumentLibraryForm</Edit>
   <New>DocumentLibraryForm</New>
 </FormTemplates>
-</file>
-
-<file path=customXml/item2.xml><?xml version="1.0" encoding="utf-8"?>
-<p:properties xmlns:p="http://schemas.microsoft.com/office/2006/metadata/properties" xmlns:xsi="http://www.w3.org/2001/XMLSchema-instance" xmlns:pc="http://schemas.microsoft.com/office/infopath/2007/PartnerControls">
-  <documentManagement>
-    <Document_x0020_Purpose xmlns="f577acbf-5b0b-4b4f-9948-268e97f8d3a4">Informational</Document_x0020_Purpose>
-    <Initiatives xmlns="f577acbf-5b0b-4b4f-9948-268e97f8d3a4"/>
-  </documentManagement>
-</p:properties>
 </file>
 
 <file path=customXml/item3.xml><?xml version="1.0" encoding="utf-8"?>
@@ -7012,14 +7012,6 @@
 </file>
 
 <file path=customXml/itemProps1.xml><?xml version="1.0" encoding="utf-8"?>
-<ds:datastoreItem xmlns:ds="http://schemas.openxmlformats.org/officeDocument/2006/customXml" ds:itemID="{E21AFCC0-734A-4A90-A597-A1CB34860DCD}">
-  <ds:schemaRefs>
-    <ds:schemaRef ds:uri="http://schemas.microsoft.com/sharepoint/v3/contenttype/forms"/>
-  </ds:schemaRefs>
-</ds:datastoreItem>
-</file>
-
-<file path=customXml/itemProps2.xml><?xml version="1.0" encoding="utf-8"?>
 <ds:datastoreItem xmlns:ds="http://schemas.openxmlformats.org/officeDocument/2006/customXml" ds:itemID="{617AB1FA-2F28-4684-9230-02ACEB6C0B0A}">
   <ds:schemaRefs>
     <ds:schemaRef ds:uri="http://purl.org/dc/elements/1.1/"/>
@@ -7032,6 +7024,14 @@
     <ds:schemaRef ds:uri="http://purl.org/dc/dcmitype/"/>
     <ds:schemaRef ds:uri="http://schemas.microsoft.com/office/infopath/2007/PartnerControls"/>
     <ds:schemaRef ds:uri="http://www.w3.org/XML/1998/namespace"/>
+  </ds:schemaRefs>
+</ds:datastoreItem>
+</file>
+
+<file path=customXml/itemProps2.xml><?xml version="1.0" encoding="utf-8"?>
+<ds:datastoreItem xmlns:ds="http://schemas.openxmlformats.org/officeDocument/2006/customXml" ds:itemID="{E21AFCC0-734A-4A90-A597-A1CB34860DCD}">
+  <ds:schemaRefs>
+    <ds:schemaRef ds:uri="http://schemas.microsoft.com/sharepoint/v3/contenttype/forms"/>
   </ds:schemaRefs>
 </ds:datastoreItem>
 </file>

</xml_diff>

<commit_message>
update: remove unneccessary view
</commit_message>
<xml_diff>
--- a/Abschlusspräsentation_MySQL_Frank_Wünsch.pptx
+++ b/Abschlusspräsentation_MySQL_Frank_Wünsch.pptx
@@ -5,7 +5,7 @@
     <p:sldMasterId id="2147483648" r:id="rId4"/>
   </p:sldMasterIdLst>
   <p:notesMasterIdLst>
-    <p:notesMasterId r:id="rId15"/>
+    <p:notesMasterId r:id="rId14"/>
   </p:notesMasterIdLst>
   <p:sldIdLst>
     <p:sldId id="258" r:id="rId5"/>
@@ -15,14 +15,13 @@
     <p:sldId id="262" r:id="rId9"/>
     <p:sldId id="263" r:id="rId10"/>
     <p:sldId id="264" r:id="rId11"/>
-    <p:sldId id="265" r:id="rId12"/>
-    <p:sldId id="256" r:id="rId13"/>
-    <p:sldId id="266" r:id="rId14"/>
+    <p:sldId id="256" r:id="rId12"/>
+    <p:sldId id="266" r:id="rId13"/>
   </p:sldIdLst>
   <p:sldSz cx="12192000" cy="6858000"/>
   <p:notesSz cx="6858000" cy="9144000"/>
   <p:custDataLst>
-    <p:tags r:id="rId16"/>
+    <p:tags r:id="rId15"/>
   </p:custDataLst>
   <p:defaultTextStyle>
     <a:defPPr>
@@ -3871,289 +3870,6 @@
 </p:sld>
 </file>
 
-<file path=ppt/slides/slide10.xml><?xml version="1.0" encoding="utf-8"?>
-<p:sld xmlns:a="http://schemas.openxmlformats.org/drawingml/2006/main" xmlns:r="http://schemas.openxmlformats.org/officeDocument/2006/relationships" xmlns:p="http://schemas.openxmlformats.org/presentationml/2006/main">
-  <p:cSld>
-    <p:spTree>
-      <p:nvGrpSpPr>
-        <p:cNvPr id="1" name=""/>
-        <p:cNvGrpSpPr/>
-        <p:nvPr/>
-      </p:nvGrpSpPr>
-      <p:grpSpPr>
-        <a:xfrm>
-          <a:off x="0" y="0"/>
-          <a:ext cx="0" cy="0"/>
-          <a:chOff x="0" y="0"/>
-          <a:chExt cx="0" cy="0"/>
-        </a:xfrm>
-      </p:grpSpPr>
-      <p:sp>
-        <p:nvSpPr>
-          <p:cNvPr id="2" name="Titel 1">
-            <a:extLst>
-              <a:ext uri="{FF2B5EF4-FFF2-40B4-BE49-F238E27FC236}">
-                <a16:creationId xmlns:a16="http://schemas.microsoft.com/office/drawing/2014/main" id="{EB32ADF1-F79D-E6DE-EC2C-0CCEE33F3F07}"/>
-              </a:ext>
-            </a:extLst>
-          </p:cNvPr>
-          <p:cNvSpPr>
-            <a:spLocks noGrp="1"/>
-          </p:cNvSpPr>
-          <p:nvPr>
-            <p:ph type="title"/>
-          </p:nvPr>
-        </p:nvSpPr>
-        <p:spPr/>
-        <p:txBody>
-          <a:bodyPr/>
-          <a:lstStyle/>
-          <a:p>
-            <a:r>
-              <a:rPr lang="en-US" dirty="0" err="1"/>
-              <a:t>Fazit</a:t>
-            </a:r>
-            <a:endParaRPr lang="de-DE" dirty="0"/>
-          </a:p>
-        </p:txBody>
-      </p:sp>
-      <p:sp>
-        <p:nvSpPr>
-          <p:cNvPr id="3" name="Inhaltsplatzhalter 2">
-            <a:extLst>
-              <a:ext uri="{FF2B5EF4-FFF2-40B4-BE49-F238E27FC236}">
-                <a16:creationId xmlns:a16="http://schemas.microsoft.com/office/drawing/2014/main" id="{7FCECF97-35EB-82CF-9471-0A278FD22AC1}"/>
-              </a:ext>
-            </a:extLst>
-          </p:cNvPr>
-          <p:cNvSpPr>
-            <a:spLocks noGrp="1"/>
-          </p:cNvSpPr>
-          <p:nvPr>
-            <p:ph idx="1"/>
-          </p:nvPr>
-        </p:nvSpPr>
-        <p:spPr/>
-        <p:txBody>
-          <a:bodyPr>
-            <a:normAutofit lnSpcReduction="10000"/>
-          </a:bodyPr>
-          <a:lstStyle/>
-          <a:p>
-            <a:r>
-              <a:rPr lang="de-DE" dirty="0">
-                <a:solidFill>
-                  <a:srgbClr val="00B050"/>
-                </a:solidFill>
-              </a:rPr>
-              <a:t>Datensatz sehr gut geeignet zum Lernen von</a:t>
-            </a:r>
-          </a:p>
-          <a:p>
-            <a:pPr lvl="1"/>
-            <a:r>
-              <a:rPr lang="de-DE" dirty="0">
-                <a:solidFill>
-                  <a:srgbClr val="00B050"/>
-                </a:solidFill>
-              </a:rPr>
-              <a:t>Umgang mit MySQL</a:t>
-            </a:r>
-          </a:p>
-          <a:p>
-            <a:pPr lvl="1"/>
-            <a:r>
-              <a:rPr lang="de-DE" dirty="0">
-                <a:solidFill>
-                  <a:srgbClr val="00B050"/>
-                </a:solidFill>
-              </a:rPr>
-              <a:t>Datenanalyse mit KNIME</a:t>
-            </a:r>
-          </a:p>
-          <a:p>
-            <a:pPr lvl="1"/>
-            <a:r>
-              <a:rPr lang="de-DE" dirty="0">
-                <a:solidFill>
-                  <a:srgbClr val="00B050"/>
-                </a:solidFill>
-              </a:rPr>
-              <a:t>Erstellen von Vorhersagemodellen</a:t>
-            </a:r>
-          </a:p>
-          <a:p>
-            <a:pPr lvl="1"/>
-            <a:r>
-              <a:rPr lang="de-DE" dirty="0">
-                <a:solidFill>
-                  <a:srgbClr val="00B050"/>
-                </a:solidFill>
-              </a:rPr>
-              <a:t>Visualisierung / Analyse mit Power BI</a:t>
-            </a:r>
-          </a:p>
-          <a:p>
-            <a:pPr marL="457200" lvl="1" indent="0">
-              <a:buNone/>
-            </a:pPr>
-            <a:endParaRPr lang="de-DE" dirty="0"/>
-          </a:p>
-          <a:p>
-            <a:r>
-              <a:rPr lang="de-DE" dirty="0">
-                <a:solidFill>
-                  <a:srgbClr val="FF0000"/>
-                </a:solidFill>
-              </a:rPr>
-              <a:t>Datensatz schlecht oder nicht geeignet für</a:t>
-            </a:r>
-          </a:p>
-          <a:p>
-            <a:pPr lvl="1"/>
-            <a:r>
-              <a:rPr lang="de-DE" dirty="0">
-                <a:solidFill>
-                  <a:srgbClr val="FF0000"/>
-                </a:solidFill>
-              </a:rPr>
-              <a:t>Tiefgreifende Analysen zu</a:t>
-            </a:r>
-          </a:p>
-          <a:p>
-            <a:pPr lvl="2"/>
-            <a:r>
-              <a:rPr lang="de-DE" dirty="0">
-                <a:solidFill>
-                  <a:srgbClr val="FF0000"/>
-                </a:solidFill>
-              </a:rPr>
-              <a:t>Feuchtigkeit und Niederschlag</a:t>
-            </a:r>
-          </a:p>
-          <a:p>
-            <a:pPr lvl="2"/>
-            <a:r>
-              <a:rPr lang="de-DE" dirty="0">
-                <a:solidFill>
-                  <a:srgbClr val="FF0000"/>
-                </a:solidFill>
-              </a:rPr>
-              <a:t>Umweltverschmutzung durch Feuerwerke / Waldbrände etc.</a:t>
-            </a:r>
-          </a:p>
-          <a:p>
-            <a:pPr lvl="2"/>
-            <a:r>
-              <a:rPr lang="de-DE" dirty="0">
-                <a:solidFill>
-                  <a:srgbClr val="FF0000"/>
-                </a:solidFill>
-              </a:rPr>
-              <a:t>Langzeitanalysen zum Wetter</a:t>
-            </a:r>
-          </a:p>
-        </p:txBody>
-      </p:sp>
-      <p:sp>
-        <p:nvSpPr>
-          <p:cNvPr id="4" name="Datumsplatzhalter 3">
-            <a:extLst>
-              <a:ext uri="{FF2B5EF4-FFF2-40B4-BE49-F238E27FC236}">
-                <a16:creationId xmlns:a16="http://schemas.microsoft.com/office/drawing/2014/main" id="{774540AC-39CA-E7E8-135D-914C5B7093F6}"/>
-              </a:ext>
-            </a:extLst>
-          </p:cNvPr>
-          <p:cNvSpPr>
-            <a:spLocks noGrp="1"/>
-          </p:cNvSpPr>
-          <p:nvPr>
-            <p:ph type="dt" sz="half" idx="10"/>
-          </p:nvPr>
-        </p:nvSpPr>
-        <p:spPr/>
-        <p:txBody>
-          <a:bodyPr/>
-          <a:lstStyle/>
-          <a:p>
-            <a:fld id="{979AD6E7-A48C-4424-B592-37C7B13B8FC0}" type="datetime1">
-              <a:rPr lang="de-DE" smtClean="0"/>
-              <a:t>31.01.2026</a:t>
-            </a:fld>
-            <a:endParaRPr lang="en-US"/>
-          </a:p>
-        </p:txBody>
-      </p:sp>
-      <p:sp>
-        <p:nvSpPr>
-          <p:cNvPr id="5" name="Fußzeilenplatzhalter 4">
-            <a:extLst>
-              <a:ext uri="{FF2B5EF4-FFF2-40B4-BE49-F238E27FC236}">
-                <a16:creationId xmlns:a16="http://schemas.microsoft.com/office/drawing/2014/main" id="{3489CA39-8321-F0C4-5E59-FB8B7C89A47F}"/>
-              </a:ext>
-            </a:extLst>
-          </p:cNvPr>
-          <p:cNvSpPr>
-            <a:spLocks noGrp="1"/>
-          </p:cNvSpPr>
-          <p:nvPr>
-            <p:ph type="ftr" sz="quarter" idx="11"/>
-          </p:nvPr>
-        </p:nvSpPr>
-        <p:spPr/>
-        <p:txBody>
-          <a:bodyPr/>
-          <a:lstStyle/>
-          <a:p>
-            <a:r>
-              <a:rPr lang="en-US"/>
-              <a:t>Abschlussarbeit MySQL - Frank Wünsch</a:t>
-            </a:r>
-          </a:p>
-        </p:txBody>
-      </p:sp>
-      <p:sp>
-        <p:nvSpPr>
-          <p:cNvPr id="6" name="Foliennummernplatzhalter 5">
-            <a:extLst>
-              <a:ext uri="{FF2B5EF4-FFF2-40B4-BE49-F238E27FC236}">
-                <a16:creationId xmlns:a16="http://schemas.microsoft.com/office/drawing/2014/main" id="{8D5B02D2-3DCE-B83F-B227-8BE1EA75C050}"/>
-              </a:ext>
-            </a:extLst>
-          </p:cNvPr>
-          <p:cNvSpPr>
-            <a:spLocks noGrp="1"/>
-          </p:cNvSpPr>
-          <p:nvPr>
-            <p:ph type="sldNum" sz="quarter" idx="12"/>
-          </p:nvPr>
-        </p:nvSpPr>
-        <p:spPr/>
-        <p:txBody>
-          <a:bodyPr/>
-          <a:lstStyle/>
-          <a:p>
-            <a:fld id="{8E05DC9C-C50D-D242-B083-59CEE07163F1}" type="slidenum">
-              <a:rPr lang="en-US" smtClean="0"/>
-              <a:t>10</a:t>
-            </a:fld>
-            <a:endParaRPr lang="en-US"/>
-          </a:p>
-        </p:txBody>
-      </p:sp>
-    </p:spTree>
-    <p:extLst>
-      <p:ext uri="{BB962C8B-B14F-4D97-AF65-F5344CB8AC3E}">
-        <p14:creationId xmlns:p14="http://schemas.microsoft.com/office/powerpoint/2010/main" val="194241005"/>
-      </p:ext>
-    </p:extLst>
-  </p:cSld>
-  <p:clrMapOvr>
-    <a:masterClrMapping/>
-  </p:clrMapOvr>
-</p:sld>
-</file>
-
 <file path=ppt/slides/slide2.xml><?xml version="1.0" encoding="utf-8"?>
 <p:sld xmlns:a="http://schemas.openxmlformats.org/drawingml/2006/main" xmlns:r="http://schemas.openxmlformats.org/officeDocument/2006/relationships" xmlns:p="http://schemas.openxmlformats.org/presentationml/2006/main">
   <p:cSld>
@@ -4253,15 +3969,6 @@
             <a:r>
               <a:rPr lang="de-DE" dirty="0"/>
               <a:t>Korrelationen</a:t>
-            </a:r>
-          </a:p>
-          <a:p>
-            <a:pPr marL="514350" indent="-514350">
-              <a:buAutoNum type="arabicPeriod"/>
-            </a:pPr>
-            <a:r>
-              <a:rPr lang="de-DE" dirty="0"/>
-              <a:t>Komplexe Abfrage</a:t>
             </a:r>
           </a:p>
           <a:p>
@@ -4682,48 +4389,6 @@
       </p:sp>
       <p:sp>
         <p:nvSpPr>
-          <p:cNvPr id="3" name="Inhaltsplatzhalter 2">
-            <a:extLst>
-              <a:ext uri="{FF2B5EF4-FFF2-40B4-BE49-F238E27FC236}">
-                <a16:creationId xmlns:a16="http://schemas.microsoft.com/office/drawing/2014/main" id="{77858C8C-DE7F-CB92-1398-408E1BF70E2D}"/>
-              </a:ext>
-            </a:extLst>
-          </p:cNvPr>
-          <p:cNvSpPr>
-            <a:spLocks noGrp="1"/>
-          </p:cNvSpPr>
-          <p:nvPr>
-            <p:ph idx="1"/>
-          </p:nvPr>
-        </p:nvSpPr>
-        <p:spPr>
-          <a:xfrm>
-            <a:off x="838200" y="1781466"/>
-            <a:ext cx="10515600" cy="4351338"/>
-          </a:xfrm>
-        </p:spPr>
-        <p:txBody>
-          <a:bodyPr/>
-          <a:lstStyle/>
-          <a:p>
-            <a:pPr marL="0" indent="0">
-              <a:buNone/>
-            </a:pPr>
-            <a:r>
-              <a:rPr lang="de-DE" dirty="0"/>
-              <a:t>Wichtigste Spalten (Gesamt: 41 Spalten)</a:t>
-            </a:r>
-          </a:p>
-          <a:p>
-            <a:pPr marL="0" indent="0">
-              <a:buNone/>
-            </a:pPr>
-            <a:endParaRPr lang="de-DE" dirty="0"/>
-          </a:p>
-        </p:txBody>
-      </p:sp>
-      <p:sp>
-        <p:nvSpPr>
           <p:cNvPr id="4" name="Datumsplatzhalter 3">
             <a:extLst>
               <a:ext uri="{FF2B5EF4-FFF2-40B4-BE49-F238E27FC236}">
@@ -4808,1215 +4473,36 @@
           </a:p>
         </p:txBody>
       </p:sp>
-      <p:graphicFrame>
-        <p:nvGraphicFramePr>
-          <p:cNvPr id="7" name="Tabelle 6">
-            <a:extLst>
-              <a:ext uri="{FF2B5EF4-FFF2-40B4-BE49-F238E27FC236}">
-                <a16:creationId xmlns:a16="http://schemas.microsoft.com/office/drawing/2014/main" id="{A2C4F397-36FB-6315-F021-3001327A836B}"/>
-              </a:ext>
-            </a:extLst>
-          </p:cNvPr>
-          <p:cNvGraphicFramePr>
-            <a:graphicFrameLocks noGrp="1"/>
-          </p:cNvGraphicFramePr>
-          <p:nvPr>
-            <p:extLst>
-              <p:ext uri="{D42A27DB-BD31-4B8C-83A1-F6EECF244321}">
-                <p14:modId xmlns:p14="http://schemas.microsoft.com/office/powerpoint/2010/main" val="2225748227"/>
-              </p:ext>
-            </p:extLst>
-          </p:nvPr>
-        </p:nvGraphicFramePr>
-        <p:xfrm>
-          <a:off x="838200" y="2388211"/>
-          <a:ext cx="10515600" cy="3744593"/>
-        </p:xfrm>
-        <a:graphic>
-          <a:graphicData uri="http://schemas.openxmlformats.org/drawingml/2006/table">
-            <a:tbl>
-              <a:tblPr firstRow="1" bandRow="1">
-                <a:tableStyleId>{8799B23B-EC83-4686-B30A-512413B5E67A}</a:tableStyleId>
-              </a:tblPr>
-              <a:tblGrid>
-                <a:gridCol w="2677998">
-                  <a:extLst>
-                    <a:ext uri="{9D8B030D-6E8A-4147-A177-3AD203B41FA5}">
-                      <a16:colId xmlns:a16="http://schemas.microsoft.com/office/drawing/2014/main" val="1349699990"/>
-                    </a:ext>
-                  </a:extLst>
-                </a:gridCol>
-                <a:gridCol w="7837602">
-                  <a:extLst>
-                    <a:ext uri="{9D8B030D-6E8A-4147-A177-3AD203B41FA5}">
-                      <a16:colId xmlns:a16="http://schemas.microsoft.com/office/drawing/2014/main" val="3822429309"/>
-                    </a:ext>
-                  </a:extLst>
-                </a:gridCol>
-              </a:tblGrid>
-              <a:tr h="294018">
-                <a:tc>
-                  <a:txBody>
-                    <a:bodyPr/>
-                    <a:lstStyle/>
-                    <a:p>
-                      <a:r>
-                        <a:rPr lang="de-DE" b="1" dirty="0"/>
-                        <a:t>Spaltenname(n)</a:t>
-                      </a:r>
-                    </a:p>
-                  </a:txBody>
-                  <a:tcPr>
-                    <a:lnL w="12700" cap="flat" cmpd="sng" algn="ctr">
-                      <a:solidFill>
-                        <a:schemeClr val="tx1"/>
-                      </a:solidFill>
-                      <a:prstDash val="solid"/>
-                      <a:round/>
-                      <a:headEnd type="none" w="med" len="med"/>
-                      <a:tailEnd type="none" w="med" len="med"/>
-                    </a:lnL>
-                    <a:lnR w="12700" cap="flat" cmpd="sng" algn="ctr">
-                      <a:solidFill>
-                        <a:schemeClr val="tx1"/>
-                      </a:solidFill>
-                      <a:prstDash val="solid"/>
-                      <a:round/>
-                      <a:headEnd type="none" w="med" len="med"/>
-                      <a:tailEnd type="none" w="med" len="med"/>
-                    </a:lnR>
-                    <a:lnT w="12700" cap="flat" cmpd="sng" algn="ctr">
-                      <a:solidFill>
-                        <a:schemeClr val="tx1"/>
-                      </a:solidFill>
-                      <a:prstDash val="solid"/>
-                      <a:round/>
-                      <a:headEnd type="none" w="med" len="med"/>
-                      <a:tailEnd type="none" w="med" len="med"/>
-                    </a:lnT>
-                    <a:lnB w="12700" cap="flat" cmpd="sng" algn="ctr">
-                      <a:solidFill>
-                        <a:schemeClr val="tx1"/>
-                      </a:solidFill>
-                      <a:prstDash val="solid"/>
-                      <a:round/>
-                      <a:headEnd type="none" w="med" len="med"/>
-                      <a:tailEnd type="none" w="med" len="med"/>
-                    </a:lnB>
-                  </a:tcPr>
-                </a:tc>
-                <a:tc>
-                  <a:txBody>
-                    <a:bodyPr/>
-                    <a:lstStyle/>
-                    <a:p>
-                      <a:r>
-                        <a:rPr lang="de-DE" dirty="0"/>
-                        <a:t>Information</a:t>
-                      </a:r>
-                    </a:p>
-                  </a:txBody>
-                  <a:tcPr>
-                    <a:lnL w="12700" cap="flat" cmpd="sng" algn="ctr">
-                      <a:solidFill>
-                        <a:schemeClr val="tx1"/>
-                      </a:solidFill>
-                      <a:prstDash val="solid"/>
-                      <a:round/>
-                      <a:headEnd type="none" w="med" len="med"/>
-                      <a:tailEnd type="none" w="med" len="med"/>
-                    </a:lnL>
-                    <a:lnR w="12700" cap="flat" cmpd="sng" algn="ctr">
-                      <a:solidFill>
-                        <a:schemeClr val="tx1"/>
-                      </a:solidFill>
-                      <a:prstDash val="solid"/>
-                      <a:round/>
-                      <a:headEnd type="none" w="med" len="med"/>
-                      <a:tailEnd type="none" w="med" len="med"/>
-                    </a:lnR>
-                    <a:lnT w="12700" cap="flat" cmpd="sng" algn="ctr">
-                      <a:solidFill>
-                        <a:schemeClr val="tx1"/>
-                      </a:solidFill>
-                      <a:prstDash val="solid"/>
-                      <a:round/>
-                      <a:headEnd type="none" w="med" len="med"/>
-                      <a:tailEnd type="none" w="med" len="med"/>
-                    </a:lnT>
-                    <a:lnB w="12700" cap="flat" cmpd="sng" algn="ctr">
-                      <a:solidFill>
-                        <a:schemeClr val="tx1"/>
-                      </a:solidFill>
-                      <a:prstDash val="solid"/>
-                      <a:round/>
-                      <a:headEnd type="none" w="med" len="med"/>
-                      <a:tailEnd type="none" w="med" len="med"/>
-                    </a:lnB>
-                  </a:tcPr>
-                </a:tc>
-                <a:extLst>
-                  <a:ext uri="{0D108BD9-81ED-4DB2-BD59-A6C34878D82A}">
-                    <a16:rowId xmlns:a16="http://schemas.microsoft.com/office/drawing/2014/main" val="1160005188"/>
-                  </a:ext>
-                </a:extLst>
-              </a:tr>
-              <a:tr h="294018">
-                <a:tc>
-                  <a:txBody>
-                    <a:bodyPr/>
-                    <a:lstStyle/>
-                    <a:p>
-                      <a:r>
-                        <a:rPr lang="de-DE" b="0" dirty="0"/>
-                        <a:t>Country</a:t>
-                      </a:r>
-                    </a:p>
-                  </a:txBody>
-                  <a:tcPr>
-                    <a:lnL w="12700" cap="flat" cmpd="sng" algn="ctr">
-                      <a:solidFill>
-                        <a:schemeClr val="tx1"/>
-                      </a:solidFill>
-                      <a:prstDash val="solid"/>
-                      <a:round/>
-                      <a:headEnd type="none" w="med" len="med"/>
-                      <a:tailEnd type="none" w="med" len="med"/>
-                    </a:lnL>
-                    <a:lnR w="12700" cap="flat" cmpd="sng" algn="ctr">
-                      <a:solidFill>
-                        <a:schemeClr val="tx1"/>
-                      </a:solidFill>
-                      <a:prstDash val="solid"/>
-                      <a:round/>
-                      <a:headEnd type="none" w="med" len="med"/>
-                      <a:tailEnd type="none" w="med" len="med"/>
-                    </a:lnR>
-                    <a:lnT w="12700" cap="flat" cmpd="sng" algn="ctr">
-                      <a:solidFill>
-                        <a:schemeClr val="tx1"/>
-                      </a:solidFill>
-                      <a:prstDash val="solid"/>
-                      <a:round/>
-                      <a:headEnd type="none" w="med" len="med"/>
-                      <a:tailEnd type="none" w="med" len="med"/>
-                    </a:lnT>
-                    <a:lnB w="12700" cap="flat" cmpd="sng" algn="ctr">
-                      <a:solidFill>
-                        <a:schemeClr val="tx1"/>
-                      </a:solidFill>
-                      <a:prstDash val="solid"/>
-                      <a:round/>
-                      <a:headEnd type="none" w="med" len="med"/>
-                      <a:tailEnd type="none" w="med" len="med"/>
-                    </a:lnB>
-                    <a:solidFill>
-                      <a:srgbClr val="F4F8FC">
-                        <a:alpha val="20000"/>
-                      </a:srgbClr>
-                    </a:solidFill>
-                  </a:tcPr>
-                </a:tc>
-                <a:tc>
-                  <a:txBody>
-                    <a:bodyPr/>
-                    <a:lstStyle/>
-                    <a:p>
-                      <a:r>
-                        <a:rPr lang="de-DE" dirty="0"/>
-                        <a:t>Land, auf das sich die Messdaten beziehen</a:t>
-                      </a:r>
-                    </a:p>
-                  </a:txBody>
-                  <a:tcPr>
-                    <a:lnL w="12700" cap="flat" cmpd="sng" algn="ctr">
-                      <a:solidFill>
-                        <a:schemeClr val="tx1"/>
-                      </a:solidFill>
-                      <a:prstDash val="solid"/>
-                      <a:round/>
-                      <a:headEnd type="none" w="med" len="med"/>
-                      <a:tailEnd type="none" w="med" len="med"/>
-                    </a:lnL>
-                    <a:lnR w="12700" cap="flat" cmpd="sng" algn="ctr">
-                      <a:solidFill>
-                        <a:schemeClr val="tx1"/>
-                      </a:solidFill>
-                      <a:prstDash val="solid"/>
-                      <a:round/>
-                      <a:headEnd type="none" w="med" len="med"/>
-                      <a:tailEnd type="none" w="med" len="med"/>
-                    </a:lnR>
-                    <a:lnT w="12700" cap="flat" cmpd="sng" algn="ctr">
-                      <a:solidFill>
-                        <a:schemeClr val="tx1"/>
-                      </a:solidFill>
-                      <a:prstDash val="solid"/>
-                      <a:round/>
-                      <a:headEnd type="none" w="med" len="med"/>
-                      <a:tailEnd type="none" w="med" len="med"/>
-                    </a:lnT>
-                    <a:lnB w="12700" cap="flat" cmpd="sng" algn="ctr">
-                      <a:solidFill>
-                        <a:schemeClr val="tx1"/>
-                      </a:solidFill>
-                      <a:prstDash val="solid"/>
-                      <a:round/>
-                      <a:headEnd type="none" w="med" len="med"/>
-                      <a:tailEnd type="none" w="med" len="med"/>
-                    </a:lnB>
-                    <a:solidFill>
-                      <a:srgbClr val="F4F8FC">
-                        <a:alpha val="20000"/>
-                      </a:srgbClr>
-                    </a:solidFill>
-                  </a:tcPr>
-                </a:tc>
-                <a:extLst>
-                  <a:ext uri="{0D108BD9-81ED-4DB2-BD59-A6C34878D82A}">
-                    <a16:rowId xmlns:a16="http://schemas.microsoft.com/office/drawing/2014/main" val="1218495045"/>
-                  </a:ext>
-                </a:extLst>
-              </a:tr>
-              <a:tr h="294018">
-                <a:tc>
-                  <a:txBody>
-                    <a:bodyPr/>
-                    <a:lstStyle/>
-                    <a:p>
-                      <a:r>
-                        <a:rPr lang="de-DE" b="0" dirty="0" err="1"/>
-                        <a:t>Location_name</a:t>
-                      </a:r>
-                      <a:endParaRPr lang="de-DE" b="0" dirty="0"/>
-                    </a:p>
-                  </a:txBody>
-                  <a:tcPr>
-                    <a:lnL w="12700" cap="flat" cmpd="sng" algn="ctr">
-                      <a:solidFill>
-                        <a:schemeClr val="tx1"/>
-                      </a:solidFill>
-                      <a:prstDash val="solid"/>
-                      <a:round/>
-                      <a:headEnd type="none" w="med" len="med"/>
-                      <a:tailEnd type="none" w="med" len="med"/>
-                    </a:lnL>
-                    <a:lnR w="12700" cap="flat" cmpd="sng" algn="ctr">
-                      <a:solidFill>
-                        <a:schemeClr val="tx1"/>
-                      </a:solidFill>
-                      <a:prstDash val="solid"/>
-                      <a:round/>
-                      <a:headEnd type="none" w="med" len="med"/>
-                      <a:tailEnd type="none" w="med" len="med"/>
-                    </a:lnR>
-                    <a:lnT w="12700" cap="flat" cmpd="sng" algn="ctr">
-                      <a:solidFill>
-                        <a:schemeClr val="tx1"/>
-                      </a:solidFill>
-                      <a:prstDash val="solid"/>
-                      <a:round/>
-                      <a:headEnd type="none" w="med" len="med"/>
-                      <a:tailEnd type="none" w="med" len="med"/>
-                    </a:lnT>
-                    <a:lnB w="12700" cap="flat" cmpd="sng" algn="ctr">
-                      <a:solidFill>
-                        <a:schemeClr val="tx1"/>
-                      </a:solidFill>
-                      <a:prstDash val="solid"/>
-                      <a:round/>
-                      <a:headEnd type="none" w="med" len="med"/>
-                      <a:tailEnd type="none" w="med" len="med"/>
-                    </a:lnB>
-                    <a:solidFill>
-                      <a:srgbClr val="F4F8FC"/>
-                    </a:solidFill>
-                  </a:tcPr>
-                </a:tc>
-                <a:tc>
-                  <a:txBody>
-                    <a:bodyPr/>
-                    <a:lstStyle/>
-                    <a:p>
-                      <a:r>
-                        <a:rPr lang="de-DE" dirty="0"/>
-                        <a:t>Ort</a:t>
-                      </a:r>
-                    </a:p>
-                  </a:txBody>
-                  <a:tcPr>
-                    <a:lnL w="12700" cap="flat" cmpd="sng" algn="ctr">
-                      <a:solidFill>
-                        <a:schemeClr val="tx1"/>
-                      </a:solidFill>
-                      <a:prstDash val="solid"/>
-                      <a:round/>
-                      <a:headEnd type="none" w="med" len="med"/>
-                      <a:tailEnd type="none" w="med" len="med"/>
-                    </a:lnL>
-                    <a:lnR w="12700" cap="flat" cmpd="sng" algn="ctr">
-                      <a:solidFill>
-                        <a:schemeClr val="tx1"/>
-                      </a:solidFill>
-                      <a:prstDash val="solid"/>
-                      <a:round/>
-                      <a:headEnd type="none" w="med" len="med"/>
-                      <a:tailEnd type="none" w="med" len="med"/>
-                    </a:lnR>
-                    <a:lnT w="12700" cap="flat" cmpd="sng" algn="ctr">
-                      <a:solidFill>
-                        <a:schemeClr val="tx1"/>
-                      </a:solidFill>
-                      <a:prstDash val="solid"/>
-                      <a:round/>
-                      <a:headEnd type="none" w="med" len="med"/>
-                      <a:tailEnd type="none" w="med" len="med"/>
-                    </a:lnT>
-                    <a:lnB w="12700" cap="flat" cmpd="sng" algn="ctr">
-                      <a:solidFill>
-                        <a:schemeClr val="tx1"/>
-                      </a:solidFill>
-                      <a:prstDash val="solid"/>
-                      <a:round/>
-                      <a:headEnd type="none" w="med" len="med"/>
-                      <a:tailEnd type="none" w="med" len="med"/>
-                    </a:lnB>
-                    <a:solidFill>
-                      <a:srgbClr val="F4F8FC"/>
-                    </a:solidFill>
-                  </a:tcPr>
-                </a:tc>
-                <a:extLst>
-                  <a:ext uri="{0D108BD9-81ED-4DB2-BD59-A6C34878D82A}">
-                    <a16:rowId xmlns:a16="http://schemas.microsoft.com/office/drawing/2014/main" val="1863774808"/>
-                  </a:ext>
-                </a:extLst>
-              </a:tr>
-              <a:tr h="294018">
-                <a:tc>
-                  <a:txBody>
-                    <a:bodyPr/>
-                    <a:lstStyle/>
-                    <a:p>
-                      <a:r>
-                        <a:rPr lang="de-DE" b="0" dirty="0"/>
-                        <a:t>Latitude, </a:t>
-                      </a:r>
-                      <a:r>
-                        <a:rPr lang="de-DE" b="0" dirty="0" err="1"/>
-                        <a:t>Longitude</a:t>
-                      </a:r>
-                      <a:endParaRPr lang="de-DE" b="0" dirty="0"/>
-                    </a:p>
-                  </a:txBody>
-                  <a:tcPr>
-                    <a:lnL w="12700" cap="flat" cmpd="sng" algn="ctr">
-                      <a:solidFill>
-                        <a:schemeClr val="tx1"/>
-                      </a:solidFill>
-                      <a:prstDash val="solid"/>
-                      <a:round/>
-                      <a:headEnd type="none" w="med" len="med"/>
-                      <a:tailEnd type="none" w="med" len="med"/>
-                    </a:lnL>
-                    <a:lnR w="12700" cap="flat" cmpd="sng" algn="ctr">
-                      <a:solidFill>
-                        <a:schemeClr val="tx1"/>
-                      </a:solidFill>
-                      <a:prstDash val="solid"/>
-                      <a:round/>
-                      <a:headEnd type="none" w="med" len="med"/>
-                      <a:tailEnd type="none" w="med" len="med"/>
-                    </a:lnR>
-                    <a:lnT w="12700" cap="flat" cmpd="sng" algn="ctr">
-                      <a:solidFill>
-                        <a:schemeClr val="tx1"/>
-                      </a:solidFill>
-                      <a:prstDash val="solid"/>
-                      <a:round/>
-                      <a:headEnd type="none" w="med" len="med"/>
-                      <a:tailEnd type="none" w="med" len="med"/>
-                    </a:lnT>
-                    <a:lnB w="12700" cap="flat" cmpd="sng" algn="ctr">
-                      <a:solidFill>
-                        <a:schemeClr val="tx1"/>
-                      </a:solidFill>
-                      <a:prstDash val="solid"/>
-                      <a:round/>
-                      <a:headEnd type="none" w="med" len="med"/>
-                      <a:tailEnd type="none" w="med" len="med"/>
-                    </a:lnB>
-                    <a:solidFill>
-                      <a:srgbClr val="F4F8FC">
-                        <a:alpha val="20000"/>
-                      </a:srgbClr>
-                    </a:solidFill>
-                  </a:tcPr>
-                </a:tc>
-                <a:tc>
-                  <a:txBody>
-                    <a:bodyPr/>
-                    <a:lstStyle/>
-                    <a:p>
-                      <a:r>
-                        <a:rPr lang="de-DE" dirty="0"/>
-                        <a:t>Längen- und Breitengrad</a:t>
-                      </a:r>
-                    </a:p>
-                  </a:txBody>
-                  <a:tcPr>
-                    <a:lnL w="12700" cap="flat" cmpd="sng" algn="ctr">
-                      <a:solidFill>
-                        <a:schemeClr val="tx1"/>
-                      </a:solidFill>
-                      <a:prstDash val="solid"/>
-                      <a:round/>
-                      <a:headEnd type="none" w="med" len="med"/>
-                      <a:tailEnd type="none" w="med" len="med"/>
-                    </a:lnL>
-                    <a:lnR w="12700" cap="flat" cmpd="sng" algn="ctr">
-                      <a:solidFill>
-                        <a:schemeClr val="tx1"/>
-                      </a:solidFill>
-                      <a:prstDash val="solid"/>
-                      <a:round/>
-                      <a:headEnd type="none" w="med" len="med"/>
-                      <a:tailEnd type="none" w="med" len="med"/>
-                    </a:lnR>
-                    <a:lnT w="12700" cap="flat" cmpd="sng" algn="ctr">
-                      <a:solidFill>
-                        <a:schemeClr val="tx1"/>
-                      </a:solidFill>
-                      <a:prstDash val="solid"/>
-                      <a:round/>
-                      <a:headEnd type="none" w="med" len="med"/>
-                      <a:tailEnd type="none" w="med" len="med"/>
-                    </a:lnT>
-                    <a:lnB w="12700" cap="flat" cmpd="sng" algn="ctr">
-                      <a:solidFill>
-                        <a:schemeClr val="tx1"/>
-                      </a:solidFill>
-                      <a:prstDash val="solid"/>
-                      <a:round/>
-                      <a:headEnd type="none" w="med" len="med"/>
-                      <a:tailEnd type="none" w="med" len="med"/>
-                    </a:lnB>
-                    <a:solidFill>
-                      <a:srgbClr val="F4F8FC">
-                        <a:alpha val="20000"/>
-                      </a:srgbClr>
-                    </a:solidFill>
-                  </a:tcPr>
-                </a:tc>
-                <a:extLst>
-                  <a:ext uri="{0D108BD9-81ED-4DB2-BD59-A6C34878D82A}">
-                    <a16:rowId xmlns:a16="http://schemas.microsoft.com/office/drawing/2014/main" val="4247693577"/>
-                  </a:ext>
-                </a:extLst>
-              </a:tr>
-              <a:tr h="294018">
-                <a:tc>
-                  <a:txBody>
-                    <a:bodyPr/>
-                    <a:lstStyle/>
-                    <a:p>
-                      <a:r>
-                        <a:rPr lang="de-DE" b="0" dirty="0" err="1"/>
-                        <a:t>Wind_kph</a:t>
-                      </a:r>
-                      <a:endParaRPr lang="de-DE" b="0" dirty="0"/>
-                    </a:p>
-                  </a:txBody>
-                  <a:tcPr>
-                    <a:lnL w="12700" cap="flat" cmpd="sng" algn="ctr">
-                      <a:solidFill>
-                        <a:schemeClr val="tx1"/>
-                      </a:solidFill>
-                      <a:prstDash val="solid"/>
-                      <a:round/>
-                      <a:headEnd type="none" w="med" len="med"/>
-                      <a:tailEnd type="none" w="med" len="med"/>
-                    </a:lnL>
-                    <a:lnR w="12700" cap="flat" cmpd="sng" algn="ctr">
-                      <a:solidFill>
-                        <a:schemeClr val="tx1"/>
-                      </a:solidFill>
-                      <a:prstDash val="solid"/>
-                      <a:round/>
-                      <a:headEnd type="none" w="med" len="med"/>
-                      <a:tailEnd type="none" w="med" len="med"/>
-                    </a:lnR>
-                    <a:lnT w="12700" cap="flat" cmpd="sng" algn="ctr">
-                      <a:solidFill>
-                        <a:schemeClr val="tx1"/>
-                      </a:solidFill>
-                      <a:prstDash val="solid"/>
-                      <a:round/>
-                      <a:headEnd type="none" w="med" len="med"/>
-                      <a:tailEnd type="none" w="med" len="med"/>
-                    </a:lnT>
-                    <a:lnB w="12700" cap="flat" cmpd="sng" algn="ctr">
-                      <a:solidFill>
-                        <a:schemeClr val="tx1"/>
-                      </a:solidFill>
-                      <a:prstDash val="solid"/>
-                      <a:round/>
-                      <a:headEnd type="none" w="med" len="med"/>
-                      <a:tailEnd type="none" w="med" len="med"/>
-                    </a:lnB>
-                    <a:solidFill>
-                      <a:srgbClr val="F4F8FC"/>
-                    </a:solidFill>
-                  </a:tcPr>
-                </a:tc>
-                <a:tc>
-                  <a:txBody>
-                    <a:bodyPr/>
-                    <a:lstStyle/>
-                    <a:p>
-                      <a:r>
-                        <a:rPr lang="de-DE" dirty="0"/>
-                        <a:t>Windgeschwindigkeit in km/h</a:t>
-                      </a:r>
-                    </a:p>
-                  </a:txBody>
-                  <a:tcPr>
-                    <a:lnL w="12700" cap="flat" cmpd="sng" algn="ctr">
-                      <a:solidFill>
-                        <a:schemeClr val="tx1"/>
-                      </a:solidFill>
-                      <a:prstDash val="solid"/>
-                      <a:round/>
-                      <a:headEnd type="none" w="med" len="med"/>
-                      <a:tailEnd type="none" w="med" len="med"/>
-                    </a:lnL>
-                    <a:lnR w="12700" cap="flat" cmpd="sng" algn="ctr">
-                      <a:solidFill>
-                        <a:schemeClr val="tx1"/>
-                      </a:solidFill>
-                      <a:prstDash val="solid"/>
-                      <a:round/>
-                      <a:headEnd type="none" w="med" len="med"/>
-                      <a:tailEnd type="none" w="med" len="med"/>
-                    </a:lnR>
-                    <a:lnT w="12700" cap="flat" cmpd="sng" algn="ctr">
-                      <a:solidFill>
-                        <a:schemeClr val="tx1"/>
-                      </a:solidFill>
-                      <a:prstDash val="solid"/>
-                      <a:round/>
-                      <a:headEnd type="none" w="med" len="med"/>
-                      <a:tailEnd type="none" w="med" len="med"/>
-                    </a:lnT>
-                    <a:lnB w="12700" cap="flat" cmpd="sng" algn="ctr">
-                      <a:solidFill>
-                        <a:schemeClr val="tx1"/>
-                      </a:solidFill>
-                      <a:prstDash val="solid"/>
-                      <a:round/>
-                      <a:headEnd type="none" w="med" len="med"/>
-                      <a:tailEnd type="none" w="med" len="med"/>
-                    </a:lnB>
-                    <a:solidFill>
-                      <a:srgbClr val="F4F8FC"/>
-                    </a:solidFill>
-                  </a:tcPr>
-                </a:tc>
-                <a:extLst>
-                  <a:ext uri="{0D108BD9-81ED-4DB2-BD59-A6C34878D82A}">
-                    <a16:rowId xmlns:a16="http://schemas.microsoft.com/office/drawing/2014/main" val="4198258758"/>
-                  </a:ext>
-                </a:extLst>
-              </a:tr>
-              <a:tr h="294018">
-                <a:tc>
-                  <a:txBody>
-                    <a:bodyPr/>
-                    <a:lstStyle/>
-                    <a:p>
-                      <a:r>
-                        <a:rPr lang="de-DE" b="0" dirty="0" err="1"/>
-                        <a:t>Precip_mm</a:t>
-                      </a:r>
-                      <a:endParaRPr lang="de-DE" b="0" dirty="0"/>
-                    </a:p>
-                  </a:txBody>
-                  <a:tcPr>
-                    <a:lnL w="12700" cap="flat" cmpd="sng" algn="ctr">
-                      <a:solidFill>
-                        <a:schemeClr val="tx1"/>
-                      </a:solidFill>
-                      <a:prstDash val="solid"/>
-                      <a:round/>
-                      <a:headEnd type="none" w="med" len="med"/>
-                      <a:tailEnd type="none" w="med" len="med"/>
-                    </a:lnL>
-                    <a:lnR w="12700" cap="flat" cmpd="sng" algn="ctr">
-                      <a:solidFill>
-                        <a:schemeClr val="tx1"/>
-                      </a:solidFill>
-                      <a:prstDash val="solid"/>
-                      <a:round/>
-                      <a:headEnd type="none" w="med" len="med"/>
-                      <a:tailEnd type="none" w="med" len="med"/>
-                    </a:lnR>
-                    <a:lnT w="12700" cap="flat" cmpd="sng" algn="ctr">
-                      <a:solidFill>
-                        <a:schemeClr val="tx1"/>
-                      </a:solidFill>
-                      <a:prstDash val="solid"/>
-                      <a:round/>
-                      <a:headEnd type="none" w="med" len="med"/>
-                      <a:tailEnd type="none" w="med" len="med"/>
-                    </a:lnT>
-                    <a:lnB w="12700" cap="flat" cmpd="sng" algn="ctr">
-                      <a:solidFill>
-                        <a:schemeClr val="tx1"/>
-                      </a:solidFill>
-                      <a:prstDash val="solid"/>
-                      <a:round/>
-                      <a:headEnd type="none" w="med" len="med"/>
-                      <a:tailEnd type="none" w="med" len="med"/>
-                    </a:lnB>
-                    <a:solidFill>
-                      <a:srgbClr val="F4F8FC">
-                        <a:alpha val="20000"/>
-                      </a:srgbClr>
-                    </a:solidFill>
-                  </a:tcPr>
-                </a:tc>
-                <a:tc>
-                  <a:txBody>
-                    <a:bodyPr/>
-                    <a:lstStyle/>
-                    <a:p>
-                      <a:r>
-                        <a:rPr lang="de-DE" dirty="0"/>
-                        <a:t>Niederschlagsmenge in mm (1 mm entspricht 1l / m²)</a:t>
-                      </a:r>
-                    </a:p>
-                  </a:txBody>
-                  <a:tcPr>
-                    <a:lnL w="12700" cap="flat" cmpd="sng" algn="ctr">
-                      <a:solidFill>
-                        <a:schemeClr val="tx1"/>
-                      </a:solidFill>
-                      <a:prstDash val="solid"/>
-                      <a:round/>
-                      <a:headEnd type="none" w="med" len="med"/>
-                      <a:tailEnd type="none" w="med" len="med"/>
-                    </a:lnL>
-                    <a:lnR w="12700" cap="flat" cmpd="sng" algn="ctr">
-                      <a:solidFill>
-                        <a:schemeClr val="tx1"/>
-                      </a:solidFill>
-                      <a:prstDash val="solid"/>
-                      <a:round/>
-                      <a:headEnd type="none" w="med" len="med"/>
-                      <a:tailEnd type="none" w="med" len="med"/>
-                    </a:lnR>
-                    <a:lnT w="12700" cap="flat" cmpd="sng" algn="ctr">
-                      <a:solidFill>
-                        <a:schemeClr val="tx1"/>
-                      </a:solidFill>
-                      <a:prstDash val="solid"/>
-                      <a:round/>
-                      <a:headEnd type="none" w="med" len="med"/>
-                      <a:tailEnd type="none" w="med" len="med"/>
-                    </a:lnT>
-                    <a:lnB w="12700" cap="flat" cmpd="sng" algn="ctr">
-                      <a:solidFill>
-                        <a:schemeClr val="tx1"/>
-                      </a:solidFill>
-                      <a:prstDash val="solid"/>
-                      <a:round/>
-                      <a:headEnd type="none" w="med" len="med"/>
-                      <a:tailEnd type="none" w="med" len="med"/>
-                    </a:lnB>
-                    <a:solidFill>
-                      <a:srgbClr val="F4F8FC">
-                        <a:alpha val="20000"/>
-                      </a:srgbClr>
-                    </a:solidFill>
-                  </a:tcPr>
-                </a:tc>
-                <a:extLst>
-                  <a:ext uri="{0D108BD9-81ED-4DB2-BD59-A6C34878D82A}">
-                    <a16:rowId xmlns:a16="http://schemas.microsoft.com/office/drawing/2014/main" val="4285019933"/>
-                  </a:ext>
-                </a:extLst>
-              </a:tr>
-              <a:tr h="294018">
-                <a:tc>
-                  <a:txBody>
-                    <a:bodyPr/>
-                    <a:lstStyle/>
-                    <a:p>
-                      <a:r>
-                        <a:rPr lang="de-DE" b="0" dirty="0" err="1"/>
-                        <a:t>Humidity</a:t>
-                      </a:r>
-                      <a:endParaRPr lang="de-DE" b="0" dirty="0"/>
-                    </a:p>
-                  </a:txBody>
-                  <a:tcPr>
-                    <a:lnL w="12700" cap="flat" cmpd="sng" algn="ctr">
-                      <a:solidFill>
-                        <a:schemeClr val="tx1"/>
-                      </a:solidFill>
-                      <a:prstDash val="solid"/>
-                      <a:round/>
-                      <a:headEnd type="none" w="med" len="med"/>
-                      <a:tailEnd type="none" w="med" len="med"/>
-                    </a:lnL>
-                    <a:lnR w="12700" cap="flat" cmpd="sng" algn="ctr">
-                      <a:solidFill>
-                        <a:schemeClr val="tx1"/>
-                      </a:solidFill>
-                      <a:prstDash val="solid"/>
-                      <a:round/>
-                      <a:headEnd type="none" w="med" len="med"/>
-                      <a:tailEnd type="none" w="med" len="med"/>
-                    </a:lnR>
-                    <a:lnT w="12700" cap="flat" cmpd="sng" algn="ctr">
-                      <a:solidFill>
-                        <a:schemeClr val="tx1"/>
-                      </a:solidFill>
-                      <a:prstDash val="solid"/>
-                      <a:round/>
-                      <a:headEnd type="none" w="med" len="med"/>
-                      <a:tailEnd type="none" w="med" len="med"/>
-                    </a:lnT>
-                    <a:lnB w="12700" cap="flat" cmpd="sng" algn="ctr">
-                      <a:solidFill>
-                        <a:schemeClr val="tx1"/>
-                      </a:solidFill>
-                      <a:prstDash val="solid"/>
-                      <a:round/>
-                      <a:headEnd type="none" w="med" len="med"/>
-                      <a:tailEnd type="none" w="med" len="med"/>
-                    </a:lnB>
-                    <a:solidFill>
-                      <a:srgbClr val="F4F8FC"/>
-                    </a:solidFill>
-                  </a:tcPr>
-                </a:tc>
-                <a:tc>
-                  <a:txBody>
-                    <a:bodyPr/>
-                    <a:lstStyle/>
-                    <a:p>
-                      <a:r>
-                        <a:rPr lang="de-DE" dirty="0"/>
-                        <a:t>Luftfeuchtigkeit in %</a:t>
-                      </a:r>
-                    </a:p>
-                  </a:txBody>
-                  <a:tcPr>
-                    <a:lnL w="12700" cap="flat" cmpd="sng" algn="ctr">
-                      <a:solidFill>
-                        <a:schemeClr val="tx1"/>
-                      </a:solidFill>
-                      <a:prstDash val="solid"/>
-                      <a:round/>
-                      <a:headEnd type="none" w="med" len="med"/>
-                      <a:tailEnd type="none" w="med" len="med"/>
-                    </a:lnL>
-                    <a:lnR w="12700" cap="flat" cmpd="sng" algn="ctr">
-                      <a:solidFill>
-                        <a:schemeClr val="tx1"/>
-                      </a:solidFill>
-                      <a:prstDash val="solid"/>
-                      <a:round/>
-                      <a:headEnd type="none" w="med" len="med"/>
-                      <a:tailEnd type="none" w="med" len="med"/>
-                    </a:lnR>
-                    <a:lnT w="12700" cap="flat" cmpd="sng" algn="ctr">
-                      <a:solidFill>
-                        <a:schemeClr val="tx1"/>
-                      </a:solidFill>
-                      <a:prstDash val="solid"/>
-                      <a:round/>
-                      <a:headEnd type="none" w="med" len="med"/>
-                      <a:tailEnd type="none" w="med" len="med"/>
-                    </a:lnT>
-                    <a:lnB w="12700" cap="flat" cmpd="sng" algn="ctr">
-                      <a:solidFill>
-                        <a:schemeClr val="tx1"/>
-                      </a:solidFill>
-                      <a:prstDash val="solid"/>
-                      <a:round/>
-                      <a:headEnd type="none" w="med" len="med"/>
-                      <a:tailEnd type="none" w="med" len="med"/>
-                    </a:lnB>
-                    <a:solidFill>
-                      <a:srgbClr val="F4F8FC"/>
-                    </a:solidFill>
-                  </a:tcPr>
-                </a:tc>
-                <a:extLst>
-                  <a:ext uri="{0D108BD9-81ED-4DB2-BD59-A6C34878D82A}">
-                    <a16:rowId xmlns:a16="http://schemas.microsoft.com/office/drawing/2014/main" val="2007500412"/>
-                  </a:ext>
-                </a:extLst>
-              </a:tr>
-              <a:tr h="294018">
-                <a:tc>
-                  <a:txBody>
-                    <a:bodyPr/>
-                    <a:lstStyle/>
-                    <a:p>
-                      <a:r>
-                        <a:rPr lang="de-DE" b="0" dirty="0" err="1"/>
-                        <a:t>Temperature_celsius</a:t>
-                      </a:r>
-                      <a:endParaRPr lang="de-DE" b="0" dirty="0"/>
-                    </a:p>
-                  </a:txBody>
-                  <a:tcPr>
-                    <a:lnL w="12700" cap="flat" cmpd="sng" algn="ctr">
-                      <a:solidFill>
-                        <a:schemeClr val="tx1"/>
-                      </a:solidFill>
-                      <a:prstDash val="solid"/>
-                      <a:round/>
-                      <a:headEnd type="none" w="med" len="med"/>
-                      <a:tailEnd type="none" w="med" len="med"/>
-                    </a:lnL>
-                    <a:lnR w="12700" cap="flat" cmpd="sng" algn="ctr">
-                      <a:solidFill>
-                        <a:schemeClr val="tx1"/>
-                      </a:solidFill>
-                      <a:prstDash val="solid"/>
-                      <a:round/>
-                      <a:headEnd type="none" w="med" len="med"/>
-                      <a:tailEnd type="none" w="med" len="med"/>
-                    </a:lnR>
-                    <a:lnT w="12700" cap="flat" cmpd="sng" algn="ctr">
-                      <a:solidFill>
-                        <a:schemeClr val="tx1"/>
-                      </a:solidFill>
-                      <a:prstDash val="solid"/>
-                      <a:round/>
-                      <a:headEnd type="none" w="med" len="med"/>
-                      <a:tailEnd type="none" w="med" len="med"/>
-                    </a:lnT>
-                    <a:lnB w="12700" cap="flat" cmpd="sng" algn="ctr">
-                      <a:solidFill>
-                        <a:schemeClr val="tx1"/>
-                      </a:solidFill>
-                      <a:prstDash val="solid"/>
-                      <a:round/>
-                      <a:headEnd type="none" w="med" len="med"/>
-                      <a:tailEnd type="none" w="med" len="med"/>
-                    </a:lnB>
-                    <a:solidFill>
-                      <a:srgbClr val="F4F8FC">
-                        <a:alpha val="20000"/>
-                      </a:srgbClr>
-                    </a:solidFill>
-                  </a:tcPr>
-                </a:tc>
-                <a:tc>
-                  <a:txBody>
-                    <a:bodyPr/>
-                    <a:lstStyle/>
-                    <a:p>
-                      <a:r>
-                        <a:rPr lang="de-DE" dirty="0"/>
-                        <a:t>Temperatur in °C</a:t>
-                      </a:r>
-                    </a:p>
-                  </a:txBody>
-                  <a:tcPr>
-                    <a:lnL w="12700" cap="flat" cmpd="sng" algn="ctr">
-                      <a:solidFill>
-                        <a:schemeClr val="tx1"/>
-                      </a:solidFill>
-                      <a:prstDash val="solid"/>
-                      <a:round/>
-                      <a:headEnd type="none" w="med" len="med"/>
-                      <a:tailEnd type="none" w="med" len="med"/>
-                    </a:lnL>
-                    <a:lnR w="12700" cap="flat" cmpd="sng" algn="ctr">
-                      <a:solidFill>
-                        <a:schemeClr val="tx1"/>
-                      </a:solidFill>
-                      <a:prstDash val="solid"/>
-                      <a:round/>
-                      <a:headEnd type="none" w="med" len="med"/>
-                      <a:tailEnd type="none" w="med" len="med"/>
-                    </a:lnR>
-                    <a:lnT w="12700" cap="flat" cmpd="sng" algn="ctr">
-                      <a:solidFill>
-                        <a:schemeClr val="tx1"/>
-                      </a:solidFill>
-                      <a:prstDash val="solid"/>
-                      <a:round/>
-                      <a:headEnd type="none" w="med" len="med"/>
-                      <a:tailEnd type="none" w="med" len="med"/>
-                    </a:lnT>
-                    <a:lnB w="12700" cap="flat" cmpd="sng" algn="ctr">
-                      <a:solidFill>
-                        <a:schemeClr val="tx1"/>
-                      </a:solidFill>
-                      <a:prstDash val="solid"/>
-                      <a:round/>
-                      <a:headEnd type="none" w="med" len="med"/>
-                      <a:tailEnd type="none" w="med" len="med"/>
-                    </a:lnB>
-                    <a:solidFill>
-                      <a:srgbClr val="F4F8FC">
-                        <a:alpha val="20000"/>
-                      </a:srgbClr>
-                    </a:solidFill>
-                  </a:tcPr>
-                </a:tc>
-                <a:extLst>
-                  <a:ext uri="{0D108BD9-81ED-4DB2-BD59-A6C34878D82A}">
-                    <a16:rowId xmlns:a16="http://schemas.microsoft.com/office/drawing/2014/main" val="3752652142"/>
-                  </a:ext>
-                </a:extLst>
-              </a:tr>
-              <a:tr h="294018">
-                <a:tc>
-                  <a:txBody>
-                    <a:bodyPr/>
-                    <a:lstStyle/>
-                    <a:p>
-                      <a:r>
-                        <a:rPr lang="de-DE" b="0" dirty="0" err="1"/>
-                        <a:t>Visibility_km</a:t>
-                      </a:r>
-                      <a:endParaRPr lang="de-DE" b="0" dirty="0"/>
-                    </a:p>
-                  </a:txBody>
-                  <a:tcPr>
-                    <a:lnL w="12700" cap="flat" cmpd="sng" algn="ctr">
-                      <a:solidFill>
-                        <a:schemeClr val="tx1"/>
-                      </a:solidFill>
-                      <a:prstDash val="solid"/>
-                      <a:round/>
-                      <a:headEnd type="none" w="med" len="med"/>
-                      <a:tailEnd type="none" w="med" len="med"/>
-                    </a:lnL>
-                    <a:lnR w="12700" cap="flat" cmpd="sng" algn="ctr">
-                      <a:solidFill>
-                        <a:schemeClr val="tx1"/>
-                      </a:solidFill>
-                      <a:prstDash val="solid"/>
-                      <a:round/>
-                      <a:headEnd type="none" w="med" len="med"/>
-                      <a:tailEnd type="none" w="med" len="med"/>
-                    </a:lnR>
-                    <a:lnT w="12700" cap="flat" cmpd="sng" algn="ctr">
-                      <a:solidFill>
-                        <a:schemeClr val="tx1"/>
-                      </a:solidFill>
-                      <a:prstDash val="solid"/>
-                      <a:round/>
-                      <a:headEnd type="none" w="med" len="med"/>
-                      <a:tailEnd type="none" w="med" len="med"/>
-                    </a:lnT>
-                    <a:lnB w="12700" cap="flat" cmpd="sng" algn="ctr">
-                      <a:solidFill>
-                        <a:schemeClr val="tx1"/>
-                      </a:solidFill>
-                      <a:prstDash val="solid"/>
-                      <a:round/>
-                      <a:headEnd type="none" w="med" len="med"/>
-                      <a:tailEnd type="none" w="med" len="med"/>
-                    </a:lnB>
-                    <a:solidFill>
-                      <a:srgbClr val="F4F8FC"/>
-                    </a:solidFill>
-                  </a:tcPr>
-                </a:tc>
-                <a:tc>
-                  <a:txBody>
-                    <a:bodyPr/>
-                    <a:lstStyle/>
-                    <a:p>
-                      <a:r>
-                        <a:rPr lang="de-DE" dirty="0"/>
-                        <a:t>Sichtweite in km</a:t>
-                      </a:r>
-                    </a:p>
-                  </a:txBody>
-                  <a:tcPr>
-                    <a:lnL w="12700" cap="flat" cmpd="sng" algn="ctr">
-                      <a:solidFill>
-                        <a:schemeClr val="tx1"/>
-                      </a:solidFill>
-                      <a:prstDash val="solid"/>
-                      <a:round/>
-                      <a:headEnd type="none" w="med" len="med"/>
-                      <a:tailEnd type="none" w="med" len="med"/>
-                    </a:lnL>
-                    <a:lnR w="12700" cap="flat" cmpd="sng" algn="ctr">
-                      <a:solidFill>
-                        <a:schemeClr val="tx1"/>
-                      </a:solidFill>
-                      <a:prstDash val="solid"/>
-                      <a:round/>
-                      <a:headEnd type="none" w="med" len="med"/>
-                      <a:tailEnd type="none" w="med" len="med"/>
-                    </a:lnR>
-                    <a:lnT w="12700" cap="flat" cmpd="sng" algn="ctr">
-                      <a:solidFill>
-                        <a:schemeClr val="tx1"/>
-                      </a:solidFill>
-                      <a:prstDash val="solid"/>
-                      <a:round/>
-                      <a:headEnd type="none" w="med" len="med"/>
-                      <a:tailEnd type="none" w="med" len="med"/>
-                    </a:lnT>
-                    <a:lnB w="12700" cap="flat" cmpd="sng" algn="ctr">
-                      <a:solidFill>
-                        <a:schemeClr val="tx1"/>
-                      </a:solidFill>
-                      <a:prstDash val="solid"/>
-                      <a:round/>
-                      <a:headEnd type="none" w="med" len="med"/>
-                      <a:tailEnd type="none" w="med" len="med"/>
-                    </a:lnB>
-                    <a:solidFill>
-                      <a:srgbClr val="F4F8FC"/>
-                    </a:solidFill>
-                  </a:tcPr>
-                </a:tc>
-                <a:extLst>
-                  <a:ext uri="{0D108BD9-81ED-4DB2-BD59-A6C34878D82A}">
-                    <a16:rowId xmlns:a16="http://schemas.microsoft.com/office/drawing/2014/main" val="1176319790"/>
-                  </a:ext>
-                </a:extLst>
-              </a:tr>
-              <a:tr h="452753">
-                <a:tc>
-                  <a:txBody>
-                    <a:bodyPr/>
-                    <a:lstStyle/>
-                    <a:p>
-                      <a:r>
-                        <a:rPr lang="de-DE" dirty="0" err="1"/>
-                        <a:t>Air_quality</a:t>
-                      </a:r>
-                      <a:r>
-                        <a:rPr lang="de-DE" dirty="0"/>
-                        <a:t>_*</a:t>
-                      </a:r>
-                    </a:p>
-                  </a:txBody>
-                  <a:tcPr>
-                    <a:lnL w="12700" cap="flat" cmpd="sng" algn="ctr">
-                      <a:solidFill>
-                        <a:schemeClr val="tx1"/>
-                      </a:solidFill>
-                      <a:prstDash val="solid"/>
-                      <a:round/>
-                      <a:headEnd type="none" w="med" len="med"/>
-                      <a:tailEnd type="none" w="med" len="med"/>
-                    </a:lnL>
-                    <a:lnR w="12700" cap="flat" cmpd="sng" algn="ctr">
-                      <a:solidFill>
-                        <a:schemeClr val="tx1"/>
-                      </a:solidFill>
-                      <a:prstDash val="solid"/>
-                      <a:round/>
-                      <a:headEnd type="none" w="med" len="med"/>
-                      <a:tailEnd type="none" w="med" len="med"/>
-                    </a:lnR>
-                    <a:lnT w="12700" cap="flat" cmpd="sng" algn="ctr">
-                      <a:solidFill>
-                        <a:schemeClr val="tx1"/>
-                      </a:solidFill>
-                      <a:prstDash val="solid"/>
-                      <a:round/>
-                      <a:headEnd type="none" w="med" len="med"/>
-                      <a:tailEnd type="none" w="med" len="med"/>
-                    </a:lnT>
-                    <a:lnB w="12700" cap="flat" cmpd="sng" algn="ctr">
-                      <a:solidFill>
-                        <a:schemeClr val="tx1"/>
-                      </a:solidFill>
-                      <a:prstDash val="solid"/>
-                      <a:round/>
-                      <a:headEnd type="none" w="med" len="med"/>
-                      <a:tailEnd type="none" w="med" len="med"/>
-                    </a:lnB>
-                    <a:solidFill>
-                      <a:srgbClr val="F4F8FC">
-                        <a:alpha val="20000"/>
-                      </a:srgbClr>
-                    </a:solidFill>
-                  </a:tcPr>
-                </a:tc>
-                <a:tc>
-                  <a:txBody>
-                    <a:bodyPr/>
-                    <a:lstStyle/>
-                    <a:p>
-                      <a:r>
-                        <a:rPr lang="de-DE" dirty="0"/>
-                        <a:t>Verschiedene Werte zur Luftqualität inkl. der Feinstaubbelastung</a:t>
-                      </a:r>
-                    </a:p>
-                  </a:txBody>
-                  <a:tcPr>
-                    <a:lnL w="12700" cap="flat" cmpd="sng" algn="ctr">
-                      <a:solidFill>
-                        <a:schemeClr val="tx1"/>
-                      </a:solidFill>
-                      <a:prstDash val="solid"/>
-                      <a:round/>
-                      <a:headEnd type="none" w="med" len="med"/>
-                      <a:tailEnd type="none" w="med" len="med"/>
-                    </a:lnL>
-                    <a:lnR w="12700" cap="flat" cmpd="sng" algn="ctr">
-                      <a:solidFill>
-                        <a:schemeClr val="tx1"/>
-                      </a:solidFill>
-                      <a:prstDash val="solid"/>
-                      <a:round/>
-                      <a:headEnd type="none" w="med" len="med"/>
-                      <a:tailEnd type="none" w="med" len="med"/>
-                    </a:lnR>
-                    <a:lnT w="12700" cap="flat" cmpd="sng" algn="ctr">
-                      <a:solidFill>
-                        <a:schemeClr val="tx1"/>
-                      </a:solidFill>
-                      <a:prstDash val="solid"/>
-                      <a:round/>
-                      <a:headEnd type="none" w="med" len="med"/>
-                      <a:tailEnd type="none" w="med" len="med"/>
-                    </a:lnT>
-                    <a:lnB w="12700" cap="flat" cmpd="sng" algn="ctr">
-                      <a:solidFill>
-                        <a:schemeClr val="tx1"/>
-                      </a:solidFill>
-                      <a:prstDash val="solid"/>
-                      <a:round/>
-                      <a:headEnd type="none" w="med" len="med"/>
-                      <a:tailEnd type="none" w="med" len="med"/>
-                    </a:lnB>
-                    <a:solidFill>
-                      <a:srgbClr val="F4F8FC">
-                        <a:alpha val="20000"/>
-                      </a:srgbClr>
-                    </a:solidFill>
-                  </a:tcPr>
-                </a:tc>
-                <a:extLst>
-                  <a:ext uri="{0D108BD9-81ED-4DB2-BD59-A6C34878D82A}">
-                    <a16:rowId xmlns:a16="http://schemas.microsoft.com/office/drawing/2014/main" val="1620487455"/>
-                  </a:ext>
-                </a:extLst>
-              </a:tr>
-            </a:tbl>
-          </a:graphicData>
-        </a:graphic>
-      </p:graphicFrame>
+      <p:pic>
+        <p:nvPicPr>
+          <p:cNvPr id="9" name="Grafik 8" descr="Ein Bild, das Text, Screenshot, Schrift, Zahl enthält.&#10;&#10;KI-generierte Inhalte können fehlerhaft sein.">
+            <a:extLst>
+              <a:ext uri="{FF2B5EF4-FFF2-40B4-BE49-F238E27FC236}">
+                <a16:creationId xmlns:a16="http://schemas.microsoft.com/office/drawing/2014/main" id="{85B32943-B9C6-E9BC-80B5-A5EB4E2F4FEB}"/>
+              </a:ext>
+            </a:extLst>
+          </p:cNvPr>
+          <p:cNvPicPr>
+            <a:picLocks noChangeAspect="1"/>
+          </p:cNvPicPr>
+          <p:nvPr/>
+        </p:nvPicPr>
+        <p:blipFill>
+          <a:blip r:embed="rId2"/>
+          <a:stretch>
+            <a:fillRect/>
+          </a:stretch>
+        </p:blipFill>
+        <p:spPr>
+          <a:xfrm>
+            <a:off x="914399" y="1572306"/>
+            <a:ext cx="8591551" cy="4449196"/>
+          </a:xfrm>
+          <a:prstGeom prst="rect">
+            <a:avLst/>
+          </a:prstGeom>
+        </p:spPr>
+      </p:pic>
     </p:spTree>
     <p:extLst>
       <p:ext uri="{BB962C8B-B14F-4D97-AF65-F5344CB8AC3E}">
@@ -6679,124 +5165,64 @@
           <a:chExt cx="0" cy="0"/>
         </a:xfrm>
       </p:grpSpPr>
-      <p:sp>
-        <p:nvSpPr>
-          <p:cNvPr id="2" name="Titel 1">
-            <a:extLst>
-              <a:ext uri="{FF2B5EF4-FFF2-40B4-BE49-F238E27FC236}">
-                <a16:creationId xmlns:a16="http://schemas.microsoft.com/office/drawing/2014/main" id="{1529E841-C60C-7246-0B58-48E6EF76F362}"/>
-              </a:ext>
-            </a:extLst>
-          </p:cNvPr>
-          <p:cNvSpPr>
-            <a:spLocks noGrp="1"/>
-          </p:cNvSpPr>
-          <p:nvPr>
-            <p:ph type="title"/>
-          </p:nvPr>
-        </p:nvSpPr>
-        <p:spPr/>
-        <p:txBody>
-          <a:bodyPr/>
-          <a:lstStyle/>
-          <a:p>
-            <a:r>
-              <a:rPr lang="de-DE" dirty="0"/>
-              <a:t>Komplexe Abfrage</a:t>
-            </a:r>
-          </a:p>
-        </p:txBody>
-      </p:sp>
-      <p:sp>
-        <p:nvSpPr>
-          <p:cNvPr id="4" name="Datumsplatzhalter 3">
-            <a:extLst>
-              <a:ext uri="{FF2B5EF4-FFF2-40B4-BE49-F238E27FC236}">
-                <a16:creationId xmlns:a16="http://schemas.microsoft.com/office/drawing/2014/main" id="{71267946-51AF-147B-19A7-93A3CB4C4599}"/>
-              </a:ext>
-            </a:extLst>
-          </p:cNvPr>
-          <p:cNvSpPr>
-            <a:spLocks noGrp="1"/>
-          </p:cNvSpPr>
-          <p:nvPr>
-            <p:ph type="dt" sz="half" idx="10"/>
-          </p:nvPr>
-        </p:nvSpPr>
-        <p:spPr/>
-        <p:txBody>
-          <a:bodyPr/>
-          <a:lstStyle/>
-          <a:p>
-            <a:fld id="{979AD6E7-A48C-4424-B592-37C7B13B8FC0}" type="datetime1">
-              <a:rPr lang="de-DE" smtClean="0"/>
-              <a:t>31.01.2026</a:t>
-            </a:fld>
-            <a:endParaRPr lang="en-US"/>
-          </a:p>
-        </p:txBody>
-      </p:sp>
-      <p:sp>
-        <p:nvSpPr>
-          <p:cNvPr id="5" name="Fußzeilenplatzhalter 4">
-            <a:extLst>
-              <a:ext uri="{FF2B5EF4-FFF2-40B4-BE49-F238E27FC236}">
-                <a16:creationId xmlns:a16="http://schemas.microsoft.com/office/drawing/2014/main" id="{055D5BD9-CB9B-1EFB-E9E8-27FF4A3F1FBD}"/>
-              </a:ext>
-            </a:extLst>
-          </p:cNvPr>
-          <p:cNvSpPr>
-            <a:spLocks noGrp="1"/>
-          </p:cNvSpPr>
-          <p:nvPr>
-            <p:ph type="ftr" sz="quarter" idx="11"/>
-          </p:nvPr>
-        </p:nvSpPr>
-        <p:spPr/>
-        <p:txBody>
-          <a:bodyPr/>
-          <a:lstStyle/>
-          <a:p>
-            <a:r>
-              <a:rPr lang="en-US"/>
-              <a:t>Abschlussarbeit MySQL - Frank Wünsch</a:t>
-            </a:r>
-          </a:p>
-        </p:txBody>
-      </p:sp>
-      <p:sp>
-        <p:nvSpPr>
-          <p:cNvPr id="6" name="Foliennummernplatzhalter 5">
-            <a:extLst>
-              <a:ext uri="{FF2B5EF4-FFF2-40B4-BE49-F238E27FC236}">
-                <a16:creationId xmlns:a16="http://schemas.microsoft.com/office/drawing/2014/main" id="{267CF1D6-F5E9-2FF1-86C5-505F14234443}"/>
-              </a:ext>
-            </a:extLst>
-          </p:cNvPr>
-          <p:cNvSpPr>
-            <a:spLocks noGrp="1"/>
-          </p:cNvSpPr>
-          <p:nvPr>
-            <p:ph type="sldNum" sz="quarter" idx="12"/>
-          </p:nvPr>
-        </p:nvSpPr>
-        <p:spPr/>
-        <p:txBody>
-          <a:bodyPr/>
-          <a:lstStyle/>
-          <a:p>
-            <a:fld id="{8E05DC9C-C50D-D242-B083-59CEE07163F1}" type="slidenum">
-              <a:rPr lang="en-US" smtClean="0"/>
-              <a:t>8</a:t>
-            </a:fld>
-            <a:endParaRPr lang="en-US"/>
-          </a:p>
-        </p:txBody>
-      </p:sp>
+      <mc:AlternateContent xmlns:mc="http://schemas.openxmlformats.org/markup-compatibility/2006">
+        <mc:Choice xmlns:we="http://schemas.microsoft.com/office/webextensions/webextension/2010/11" xmlns:pca="http://schemas.microsoft.com/office/powerpoint/2013/contentapp" Requires="we pca">
+          <p:graphicFrame>
+            <p:nvGraphicFramePr>
+              <p:cNvPr id="2" name="Add-in" descr="Add-In-Inhalt für Microsoft Power BI."/>
+              <p:cNvGraphicFramePr>
+                <a:graphicFrameLocks noGrp="1"/>
+              </p:cNvGraphicFramePr>
+              <p:nvPr>
+                <p:extLst>
+                  <p:ext uri="{D42A27DB-BD31-4B8C-83A1-F6EECF244321}">
+                    <p14:modId xmlns:p14="http://schemas.microsoft.com/office/powerpoint/2010/main" val="3030515379"/>
+                  </p:ext>
+                </p:extLst>
+              </p:nvPr>
+            </p:nvGraphicFramePr>
+            <p:xfrm>
+              <a:off x="0" y="0"/>
+              <a:ext cx="12192000" cy="6419850"/>
+            </p:xfrm>
+            <a:graphic>
+              <a:graphicData uri="http://schemas.microsoft.com/office/webextensions/webextension/2010/11">
+                <we:webextensionref xmlns:we="http://schemas.microsoft.com/office/webextensions/webextension/2010/11" xmlns:r="http://schemas.openxmlformats.org/officeDocument/2006/relationships" r:id="rId2"/>
+              </a:graphicData>
+            </a:graphic>
+          </p:graphicFrame>
+        </mc:Choice>
+        <mc:Fallback>
+          <p:pic>
+            <p:nvPicPr>
+              <p:cNvPr id="2" name="Add-in" descr="Add-In-Inhalt für Microsoft Power BI."/>
+              <p:cNvPicPr>
+                <a:picLocks noGrp="1" noRot="1" noChangeAspect="1" noMove="1" noResize="1" noEditPoints="1" noAdjustHandles="1" noChangeArrowheads="1" noChangeShapeType="1"/>
+              </p:cNvPicPr>
+              <p:nvPr/>
+            </p:nvPicPr>
+            <p:blipFill>
+              <a:blip r:embed="rId3"/>
+              <a:stretch>
+                <a:fillRect/>
+              </a:stretch>
+            </p:blipFill>
+            <p:spPr>
+              <a:xfrm>
+                <a:off x="0" y="0"/>
+                <a:ext cx="12192000" cy="6419850"/>
+              </a:xfrm>
+              <a:prstGeom prst="rect">
+                <a:avLst/>
+              </a:prstGeom>
+            </p:spPr>
+          </p:pic>
+        </mc:Fallback>
+      </mc:AlternateContent>
     </p:spTree>
     <p:extLst>
       <p:ext uri="{BB962C8B-B14F-4D97-AF65-F5344CB8AC3E}">
-        <p14:creationId xmlns:p14="http://schemas.microsoft.com/office/powerpoint/2010/main" val="3790902607"/>
+        <p14:creationId xmlns:p14="http://schemas.microsoft.com/office/powerpoint/2010/main" val="3211859542"/>
       </p:ext>
     </p:extLst>
   </p:cSld>
@@ -6823,64 +5249,263 @@
           <a:chExt cx="0" cy="0"/>
         </a:xfrm>
       </p:grpSpPr>
-      <mc:AlternateContent xmlns:mc="http://schemas.openxmlformats.org/markup-compatibility/2006">
-        <mc:Choice xmlns:we="http://schemas.microsoft.com/office/webextensions/webextension/2010/11" xmlns:pca="http://schemas.microsoft.com/office/powerpoint/2013/contentapp" Requires="we pca">
-          <p:graphicFrame>
-            <p:nvGraphicFramePr>
-              <p:cNvPr id="2" name="Add-in" descr="Add-In-Inhalt für Microsoft Power BI."/>
-              <p:cNvGraphicFramePr>
-                <a:graphicFrameLocks noGrp="1"/>
-              </p:cNvGraphicFramePr>
-              <p:nvPr>
-                <p:extLst>
-                  <p:ext uri="{D42A27DB-BD31-4B8C-83A1-F6EECF244321}">
-                    <p14:modId xmlns:p14="http://schemas.microsoft.com/office/powerpoint/2010/main" val="996125359"/>
-                  </p:ext>
-                </p:extLst>
-              </p:nvPr>
-            </p:nvGraphicFramePr>
-            <p:xfrm>
-              <a:off x="0" y="1"/>
-              <a:ext cx="12192000" cy="6858000"/>
-            </p:xfrm>
-            <a:graphic>
-              <a:graphicData uri="http://schemas.microsoft.com/office/webextensions/webextension/2010/11">
-                <we:webextensionref xmlns:we="http://schemas.microsoft.com/office/webextensions/webextension/2010/11" xmlns:r="http://schemas.openxmlformats.org/officeDocument/2006/relationships" r:id="rId2"/>
-              </a:graphicData>
-            </a:graphic>
-          </p:graphicFrame>
-        </mc:Choice>
-        <mc:Fallback>
-          <p:pic>
-            <p:nvPicPr>
-              <p:cNvPr id="2" name="Add-in" descr="Add-In-Inhalt für Microsoft Power BI."/>
-              <p:cNvPicPr>
-                <a:picLocks noGrp="1" noRot="1" noChangeAspect="1" noMove="1" noResize="1" noEditPoints="1" noAdjustHandles="1" noChangeArrowheads="1" noChangeShapeType="1"/>
-              </p:cNvPicPr>
-              <p:nvPr/>
-            </p:nvPicPr>
-            <p:blipFill>
-              <a:blip r:embed="rId3"/>
-              <a:stretch>
-                <a:fillRect/>
-              </a:stretch>
-            </p:blipFill>
-            <p:spPr>
-              <a:xfrm>
-                <a:off x="0" y="1"/>
-                <a:ext cx="12192000" cy="6858000"/>
-              </a:xfrm>
-              <a:prstGeom prst="rect">
-                <a:avLst/>
-              </a:prstGeom>
-            </p:spPr>
-          </p:pic>
-        </mc:Fallback>
-      </mc:AlternateContent>
+      <p:sp>
+        <p:nvSpPr>
+          <p:cNvPr id="2" name="Titel 1">
+            <a:extLst>
+              <a:ext uri="{FF2B5EF4-FFF2-40B4-BE49-F238E27FC236}">
+                <a16:creationId xmlns:a16="http://schemas.microsoft.com/office/drawing/2014/main" id="{EB32ADF1-F79D-E6DE-EC2C-0CCEE33F3F07}"/>
+              </a:ext>
+            </a:extLst>
+          </p:cNvPr>
+          <p:cNvSpPr>
+            <a:spLocks noGrp="1"/>
+          </p:cNvSpPr>
+          <p:nvPr>
+            <p:ph type="title"/>
+          </p:nvPr>
+        </p:nvSpPr>
+        <p:spPr/>
+        <p:txBody>
+          <a:bodyPr/>
+          <a:lstStyle/>
+          <a:p>
+            <a:r>
+              <a:rPr lang="en-US" dirty="0" err="1"/>
+              <a:t>Fazit</a:t>
+            </a:r>
+            <a:endParaRPr lang="de-DE" dirty="0"/>
+          </a:p>
+        </p:txBody>
+      </p:sp>
+      <p:sp>
+        <p:nvSpPr>
+          <p:cNvPr id="3" name="Inhaltsplatzhalter 2">
+            <a:extLst>
+              <a:ext uri="{FF2B5EF4-FFF2-40B4-BE49-F238E27FC236}">
+                <a16:creationId xmlns:a16="http://schemas.microsoft.com/office/drawing/2014/main" id="{7FCECF97-35EB-82CF-9471-0A278FD22AC1}"/>
+              </a:ext>
+            </a:extLst>
+          </p:cNvPr>
+          <p:cNvSpPr>
+            <a:spLocks noGrp="1"/>
+          </p:cNvSpPr>
+          <p:nvPr>
+            <p:ph idx="1"/>
+          </p:nvPr>
+        </p:nvSpPr>
+        <p:spPr/>
+        <p:txBody>
+          <a:bodyPr>
+            <a:normAutofit lnSpcReduction="10000"/>
+          </a:bodyPr>
+          <a:lstStyle/>
+          <a:p>
+            <a:r>
+              <a:rPr lang="de-DE" dirty="0">
+                <a:solidFill>
+                  <a:srgbClr val="00B050"/>
+                </a:solidFill>
+              </a:rPr>
+              <a:t>Datensatz sehr gut geeignet zum Lernen von</a:t>
+            </a:r>
+          </a:p>
+          <a:p>
+            <a:pPr lvl="1"/>
+            <a:r>
+              <a:rPr lang="de-DE" dirty="0">
+                <a:solidFill>
+                  <a:srgbClr val="00B050"/>
+                </a:solidFill>
+              </a:rPr>
+              <a:t>Umgang mit MySQL</a:t>
+            </a:r>
+          </a:p>
+          <a:p>
+            <a:pPr lvl="1"/>
+            <a:r>
+              <a:rPr lang="de-DE" dirty="0">
+                <a:solidFill>
+                  <a:srgbClr val="00B050"/>
+                </a:solidFill>
+              </a:rPr>
+              <a:t>Datenanalyse mit KNIME</a:t>
+            </a:r>
+          </a:p>
+          <a:p>
+            <a:pPr lvl="1"/>
+            <a:r>
+              <a:rPr lang="de-DE" dirty="0">
+                <a:solidFill>
+                  <a:srgbClr val="00B050"/>
+                </a:solidFill>
+              </a:rPr>
+              <a:t>Erstellen von Vorhersagemodellen</a:t>
+            </a:r>
+          </a:p>
+          <a:p>
+            <a:pPr lvl="1"/>
+            <a:r>
+              <a:rPr lang="de-DE" dirty="0">
+                <a:solidFill>
+                  <a:srgbClr val="00B050"/>
+                </a:solidFill>
+              </a:rPr>
+              <a:t>Visualisierung / Analyse mit Power BI</a:t>
+            </a:r>
+          </a:p>
+          <a:p>
+            <a:pPr marL="457200" lvl="1" indent="0">
+              <a:buNone/>
+            </a:pPr>
+            <a:endParaRPr lang="de-DE" dirty="0"/>
+          </a:p>
+          <a:p>
+            <a:r>
+              <a:rPr lang="de-DE" dirty="0">
+                <a:solidFill>
+                  <a:srgbClr val="FF0000"/>
+                </a:solidFill>
+              </a:rPr>
+              <a:t>Datensatz schlecht oder nicht geeignet für</a:t>
+            </a:r>
+          </a:p>
+          <a:p>
+            <a:pPr lvl="1"/>
+            <a:r>
+              <a:rPr lang="de-DE" dirty="0">
+                <a:solidFill>
+                  <a:srgbClr val="FF0000"/>
+                </a:solidFill>
+              </a:rPr>
+              <a:t>Tiefgreifende Analysen zu</a:t>
+            </a:r>
+          </a:p>
+          <a:p>
+            <a:pPr lvl="2"/>
+            <a:r>
+              <a:rPr lang="de-DE" dirty="0">
+                <a:solidFill>
+                  <a:srgbClr val="FF0000"/>
+                </a:solidFill>
+              </a:rPr>
+              <a:t>Feuchtigkeit und Niederschlag</a:t>
+            </a:r>
+          </a:p>
+          <a:p>
+            <a:pPr lvl="2"/>
+            <a:r>
+              <a:rPr lang="de-DE" dirty="0">
+                <a:solidFill>
+                  <a:srgbClr val="FF0000"/>
+                </a:solidFill>
+              </a:rPr>
+              <a:t>Umweltverschmutzung durch Feuerwerke / Waldbrände etc.</a:t>
+            </a:r>
+          </a:p>
+          <a:p>
+            <a:pPr lvl="2"/>
+            <a:r>
+              <a:rPr lang="de-DE" dirty="0">
+                <a:solidFill>
+                  <a:srgbClr val="FF0000"/>
+                </a:solidFill>
+              </a:rPr>
+              <a:t>Langzeitanalysen zum Wetter</a:t>
+            </a:r>
+          </a:p>
+        </p:txBody>
+      </p:sp>
+      <p:sp>
+        <p:nvSpPr>
+          <p:cNvPr id="4" name="Datumsplatzhalter 3">
+            <a:extLst>
+              <a:ext uri="{FF2B5EF4-FFF2-40B4-BE49-F238E27FC236}">
+                <a16:creationId xmlns:a16="http://schemas.microsoft.com/office/drawing/2014/main" id="{774540AC-39CA-E7E8-135D-914C5B7093F6}"/>
+              </a:ext>
+            </a:extLst>
+          </p:cNvPr>
+          <p:cNvSpPr>
+            <a:spLocks noGrp="1"/>
+          </p:cNvSpPr>
+          <p:nvPr>
+            <p:ph type="dt" sz="half" idx="10"/>
+          </p:nvPr>
+        </p:nvSpPr>
+        <p:spPr/>
+        <p:txBody>
+          <a:bodyPr/>
+          <a:lstStyle/>
+          <a:p>
+            <a:fld id="{979AD6E7-A48C-4424-B592-37C7B13B8FC0}" type="datetime1">
+              <a:rPr lang="de-DE" smtClean="0"/>
+              <a:t>31.01.2026</a:t>
+            </a:fld>
+            <a:endParaRPr lang="en-US"/>
+          </a:p>
+        </p:txBody>
+      </p:sp>
+      <p:sp>
+        <p:nvSpPr>
+          <p:cNvPr id="5" name="Fußzeilenplatzhalter 4">
+            <a:extLst>
+              <a:ext uri="{FF2B5EF4-FFF2-40B4-BE49-F238E27FC236}">
+                <a16:creationId xmlns:a16="http://schemas.microsoft.com/office/drawing/2014/main" id="{3489CA39-8321-F0C4-5E59-FB8B7C89A47F}"/>
+              </a:ext>
+            </a:extLst>
+          </p:cNvPr>
+          <p:cNvSpPr>
+            <a:spLocks noGrp="1"/>
+          </p:cNvSpPr>
+          <p:nvPr>
+            <p:ph type="ftr" sz="quarter" idx="11"/>
+          </p:nvPr>
+        </p:nvSpPr>
+        <p:spPr/>
+        <p:txBody>
+          <a:bodyPr/>
+          <a:lstStyle/>
+          <a:p>
+            <a:r>
+              <a:rPr lang="en-US"/>
+              <a:t>Abschlussarbeit MySQL - Frank Wünsch</a:t>
+            </a:r>
+          </a:p>
+        </p:txBody>
+      </p:sp>
+      <p:sp>
+        <p:nvSpPr>
+          <p:cNvPr id="6" name="Foliennummernplatzhalter 5">
+            <a:extLst>
+              <a:ext uri="{FF2B5EF4-FFF2-40B4-BE49-F238E27FC236}">
+                <a16:creationId xmlns:a16="http://schemas.microsoft.com/office/drawing/2014/main" id="{8D5B02D2-3DCE-B83F-B227-8BE1EA75C050}"/>
+              </a:ext>
+            </a:extLst>
+          </p:cNvPr>
+          <p:cNvSpPr>
+            <a:spLocks noGrp="1"/>
+          </p:cNvSpPr>
+          <p:nvPr>
+            <p:ph type="sldNum" sz="quarter" idx="12"/>
+          </p:nvPr>
+        </p:nvSpPr>
+        <p:spPr/>
+        <p:txBody>
+          <a:bodyPr/>
+          <a:lstStyle/>
+          <a:p>
+            <a:fld id="{8E05DC9C-C50D-D242-B083-59CEE07163F1}" type="slidenum">
+              <a:rPr lang="en-US" smtClean="0"/>
+              <a:t>9</a:t>
+            </a:fld>
+            <a:endParaRPr lang="en-US"/>
+          </a:p>
+        </p:txBody>
+      </p:sp>
     </p:spTree>
     <p:extLst>
       <p:ext uri="{BB962C8B-B14F-4D97-AF65-F5344CB8AC3E}">
-        <p14:creationId xmlns:p14="http://schemas.microsoft.com/office/powerpoint/2010/main" val="3211859542"/>
+        <p14:creationId xmlns:p14="http://schemas.microsoft.com/office/powerpoint/2010/main" val="194241005"/>
       </p:ext>
     </p:extLst>
   </p:cSld>
@@ -7537,21 +6162,21 @@
 </file>
 
 <file path=customXml/item1.xml><?xml version="1.0" encoding="utf-8"?>
+<p:properties xmlns:p="http://schemas.microsoft.com/office/2006/metadata/properties" xmlns:xsi="http://www.w3.org/2001/XMLSchema-instance" xmlns:pc="http://schemas.microsoft.com/office/infopath/2007/PartnerControls">
+  <documentManagement>
+    <Document_x0020_Purpose xmlns="f577acbf-5b0b-4b4f-9948-268e97f8d3a4">Informational</Document_x0020_Purpose>
+    <Initiatives xmlns="f577acbf-5b0b-4b4f-9948-268e97f8d3a4"/>
+  </documentManagement>
+</p:properties>
+</file>
+
+<file path=customXml/item2.xml><?xml version="1.0" encoding="utf-8"?>
 <?mso-contentType ?>
 <FormTemplates xmlns="http://schemas.microsoft.com/sharepoint/v3/contenttype/forms">
   <Display>DocumentLibraryForm</Display>
   <Edit>DocumentLibraryForm</Edit>
   <New>DocumentLibraryForm</New>
 </FormTemplates>
-</file>
-
-<file path=customXml/item2.xml><?xml version="1.0" encoding="utf-8"?>
-<p:properties xmlns:p="http://schemas.microsoft.com/office/2006/metadata/properties" xmlns:xsi="http://www.w3.org/2001/XMLSchema-instance" xmlns:pc="http://schemas.microsoft.com/office/infopath/2007/PartnerControls">
-  <documentManagement>
-    <Document_x0020_Purpose xmlns="f577acbf-5b0b-4b4f-9948-268e97f8d3a4">Informational</Document_x0020_Purpose>
-    <Initiatives xmlns="f577acbf-5b0b-4b4f-9948-268e97f8d3a4"/>
-  </documentManagement>
-</p:properties>
 </file>
 
 <file path=customXml/item3.xml><?xml version="1.0" encoding="utf-8"?>
@@ -7811,14 +6436,6 @@
 </file>
 
 <file path=customXml/itemProps1.xml><?xml version="1.0" encoding="utf-8"?>
-<ds:datastoreItem xmlns:ds="http://schemas.openxmlformats.org/officeDocument/2006/customXml" ds:itemID="{E21AFCC0-734A-4A90-A597-A1CB34860DCD}">
-  <ds:schemaRefs>
-    <ds:schemaRef ds:uri="http://schemas.microsoft.com/sharepoint/v3/contenttype/forms"/>
-  </ds:schemaRefs>
-</ds:datastoreItem>
-</file>
-
-<file path=customXml/itemProps2.xml><?xml version="1.0" encoding="utf-8"?>
 <ds:datastoreItem xmlns:ds="http://schemas.openxmlformats.org/officeDocument/2006/customXml" ds:itemID="{617AB1FA-2F28-4684-9230-02ACEB6C0B0A}">
   <ds:schemaRefs>
     <ds:schemaRef ds:uri="http://purl.org/dc/elements/1.1/"/>
@@ -7831,6 +6448,14 @@
     <ds:schemaRef ds:uri="http://purl.org/dc/dcmitype/"/>
     <ds:schemaRef ds:uri="http://schemas.microsoft.com/office/infopath/2007/PartnerControls"/>
     <ds:schemaRef ds:uri="http://www.w3.org/XML/1998/namespace"/>
+  </ds:schemaRefs>
+</ds:datastoreItem>
+</file>
+
+<file path=customXml/itemProps2.xml><?xml version="1.0" encoding="utf-8"?>
+<ds:datastoreItem xmlns:ds="http://schemas.openxmlformats.org/officeDocument/2006/customXml" ds:itemID="{E21AFCC0-734A-4A90-A597-A1CB34860DCD}">
+  <ds:schemaRefs>
+    <ds:schemaRef ds:uri="http://schemas.microsoft.com/sharepoint/v3/contenttype/forms"/>
   </ds:schemaRefs>
 </ds:datastoreItem>
 </file>

</xml_diff>

<commit_message>
update: final version of power bi and presentation
</commit_message>
<xml_diff>
--- a/Abschlusspräsentation_MySQL_Frank_Wünsch.pptx
+++ b/Abschlusspräsentation_MySQL_Frank_Wünsch.pptx
@@ -5,7 +5,7 @@
     <p:sldMasterId id="2147483648" r:id="rId4"/>
   </p:sldMasterIdLst>
   <p:notesMasterIdLst>
-    <p:notesMasterId r:id="rId14"/>
+    <p:notesMasterId r:id="rId15"/>
   </p:notesMasterIdLst>
   <p:sldIdLst>
     <p:sldId id="258" r:id="rId5"/>
@@ -17,11 +17,12 @@
     <p:sldId id="264" r:id="rId11"/>
     <p:sldId id="256" r:id="rId12"/>
     <p:sldId id="266" r:id="rId13"/>
+    <p:sldId id="267" r:id="rId14"/>
   </p:sldIdLst>
   <p:sldSz cx="12192000" cy="6858000"/>
   <p:notesSz cx="6858000" cy="9144000"/>
   <p:custDataLst>
-    <p:tags r:id="rId15"/>
+    <p:tags r:id="rId16"/>
   </p:custDataLst>
   <p:defaultTextStyle>
     <a:defPPr>
@@ -183,7 +184,7 @@
             </a:lvl1pPr>
           </a:lstStyle>
           <a:p>
-            <a:endParaRPr lang="de-DE"/>
+            <a:endParaRPr lang="de-DE" dirty="0"/>
           </a:p>
         </p:txBody>
       </p:sp>
@@ -216,9 +217,9 @@
           <a:p>
             <a:fld id="{588604D7-B149-4CBE-B78F-4BADEB5073F2}" type="datetimeFigureOut">
               <a:rPr lang="de-DE" smtClean="0"/>
-              <a:t>31.01.2026</a:t>
+              <a:t>02.02.2026</a:t>
             </a:fld>
-            <a:endParaRPr lang="de-DE"/>
+            <a:endParaRPr lang="de-DE" dirty="0"/>
           </a:p>
         </p:txBody>
       </p:sp>
@@ -251,7 +252,7 @@
           <a:bodyPr vert="horz" lIns="91440" tIns="45720" rIns="91440" bIns="45720" rtlCol="0" anchor="ctr"/>
           <a:lstStyle/>
           <a:p>
-            <a:endParaRPr lang="de-DE"/>
+            <a:endParaRPr lang="de-DE" dirty="0"/>
           </a:p>
         </p:txBody>
       </p:sp>
@@ -341,7 +342,7 @@
             </a:lvl1pPr>
           </a:lstStyle>
           <a:p>
-            <a:endParaRPr lang="de-DE"/>
+            <a:endParaRPr lang="de-DE" dirty="0"/>
           </a:p>
         </p:txBody>
       </p:sp>
@@ -376,7 +377,7 @@
               <a:rPr lang="de-DE" smtClean="0"/>
               <a:t>‹Nr.›</a:t>
             </a:fld>
-            <a:endParaRPr lang="de-DE"/>
+            <a:endParaRPr lang="de-DE" dirty="0"/>
           </a:p>
         </p:txBody>
       </p:sp>
@@ -513,7 +514,7 @@
             <a:spLocks noGrp="1"/>
           </p:cNvSpPr>
           <p:nvPr>
-            <p:ph type="ctrTitle"/>
+            <p:ph type="ctrTitle" hasCustomPrompt="1"/>
           </p:nvPr>
         </p:nvSpPr>
         <p:spPr>
@@ -526,12 +527,16 @@
           <a:bodyPr anchor="b"/>
           <a:lstStyle>
             <a:lvl1pPr algn="ctr">
-              <a:defRPr sz="6000"/>
+              <a:defRPr sz="6000">
+                <a:solidFill>
+                  <a:srgbClr val="FF994E"/>
+                </a:solidFill>
+              </a:defRPr>
             </a:lvl1pPr>
           </a:lstStyle>
           <a:p>
             <a:r>
-              <a:rPr lang="en-US"/>
+              <a:rPr lang="en-US" dirty="0"/>
               <a:t>Click to edit Master title style</a:t>
             </a:r>
           </a:p>
@@ -550,7 +555,7 @@
             <a:spLocks noGrp="1"/>
           </p:cNvSpPr>
           <p:nvPr>
-            <p:ph type="subTitle" idx="1"/>
+            <p:ph type="subTitle" idx="1" hasCustomPrompt="1"/>
           </p:nvPr>
         </p:nvSpPr>
         <p:spPr>
@@ -564,7 +569,11 @@
           <a:lstStyle>
             <a:lvl1pPr marL="0" indent="0" algn="ctr">
               <a:buNone/>
-              <a:defRPr sz="2400"/>
+              <a:defRPr sz="2400">
+                <a:solidFill>
+                  <a:srgbClr val="FFB57D"/>
+                </a:solidFill>
+              </a:defRPr>
             </a:lvl1pPr>
             <a:lvl2pPr marL="457200" indent="0" algn="ctr">
               <a:buNone/>
@@ -601,7 +610,7 @@
           </a:lstStyle>
           <a:p>
             <a:r>
-              <a:rPr lang="en-US"/>
+              <a:rPr lang="en-US" dirty="0"/>
               <a:t>Click to edit Master subtitle style</a:t>
             </a:r>
           </a:p>
@@ -630,9 +639,9 @@
           <a:p>
             <a:fld id="{9B7052B1-BD61-421F-A1DA-FDD7F43536D7}" type="datetime1">
               <a:rPr lang="de-DE" smtClean="0"/>
-              <a:t>31.01.2026</a:t>
+              <a:t>02.02.2026</a:t>
             </a:fld>
-            <a:endParaRPr lang="en-US"/>
+            <a:endParaRPr lang="en-US" dirty="0"/>
           </a:p>
         </p:txBody>
       </p:sp>
@@ -658,7 +667,7 @@
           <a:lstStyle/>
           <a:p>
             <a:r>
-              <a:rPr lang="en-US"/>
+              <a:rPr lang="en-US" dirty="0"/>
               <a:t>Abschlussarbeit MySQL - Frank Wünsch</a:t>
             </a:r>
           </a:p>
@@ -689,7 +698,7 @@
               <a:rPr lang="en-US" smtClean="0"/>
               <a:t>‹Nr.›</a:t>
             </a:fld>
-            <a:endParaRPr lang="en-US"/>
+            <a:endParaRPr lang="en-US" dirty="0"/>
           </a:p>
         </p:txBody>
       </p:sp>
@@ -736,16 +745,24 @@
             <a:spLocks noGrp="1"/>
           </p:cNvSpPr>
           <p:nvPr>
-            <p:ph type="title"/>
-          </p:nvPr>
-        </p:nvSpPr>
-        <p:spPr/>
-        <p:txBody>
-          <a:bodyPr/>
-          <a:lstStyle/>
-          <a:p>
-            <a:r>
-              <a:rPr lang="en-US"/>
+            <p:ph type="title" hasCustomPrompt="1"/>
+          </p:nvPr>
+        </p:nvSpPr>
+        <p:spPr/>
+        <p:txBody>
+          <a:bodyPr/>
+          <a:lstStyle>
+            <a:lvl1pPr>
+              <a:defRPr>
+                <a:solidFill>
+                  <a:srgbClr val="FF994E"/>
+                </a:solidFill>
+              </a:defRPr>
+            </a:lvl1pPr>
+          </a:lstStyle>
+          <a:p>
+            <a:r>
+              <a:rPr lang="en-US" dirty="0"/>
               <a:t>Click to edit Master title style</a:t>
             </a:r>
           </a:p>
@@ -774,35 +791,35 @@
           <a:p>
             <a:pPr lvl="0"/>
             <a:r>
-              <a:rPr lang="en-US"/>
+              <a:rPr lang="en-US" dirty="0"/>
               <a:t>Edit Master text styles</a:t>
             </a:r>
           </a:p>
           <a:p>
             <a:pPr lvl="1"/>
             <a:r>
-              <a:rPr lang="en-US"/>
+              <a:rPr lang="en-US" dirty="0"/>
               <a:t>Second level</a:t>
             </a:r>
           </a:p>
           <a:p>
             <a:pPr lvl="2"/>
             <a:r>
-              <a:rPr lang="en-US"/>
+              <a:rPr lang="en-US" dirty="0"/>
               <a:t>Third level</a:t>
             </a:r>
           </a:p>
           <a:p>
             <a:pPr lvl="3"/>
             <a:r>
-              <a:rPr lang="en-US"/>
+              <a:rPr lang="en-US" dirty="0"/>
               <a:t>Fourth level</a:t>
             </a:r>
           </a:p>
           <a:p>
             <a:pPr lvl="4"/>
             <a:r>
-              <a:rPr lang="en-US"/>
+              <a:rPr lang="en-US" dirty="0"/>
               <a:t>Fifth level</a:t>
             </a:r>
           </a:p>
@@ -831,9 +848,9 @@
           <a:p>
             <a:fld id="{CD6BEBE4-4FCC-4EA8-BDD5-5B3DAC9ABBD4}" type="datetime1">
               <a:rPr lang="de-DE" smtClean="0"/>
-              <a:t>31.01.2026</a:t>
+              <a:t>02.02.2026</a:t>
             </a:fld>
-            <a:endParaRPr lang="en-US"/>
+            <a:endParaRPr lang="en-US" dirty="0"/>
           </a:p>
         </p:txBody>
       </p:sp>
@@ -859,7 +876,7 @@
           <a:lstStyle/>
           <a:p>
             <a:r>
-              <a:rPr lang="en-US"/>
+              <a:rPr lang="en-US" dirty="0"/>
               <a:t>Abschlussarbeit MySQL - Frank Wünsch</a:t>
             </a:r>
           </a:p>
@@ -890,7 +907,7 @@
               <a:rPr lang="en-US" smtClean="0"/>
               <a:t>‹Nr.›</a:t>
             </a:fld>
-            <a:endParaRPr lang="en-US"/>
+            <a:endParaRPr lang="en-US" dirty="0"/>
           </a:p>
         </p:txBody>
       </p:sp>
@@ -937,7 +954,7 @@
             <a:spLocks noGrp="1"/>
           </p:cNvSpPr>
           <p:nvPr>
-            <p:ph type="title" orient="vert"/>
+            <p:ph type="title" orient="vert" hasCustomPrompt="1"/>
           </p:nvPr>
         </p:nvSpPr>
         <p:spPr>
@@ -948,10 +965,18 @@
         </p:spPr>
         <p:txBody>
           <a:bodyPr vert="eaVert"/>
-          <a:lstStyle/>
-          <a:p>
-            <a:r>
-              <a:rPr lang="en-US"/>
+          <a:lstStyle>
+            <a:lvl1pPr>
+              <a:defRPr>
+                <a:solidFill>
+                  <a:srgbClr val="FF994E"/>
+                </a:solidFill>
+              </a:defRPr>
+            </a:lvl1pPr>
+          </a:lstStyle>
+          <a:p>
+            <a:r>
+              <a:rPr lang="en-US" dirty="0"/>
               <a:t>Click to edit Master title style</a:t>
             </a:r>
           </a:p>
@@ -985,35 +1010,35 @@
           <a:p>
             <a:pPr lvl="0"/>
             <a:r>
-              <a:rPr lang="en-US"/>
+              <a:rPr lang="en-US" dirty="0"/>
               <a:t>Edit Master text styles</a:t>
             </a:r>
           </a:p>
           <a:p>
             <a:pPr lvl="1"/>
             <a:r>
-              <a:rPr lang="en-US"/>
+              <a:rPr lang="en-US" dirty="0"/>
               <a:t>Second level</a:t>
             </a:r>
           </a:p>
           <a:p>
             <a:pPr lvl="2"/>
             <a:r>
-              <a:rPr lang="en-US"/>
+              <a:rPr lang="en-US" dirty="0"/>
               <a:t>Third level</a:t>
             </a:r>
           </a:p>
           <a:p>
             <a:pPr lvl="3"/>
             <a:r>
-              <a:rPr lang="en-US"/>
+              <a:rPr lang="en-US" dirty="0"/>
               <a:t>Fourth level</a:t>
             </a:r>
           </a:p>
           <a:p>
             <a:pPr lvl="4"/>
             <a:r>
-              <a:rPr lang="en-US"/>
+              <a:rPr lang="en-US" dirty="0"/>
               <a:t>Fifth level</a:t>
             </a:r>
           </a:p>
@@ -1042,9 +1067,9 @@
           <a:p>
             <a:fld id="{9F49CD70-EED3-455B-8CC4-948292EB368F}" type="datetime1">
               <a:rPr lang="de-DE" smtClean="0"/>
-              <a:t>31.01.2026</a:t>
+              <a:t>02.02.2026</a:t>
             </a:fld>
-            <a:endParaRPr lang="en-US"/>
+            <a:endParaRPr lang="en-US" dirty="0"/>
           </a:p>
         </p:txBody>
       </p:sp>
@@ -1070,7 +1095,7 @@
           <a:lstStyle/>
           <a:p>
             <a:r>
-              <a:rPr lang="en-US"/>
+              <a:rPr lang="en-US" dirty="0"/>
               <a:t>Abschlussarbeit MySQL - Frank Wünsch</a:t>
             </a:r>
           </a:p>
@@ -1101,7 +1126,7 @@
               <a:rPr lang="en-US" smtClean="0"/>
               <a:t>‹Nr.›</a:t>
             </a:fld>
-            <a:endParaRPr lang="en-US"/>
+            <a:endParaRPr lang="en-US" dirty="0"/>
           </a:p>
         </p:txBody>
       </p:sp>
@@ -1148,16 +1173,24 @@
             <a:spLocks noGrp="1"/>
           </p:cNvSpPr>
           <p:nvPr>
-            <p:ph type="title"/>
-          </p:nvPr>
-        </p:nvSpPr>
-        <p:spPr/>
-        <p:txBody>
-          <a:bodyPr/>
-          <a:lstStyle/>
-          <a:p>
-            <a:r>
-              <a:rPr lang="en-US"/>
+            <p:ph type="title" hasCustomPrompt="1"/>
+          </p:nvPr>
+        </p:nvSpPr>
+        <p:spPr/>
+        <p:txBody>
+          <a:bodyPr/>
+          <a:lstStyle>
+            <a:lvl1pPr>
+              <a:defRPr>
+                <a:solidFill>
+                  <a:srgbClr val="FF994E"/>
+                </a:solidFill>
+              </a:defRPr>
+            </a:lvl1pPr>
+          </a:lstStyle>
+          <a:p>
+            <a:r>
+              <a:rPr lang="en-US" dirty="0"/>
               <a:t>Click to edit Master title style</a:t>
             </a:r>
           </a:p>
@@ -1186,35 +1219,35 @@
           <a:p>
             <a:pPr lvl="0"/>
             <a:r>
-              <a:rPr lang="en-US"/>
+              <a:rPr lang="en-US" dirty="0"/>
               <a:t>Edit Master text styles</a:t>
             </a:r>
           </a:p>
           <a:p>
             <a:pPr lvl="1"/>
             <a:r>
-              <a:rPr lang="en-US"/>
+              <a:rPr lang="en-US" dirty="0"/>
               <a:t>Second level</a:t>
             </a:r>
           </a:p>
           <a:p>
             <a:pPr lvl="2"/>
             <a:r>
-              <a:rPr lang="en-US"/>
+              <a:rPr lang="en-US" dirty="0"/>
               <a:t>Third level</a:t>
             </a:r>
           </a:p>
           <a:p>
             <a:pPr lvl="3"/>
             <a:r>
-              <a:rPr lang="en-US"/>
+              <a:rPr lang="en-US" dirty="0"/>
               <a:t>Fourth level</a:t>
             </a:r>
           </a:p>
           <a:p>
             <a:pPr lvl="4"/>
             <a:r>
-              <a:rPr lang="en-US"/>
+              <a:rPr lang="en-US" dirty="0"/>
               <a:t>Fifth level</a:t>
             </a:r>
           </a:p>
@@ -1243,9 +1276,9 @@
           <a:p>
             <a:fld id="{979AD6E7-A48C-4424-B592-37C7B13B8FC0}" type="datetime1">
               <a:rPr lang="de-DE" smtClean="0"/>
-              <a:t>31.01.2026</a:t>
+              <a:t>02.02.2026</a:t>
             </a:fld>
-            <a:endParaRPr lang="en-US"/>
+            <a:endParaRPr lang="en-US" dirty="0"/>
           </a:p>
         </p:txBody>
       </p:sp>
@@ -1271,7 +1304,7 @@
           <a:lstStyle/>
           <a:p>
             <a:r>
-              <a:rPr lang="en-US"/>
+              <a:rPr lang="en-US" dirty="0"/>
               <a:t>Abschlussarbeit MySQL - Frank Wünsch</a:t>
             </a:r>
           </a:p>
@@ -1302,7 +1335,7 @@
               <a:rPr lang="en-US" smtClean="0"/>
               <a:t>‹Nr.›</a:t>
             </a:fld>
-            <a:endParaRPr lang="en-US"/>
+            <a:endParaRPr lang="en-US" dirty="0"/>
           </a:p>
         </p:txBody>
       </p:sp>
@@ -1349,7 +1382,7 @@
             <a:spLocks noGrp="1"/>
           </p:cNvSpPr>
           <p:nvPr>
-            <p:ph type="title"/>
+            <p:ph type="title" hasCustomPrompt="1"/>
           </p:nvPr>
         </p:nvSpPr>
         <p:spPr>
@@ -1362,12 +1395,16 @@
           <a:bodyPr anchor="b"/>
           <a:lstStyle>
             <a:lvl1pPr>
-              <a:defRPr sz="6000"/>
+              <a:defRPr sz="6000">
+                <a:solidFill>
+                  <a:srgbClr val="FF994E"/>
+                </a:solidFill>
+              </a:defRPr>
             </a:lvl1pPr>
           </a:lstStyle>
           <a:p>
             <a:r>
-              <a:rPr lang="en-US"/>
+              <a:rPr lang="en-US" dirty="0"/>
               <a:t>Click to edit Master title style</a:t>
             </a:r>
           </a:p>
@@ -1521,9 +1558,9 @@
           <a:p>
             <a:fld id="{ACB38205-406A-4507-9625-45CB6BE1106E}" type="datetime1">
               <a:rPr lang="de-DE" smtClean="0"/>
-              <a:t>31.01.2026</a:t>
+              <a:t>02.02.2026</a:t>
             </a:fld>
-            <a:endParaRPr lang="en-US"/>
+            <a:endParaRPr lang="en-US" dirty="0"/>
           </a:p>
         </p:txBody>
       </p:sp>
@@ -1549,7 +1586,7 @@
           <a:lstStyle/>
           <a:p>
             <a:r>
-              <a:rPr lang="en-US"/>
+              <a:rPr lang="en-US" dirty="0"/>
               <a:t>Abschlussarbeit MySQL - Frank Wünsch</a:t>
             </a:r>
           </a:p>
@@ -1580,7 +1617,7 @@
               <a:rPr lang="en-US" smtClean="0"/>
               <a:t>‹Nr.›</a:t>
             </a:fld>
-            <a:endParaRPr lang="en-US"/>
+            <a:endParaRPr lang="en-US" dirty="0"/>
           </a:p>
         </p:txBody>
       </p:sp>
@@ -1627,16 +1664,24 @@
             <a:spLocks noGrp="1"/>
           </p:cNvSpPr>
           <p:nvPr>
-            <p:ph type="title"/>
-          </p:nvPr>
-        </p:nvSpPr>
-        <p:spPr/>
-        <p:txBody>
-          <a:bodyPr/>
-          <a:lstStyle/>
-          <a:p>
-            <a:r>
-              <a:rPr lang="en-US"/>
+            <p:ph type="title" hasCustomPrompt="1"/>
+          </p:nvPr>
+        </p:nvSpPr>
+        <p:spPr/>
+        <p:txBody>
+          <a:bodyPr/>
+          <a:lstStyle>
+            <a:lvl1pPr>
+              <a:defRPr>
+                <a:solidFill>
+                  <a:srgbClr val="FF994E"/>
+                </a:solidFill>
+              </a:defRPr>
+            </a:lvl1pPr>
+          </a:lstStyle>
+          <a:p>
+            <a:r>
+              <a:rPr lang="en-US" dirty="0"/>
               <a:t>Click to edit Master title style</a:t>
             </a:r>
           </a:p>
@@ -1789,9 +1834,9 @@
           <a:p>
             <a:fld id="{BD5A8128-4535-4048-83F7-BDA6F1969AC1}" type="datetime1">
               <a:rPr lang="de-DE" smtClean="0"/>
-              <a:t>31.01.2026</a:t>
+              <a:t>02.02.2026</a:t>
             </a:fld>
-            <a:endParaRPr lang="en-US"/>
+            <a:endParaRPr lang="en-US" dirty="0"/>
           </a:p>
         </p:txBody>
       </p:sp>
@@ -1817,7 +1862,7 @@
           <a:lstStyle/>
           <a:p>
             <a:r>
-              <a:rPr lang="en-US"/>
+              <a:rPr lang="en-US" dirty="0"/>
               <a:t>Abschlussarbeit MySQL - Frank Wünsch</a:t>
             </a:r>
           </a:p>
@@ -1848,7 +1893,7 @@
               <a:rPr lang="en-US" smtClean="0"/>
               <a:t>‹Nr.›</a:t>
             </a:fld>
-            <a:endParaRPr lang="en-US"/>
+            <a:endParaRPr lang="en-US" dirty="0"/>
           </a:p>
         </p:txBody>
       </p:sp>
@@ -1895,7 +1940,7 @@
             <a:spLocks noGrp="1"/>
           </p:cNvSpPr>
           <p:nvPr>
-            <p:ph type="title"/>
+            <p:ph type="title" hasCustomPrompt="1"/>
           </p:nvPr>
         </p:nvSpPr>
         <p:spPr>
@@ -1906,10 +1951,18 @@
         </p:spPr>
         <p:txBody>
           <a:bodyPr/>
-          <a:lstStyle/>
-          <a:p>
-            <a:r>
-              <a:rPr lang="en-US"/>
+          <a:lstStyle>
+            <a:lvl1pPr>
+              <a:defRPr>
+                <a:solidFill>
+                  <a:srgbClr val="FF994E"/>
+                </a:solidFill>
+              </a:defRPr>
+            </a:lvl1pPr>
+          </a:lstStyle>
+          <a:p>
+            <a:r>
+              <a:rPr lang="en-US" dirty="0"/>
               <a:t>Click to edit Master title style</a:t>
             </a:r>
           </a:p>
@@ -2204,9 +2257,9 @@
           <a:p>
             <a:fld id="{5042F379-9101-4C9D-88C3-C7F8A5AF0689}" type="datetime1">
               <a:rPr lang="de-DE" smtClean="0"/>
-              <a:t>31.01.2026</a:t>
+              <a:t>02.02.2026</a:t>
             </a:fld>
-            <a:endParaRPr lang="en-US"/>
+            <a:endParaRPr lang="en-US" dirty="0"/>
           </a:p>
         </p:txBody>
       </p:sp>
@@ -2232,7 +2285,7 @@
           <a:lstStyle/>
           <a:p>
             <a:r>
-              <a:rPr lang="en-US"/>
+              <a:rPr lang="en-US" dirty="0"/>
               <a:t>Abschlussarbeit MySQL - Frank Wünsch</a:t>
             </a:r>
           </a:p>
@@ -2263,7 +2316,7 @@
               <a:rPr lang="en-US" smtClean="0"/>
               <a:t>‹Nr.›</a:t>
             </a:fld>
-            <a:endParaRPr lang="en-US"/>
+            <a:endParaRPr lang="en-US" dirty="0"/>
           </a:p>
         </p:txBody>
       </p:sp>
@@ -2310,16 +2363,24 @@
             <a:spLocks noGrp="1"/>
           </p:cNvSpPr>
           <p:nvPr>
-            <p:ph type="title"/>
-          </p:nvPr>
-        </p:nvSpPr>
-        <p:spPr/>
-        <p:txBody>
-          <a:bodyPr/>
-          <a:lstStyle/>
-          <a:p>
-            <a:r>
-              <a:rPr lang="en-US"/>
+            <p:ph type="title" hasCustomPrompt="1"/>
+          </p:nvPr>
+        </p:nvSpPr>
+        <p:spPr/>
+        <p:txBody>
+          <a:bodyPr/>
+          <a:lstStyle>
+            <a:lvl1pPr>
+              <a:defRPr>
+                <a:solidFill>
+                  <a:srgbClr val="FF994E"/>
+                </a:solidFill>
+              </a:defRPr>
+            </a:lvl1pPr>
+          </a:lstStyle>
+          <a:p>
+            <a:r>
+              <a:rPr lang="en-US" dirty="0"/>
               <a:t>Click to edit Master title style</a:t>
             </a:r>
           </a:p>
@@ -2348,9 +2409,9 @@
           <a:p>
             <a:fld id="{1655DBDF-0D89-4019-8FD6-4FC0A4BF2CB6}" type="datetime1">
               <a:rPr lang="de-DE" smtClean="0"/>
-              <a:t>31.01.2026</a:t>
+              <a:t>02.02.2026</a:t>
             </a:fld>
-            <a:endParaRPr lang="en-US"/>
+            <a:endParaRPr lang="en-US" dirty="0"/>
           </a:p>
         </p:txBody>
       </p:sp>
@@ -2376,7 +2437,7 @@
           <a:lstStyle/>
           <a:p>
             <a:r>
-              <a:rPr lang="en-US"/>
+              <a:rPr lang="en-US" dirty="0"/>
               <a:t>Abschlussarbeit MySQL - Frank Wünsch</a:t>
             </a:r>
           </a:p>
@@ -2407,7 +2468,7 @@
               <a:rPr lang="en-US" smtClean="0"/>
               <a:t>‹Nr.›</a:t>
             </a:fld>
-            <a:endParaRPr lang="en-US"/>
+            <a:endParaRPr lang="en-US" dirty="0"/>
           </a:p>
         </p:txBody>
       </p:sp>
@@ -2464,9 +2525,9 @@
           <a:p>
             <a:fld id="{36A35928-6455-4327-9B81-75CC8615A8CE}" type="datetime1">
               <a:rPr lang="de-DE" smtClean="0"/>
-              <a:t>31.01.2026</a:t>
+              <a:t>02.02.2026</a:t>
             </a:fld>
-            <a:endParaRPr lang="en-US"/>
+            <a:endParaRPr lang="en-US" dirty="0"/>
           </a:p>
         </p:txBody>
       </p:sp>
@@ -2492,7 +2553,7 @@
           <a:lstStyle/>
           <a:p>
             <a:r>
-              <a:rPr lang="en-US"/>
+              <a:rPr lang="en-US" dirty="0"/>
               <a:t>Abschlussarbeit MySQL - Frank Wünsch</a:t>
             </a:r>
           </a:p>
@@ -2523,7 +2584,7 @@
               <a:rPr lang="en-US" smtClean="0"/>
               <a:t>‹Nr.›</a:t>
             </a:fld>
-            <a:endParaRPr lang="en-US"/>
+            <a:endParaRPr lang="en-US" dirty="0"/>
           </a:p>
         </p:txBody>
       </p:sp>
@@ -2570,7 +2631,7 @@
             <a:spLocks noGrp="1"/>
           </p:cNvSpPr>
           <p:nvPr>
-            <p:ph type="title"/>
+            <p:ph type="title" hasCustomPrompt="1"/>
           </p:nvPr>
         </p:nvSpPr>
         <p:spPr>
@@ -2583,12 +2644,16 @@
           <a:bodyPr anchor="b"/>
           <a:lstStyle>
             <a:lvl1pPr>
-              <a:defRPr sz="3200"/>
+              <a:defRPr sz="3200">
+                <a:solidFill>
+                  <a:srgbClr val="FF994E"/>
+                </a:solidFill>
+              </a:defRPr>
             </a:lvl1pPr>
           </a:lstStyle>
           <a:p>
             <a:r>
-              <a:rPr lang="en-US"/>
+              <a:rPr lang="en-US" dirty="0"/>
               <a:t>Click to edit Master title style</a:t>
             </a:r>
           </a:p>
@@ -2778,9 +2843,9 @@
           <a:p>
             <a:fld id="{F77A4E6B-3535-47A9-9B19-077E52398501}" type="datetime1">
               <a:rPr lang="de-DE" smtClean="0"/>
-              <a:t>31.01.2026</a:t>
+              <a:t>02.02.2026</a:t>
             </a:fld>
-            <a:endParaRPr lang="en-US"/>
+            <a:endParaRPr lang="en-US" dirty="0"/>
           </a:p>
         </p:txBody>
       </p:sp>
@@ -2806,7 +2871,7 @@
           <a:lstStyle/>
           <a:p>
             <a:r>
-              <a:rPr lang="en-US"/>
+              <a:rPr lang="en-US" dirty="0"/>
               <a:t>Abschlussarbeit MySQL - Frank Wünsch</a:t>
             </a:r>
           </a:p>
@@ -2837,7 +2902,7 @@
               <a:rPr lang="en-US" smtClean="0"/>
               <a:t>‹Nr.›</a:t>
             </a:fld>
-            <a:endParaRPr lang="en-US"/>
+            <a:endParaRPr lang="en-US" dirty="0"/>
           </a:p>
         </p:txBody>
       </p:sp>
@@ -2884,7 +2949,7 @@
             <a:spLocks noGrp="1"/>
           </p:cNvSpPr>
           <p:nvPr>
-            <p:ph type="title"/>
+            <p:ph type="title" hasCustomPrompt="1"/>
           </p:nvPr>
         </p:nvSpPr>
         <p:spPr>
@@ -2897,12 +2962,16 @@
           <a:bodyPr anchor="b"/>
           <a:lstStyle>
             <a:lvl1pPr>
-              <a:defRPr sz="3200"/>
+              <a:defRPr sz="3200">
+                <a:solidFill>
+                  <a:srgbClr val="FF994E"/>
+                </a:solidFill>
+              </a:defRPr>
             </a:lvl1pPr>
           </a:lstStyle>
           <a:p>
             <a:r>
-              <a:rPr lang="en-US"/>
+              <a:rPr lang="en-US" dirty="0"/>
               <a:t>Click to edit Master title style</a:t>
             </a:r>
           </a:p>
@@ -2971,7 +3040,7 @@
             </a:lvl9pPr>
           </a:lstStyle>
           <a:p>
-            <a:endParaRPr lang="en-US"/>
+            <a:endParaRPr lang="en-US" dirty="0"/>
           </a:p>
         </p:txBody>
       </p:sp>
@@ -3069,9 +3138,9 @@
           <a:p>
             <a:fld id="{64E1626F-68EC-4B02-AD8D-2E5F851E62A0}" type="datetime1">
               <a:rPr lang="de-DE" smtClean="0"/>
-              <a:t>31.01.2026</a:t>
+              <a:t>02.02.2026</a:t>
             </a:fld>
-            <a:endParaRPr lang="en-US"/>
+            <a:endParaRPr lang="en-US" dirty="0"/>
           </a:p>
         </p:txBody>
       </p:sp>
@@ -3097,7 +3166,7 @@
           <a:lstStyle/>
           <a:p>
             <a:r>
-              <a:rPr lang="en-US"/>
+              <a:rPr lang="en-US" dirty="0"/>
               <a:t>Abschlussarbeit MySQL - Frank Wünsch</a:t>
             </a:r>
           </a:p>
@@ -3128,7 +3197,7 @@
               <a:rPr lang="en-US" smtClean="0"/>
               <a:t>‹Nr.›</a:t>
             </a:fld>
-            <a:endParaRPr lang="en-US"/>
+            <a:endParaRPr lang="en-US" dirty="0"/>
           </a:p>
         </p:txBody>
       </p:sp>
@@ -3199,7 +3268,7 @@
           <a:lstStyle/>
           <a:p>
             <a:r>
-              <a:rPr lang="en-US"/>
+              <a:rPr lang="en-US" dirty="0"/>
               <a:t>Click to edit Master title style</a:t>
             </a:r>
           </a:p>
@@ -3238,35 +3307,35 @@
           <a:p>
             <a:pPr lvl="0"/>
             <a:r>
-              <a:rPr lang="en-US"/>
+              <a:rPr lang="en-US" dirty="0"/>
               <a:t>Edit Master text styles</a:t>
             </a:r>
           </a:p>
           <a:p>
             <a:pPr lvl="1"/>
             <a:r>
-              <a:rPr lang="en-US"/>
+              <a:rPr lang="en-US" dirty="0"/>
               <a:t>Second level</a:t>
             </a:r>
           </a:p>
           <a:p>
             <a:pPr lvl="2"/>
             <a:r>
-              <a:rPr lang="en-US"/>
+              <a:rPr lang="en-US" dirty="0"/>
               <a:t>Third level</a:t>
             </a:r>
           </a:p>
           <a:p>
             <a:pPr lvl="3"/>
             <a:r>
-              <a:rPr lang="en-US"/>
+              <a:rPr lang="en-US" dirty="0"/>
               <a:t>Fourth level</a:t>
             </a:r>
           </a:p>
           <a:p>
             <a:pPr lvl="4"/>
             <a:r>
-              <a:rPr lang="en-US"/>
+              <a:rPr lang="en-US" dirty="0"/>
               <a:t>Fifth level</a:t>
             </a:r>
           </a:p>
@@ -3313,9 +3382,9 @@
           <a:p>
             <a:fld id="{B53B0A0C-0502-4005-9A69-FFD78D14F989}" type="datetime1">
               <a:rPr lang="de-DE" smtClean="0"/>
-              <a:t>31.01.2026</a:t>
+              <a:t>02.02.2026</a:t>
             </a:fld>
-            <a:endParaRPr lang="en-US"/>
+            <a:endParaRPr lang="en-US" dirty="0"/>
           </a:p>
         </p:txBody>
       </p:sp>
@@ -3359,7 +3428,7 @@
           </a:lstStyle>
           <a:p>
             <a:r>
-              <a:rPr lang="en-US"/>
+              <a:rPr lang="en-US" dirty="0"/>
               <a:t>Abschlussarbeit MySQL - Frank Wünsch</a:t>
             </a:r>
           </a:p>
@@ -3408,7 +3477,7 @@
               <a:rPr lang="en-US" smtClean="0"/>
               <a:t>‹Nr.›</a:t>
             </a:fld>
-            <a:endParaRPr lang="en-US"/>
+            <a:endParaRPr lang="en-US" dirty="0"/>
           </a:p>
         </p:txBody>
       </p:sp>
@@ -3446,7 +3515,7 @@
         <a:buNone/>
         <a:defRPr sz="4400" kern="1200">
           <a:solidFill>
-            <a:schemeClr val="tx1"/>
+            <a:srgbClr val="FC9E14"/>
           </a:solidFill>
           <a:latin typeface="+mj-lt"/>
           <a:ea typeface="+mj-ea"/>
@@ -3795,16 +3864,14 @@
           <a:bodyPr/>
           <a:lstStyle/>
           <a:p>
-            <a:r>
-              <a:rPr lang="de-DE" dirty="0"/>
-              <a:t>Im Auftrag von</a:t>
-            </a:r>
-          </a:p>
-          <a:p>
-            <a:r>
-              <a:rPr lang="de-DE" sz="3200" dirty="0"/>
-              <a:t>Data Smart Point GmbH</a:t>
-            </a:r>
+            <a:endParaRPr lang="de-DE" sz="1400" dirty="0">
+              <a:solidFill>
+                <a:schemeClr val="tx1">
+                  <a:lumMod val="50000"/>
+                  <a:lumOff val="50000"/>
+                </a:schemeClr>
+              </a:solidFill>
+            </a:endParaRPr>
           </a:p>
           <a:p>
             <a:r>
@@ -3861,6 +3928,238 @@
     <p:extLst>
       <p:ext uri="{BB962C8B-B14F-4D97-AF65-F5344CB8AC3E}">
         <p14:creationId xmlns:p14="http://schemas.microsoft.com/office/powerpoint/2010/main" val="4252583647"/>
+      </p:ext>
+    </p:extLst>
+  </p:cSld>
+  <p:clrMapOvr>
+    <a:masterClrMapping/>
+  </p:clrMapOvr>
+</p:sld>
+</file>
+
+<file path=ppt/slides/slide10.xml><?xml version="1.0" encoding="utf-8"?>
+<p:sld xmlns:a="http://schemas.openxmlformats.org/drawingml/2006/main" xmlns:r="http://schemas.openxmlformats.org/officeDocument/2006/relationships" xmlns:p="http://schemas.openxmlformats.org/presentationml/2006/main">
+  <p:cSld>
+    <p:spTree>
+      <p:nvGrpSpPr>
+        <p:cNvPr id="1" name=""/>
+        <p:cNvGrpSpPr/>
+        <p:nvPr/>
+      </p:nvGrpSpPr>
+      <p:grpSpPr>
+        <a:xfrm>
+          <a:off x="0" y="0"/>
+          <a:ext cx="0" cy="0"/>
+          <a:chOff x="0" y="0"/>
+          <a:chExt cx="0" cy="0"/>
+        </a:xfrm>
+      </p:grpSpPr>
+      <p:sp>
+        <p:nvSpPr>
+          <p:cNvPr id="2" name="Titel 1">
+            <a:extLst>
+              <a:ext uri="{FF2B5EF4-FFF2-40B4-BE49-F238E27FC236}">
+                <a16:creationId xmlns:a16="http://schemas.microsoft.com/office/drawing/2014/main" id="{4C713F6D-A6FE-3D8E-5E3C-891573451BE3}"/>
+              </a:ext>
+            </a:extLst>
+          </p:cNvPr>
+          <p:cNvSpPr>
+            <a:spLocks noGrp="1"/>
+          </p:cNvSpPr>
+          <p:nvPr>
+            <p:ph type="title"/>
+          </p:nvPr>
+        </p:nvSpPr>
+        <p:spPr/>
+        <p:txBody>
+          <a:bodyPr/>
+          <a:lstStyle/>
+          <a:p>
+            <a:pPr algn="ctr"/>
+            <a:r>
+              <a:rPr lang="de-DE" dirty="0"/>
+              <a:t>Vielen Dank für die Aufmerksamkeit</a:t>
+            </a:r>
+          </a:p>
+        </p:txBody>
+      </p:sp>
+      <p:sp>
+        <p:nvSpPr>
+          <p:cNvPr id="4" name="Datumsplatzhalter 3">
+            <a:extLst>
+              <a:ext uri="{FF2B5EF4-FFF2-40B4-BE49-F238E27FC236}">
+                <a16:creationId xmlns:a16="http://schemas.microsoft.com/office/drawing/2014/main" id="{260D54EE-9129-DB2C-393C-6108FC85783B}"/>
+              </a:ext>
+            </a:extLst>
+          </p:cNvPr>
+          <p:cNvSpPr>
+            <a:spLocks noGrp="1"/>
+          </p:cNvSpPr>
+          <p:nvPr>
+            <p:ph type="dt" sz="half" idx="10"/>
+          </p:nvPr>
+        </p:nvSpPr>
+        <p:spPr/>
+        <p:txBody>
+          <a:bodyPr/>
+          <a:lstStyle/>
+          <a:p>
+            <a:fld id="{979AD6E7-A48C-4424-B592-37C7B13B8FC0}" type="datetime1">
+              <a:rPr lang="de-DE" smtClean="0"/>
+              <a:t>02.02.2026</a:t>
+            </a:fld>
+            <a:endParaRPr lang="en-US" dirty="0"/>
+          </a:p>
+        </p:txBody>
+      </p:sp>
+      <p:sp>
+        <p:nvSpPr>
+          <p:cNvPr id="5" name="Fußzeilenplatzhalter 4">
+            <a:extLst>
+              <a:ext uri="{FF2B5EF4-FFF2-40B4-BE49-F238E27FC236}">
+                <a16:creationId xmlns:a16="http://schemas.microsoft.com/office/drawing/2014/main" id="{B7826D1E-D36C-4163-B620-71CE89CBC8C6}"/>
+              </a:ext>
+            </a:extLst>
+          </p:cNvPr>
+          <p:cNvSpPr>
+            <a:spLocks noGrp="1"/>
+          </p:cNvSpPr>
+          <p:nvPr>
+            <p:ph type="ftr" sz="quarter" idx="11"/>
+          </p:nvPr>
+        </p:nvSpPr>
+        <p:spPr/>
+        <p:txBody>
+          <a:bodyPr/>
+          <a:lstStyle/>
+          <a:p>
+            <a:r>
+              <a:rPr lang="en-US" dirty="0"/>
+              <a:t>Abschlussarbeit MySQL - Frank Wünsch</a:t>
+            </a:r>
+          </a:p>
+        </p:txBody>
+      </p:sp>
+      <p:sp>
+        <p:nvSpPr>
+          <p:cNvPr id="6" name="Foliennummernplatzhalter 5">
+            <a:extLst>
+              <a:ext uri="{FF2B5EF4-FFF2-40B4-BE49-F238E27FC236}">
+                <a16:creationId xmlns:a16="http://schemas.microsoft.com/office/drawing/2014/main" id="{4F8798F6-4076-A8A2-2832-456894E9907C}"/>
+              </a:ext>
+            </a:extLst>
+          </p:cNvPr>
+          <p:cNvSpPr>
+            <a:spLocks noGrp="1"/>
+          </p:cNvSpPr>
+          <p:nvPr>
+            <p:ph type="sldNum" sz="quarter" idx="12"/>
+          </p:nvPr>
+        </p:nvSpPr>
+        <p:spPr/>
+        <p:txBody>
+          <a:bodyPr/>
+          <a:lstStyle/>
+          <a:p>
+            <a:fld id="{8E05DC9C-C50D-D242-B083-59CEE07163F1}" type="slidenum">
+              <a:rPr lang="en-US" smtClean="0"/>
+              <a:t>10</a:t>
+            </a:fld>
+            <a:endParaRPr lang="en-US" dirty="0"/>
+          </a:p>
+        </p:txBody>
+      </p:sp>
+      <p:grpSp>
+        <p:nvGrpSpPr>
+          <p:cNvPr id="21" name="Gruppieren 20">
+            <a:extLst>
+              <a:ext uri="{FF2B5EF4-FFF2-40B4-BE49-F238E27FC236}">
+                <a16:creationId xmlns:a16="http://schemas.microsoft.com/office/drawing/2014/main" id="{37FE0CB6-59C4-A1BB-1E0F-35D3FE4FC868}"/>
+              </a:ext>
+            </a:extLst>
+          </p:cNvPr>
+          <p:cNvGrpSpPr/>
+          <p:nvPr/>
+        </p:nvGrpSpPr>
+        <p:grpSpPr>
+          <a:xfrm>
+            <a:off x="2063345" y="1690688"/>
+            <a:ext cx="8065310" cy="4381500"/>
+            <a:chOff x="838199" y="1623217"/>
+            <a:chExt cx="8065310" cy="4381500"/>
+          </a:xfrm>
+        </p:grpSpPr>
+        <p:pic>
+          <p:nvPicPr>
+            <p:cNvPr id="12" name="Grafik 11" descr="Junger Geschäftsmann schreibt auf Notepad">
+              <a:extLst>
+                <a:ext uri="{FF2B5EF4-FFF2-40B4-BE49-F238E27FC236}">
+                  <a16:creationId xmlns:a16="http://schemas.microsoft.com/office/drawing/2014/main" id="{BB9B5DF9-AF96-E207-E90E-6A7FBE1EFFC3}"/>
+                </a:ext>
+              </a:extLst>
+            </p:cNvPr>
+            <p:cNvPicPr>
+              <a:picLocks noChangeAspect="1"/>
+            </p:cNvPicPr>
+            <p:nvPr/>
+          </p:nvPicPr>
+          <p:blipFill>
+            <a:blip r:embed="rId2"/>
+            <a:stretch>
+              <a:fillRect/>
+            </a:stretch>
+          </p:blipFill>
+          <p:spPr>
+            <a:xfrm>
+              <a:off x="7527114" y="1623217"/>
+              <a:ext cx="1376395" cy="4381500"/>
+            </a:xfrm>
+            <a:prstGeom prst="rect">
+              <a:avLst/>
+            </a:prstGeom>
+          </p:spPr>
+        </p:pic>
+        <p:pic>
+          <p:nvPicPr>
+            <p:cNvPr id="18" name="Grafik 17" descr="Fragen mit einfarbiger Füllung">
+              <a:extLst>
+                <a:ext uri="{FF2B5EF4-FFF2-40B4-BE49-F238E27FC236}">
+                  <a16:creationId xmlns:a16="http://schemas.microsoft.com/office/drawing/2014/main" id="{51EBC60E-CD38-08FE-197E-9B75D8BB3A0B}"/>
+                </a:ext>
+              </a:extLst>
+            </p:cNvPr>
+            <p:cNvPicPr>
+              <a:picLocks noChangeAspect="1"/>
+            </p:cNvPicPr>
+            <p:nvPr/>
+          </p:nvPicPr>
+          <p:blipFill>
+            <a:blip r:embed="rId3">
+              <a:extLst>
+                <a:ext uri="{96DAC541-7B7A-43D3-8B79-37D633B846F1}">
+                  <asvg:svgBlip xmlns:asvg="http://schemas.microsoft.com/office/drawing/2016/SVG/main" r:embed="rId4"/>
+                </a:ext>
+              </a:extLst>
+            </a:blip>
+            <a:stretch>
+              <a:fillRect/>
+            </a:stretch>
+          </p:blipFill>
+          <p:spPr>
+            <a:xfrm>
+              <a:off x="838199" y="1694655"/>
+              <a:ext cx="4238625" cy="4238625"/>
+            </a:xfrm>
+            <a:prstGeom prst="rect">
+              <a:avLst/>
+            </a:prstGeom>
+          </p:spPr>
+        </p:pic>
+      </p:grpSp>
+    </p:spTree>
+    <p:extLst>
+      <p:ext uri="{BB962C8B-B14F-4D97-AF65-F5344CB8AC3E}">
+        <p14:creationId xmlns:p14="http://schemas.microsoft.com/office/powerpoint/2010/main" val="1429014855"/>
       </p:ext>
     </p:extLst>
   </p:cSld>
@@ -4020,9 +4319,9 @@
           <a:p>
             <a:fld id="{3B7D17E4-C383-4D8C-9298-0702EEB52F70}" type="datetime1">
               <a:rPr lang="de-DE" smtClean="0"/>
-              <a:t>31.01.2026</a:t>
+              <a:t>02.02.2026</a:t>
             </a:fld>
-            <a:endParaRPr lang="en-US"/>
+            <a:endParaRPr lang="en-US" dirty="0"/>
           </a:p>
         </p:txBody>
       </p:sp>
@@ -4048,10 +4347,9 @@
           <a:lstStyle/>
           <a:p>
             <a:r>
-              <a:rPr lang="en-US"/>
+              <a:rPr lang="en-US" dirty="0"/>
               <a:t>Abschlussarbeit MySQL - Frank Wünsch</a:t>
             </a:r>
-            <a:endParaRPr lang="en-US" dirty="0"/>
           </a:p>
         </p:txBody>
       </p:sp>
@@ -4180,19 +4478,7 @@
               <a:rPr lang="de-DE" dirty="0">
                 <a:hlinkClick r:id="rId2"/>
               </a:rPr>
-              <a:t>World </a:t>
-            </a:r>
-            <a:r>
-              <a:rPr lang="de-DE" dirty="0" err="1">
-                <a:hlinkClick r:id="rId2"/>
-              </a:rPr>
-              <a:t>Weather</a:t>
-            </a:r>
-            <a:r>
-              <a:rPr lang="de-DE" dirty="0">
-                <a:hlinkClick r:id="rId2"/>
-              </a:rPr>
-              <a:t> Repository</a:t>
+              <a:t>World Weather Repository</a:t>
             </a:r>
             <a:r>
               <a:rPr lang="de-DE" dirty="0"/>
@@ -4266,9 +4552,9 @@
           <a:p>
             <a:fld id="{979AD6E7-A48C-4424-B592-37C7B13B8FC0}" type="datetime1">
               <a:rPr lang="de-DE" smtClean="0"/>
-              <a:t>31.01.2026</a:t>
+              <a:t>02.02.2026</a:t>
             </a:fld>
-            <a:endParaRPr lang="en-US"/>
+            <a:endParaRPr lang="en-US" dirty="0"/>
           </a:p>
         </p:txBody>
       </p:sp>
@@ -4294,7 +4580,7 @@
           <a:lstStyle/>
           <a:p>
             <a:r>
-              <a:rPr lang="en-US"/>
+              <a:rPr lang="en-US" dirty="0"/>
               <a:t>Abschlussarbeit MySQL - Frank Wünsch</a:t>
             </a:r>
           </a:p>
@@ -4325,7 +4611,7 @@
               <a:rPr lang="en-US" smtClean="0"/>
               <a:t>3</a:t>
             </a:fld>
-            <a:endParaRPr lang="en-US"/>
+            <a:endParaRPr lang="en-US" dirty="0"/>
           </a:p>
         </p:txBody>
       </p:sp>
@@ -4410,9 +4696,9 @@
           <a:p>
             <a:fld id="{979AD6E7-A48C-4424-B592-37C7B13B8FC0}" type="datetime1">
               <a:rPr lang="de-DE" smtClean="0"/>
-              <a:t>31.01.2026</a:t>
+              <a:t>02.02.2026</a:t>
             </a:fld>
-            <a:endParaRPr lang="en-US"/>
+            <a:endParaRPr lang="en-US" dirty="0"/>
           </a:p>
         </p:txBody>
       </p:sp>
@@ -4438,7 +4724,7 @@
           <a:lstStyle/>
           <a:p>
             <a:r>
-              <a:rPr lang="en-US"/>
+              <a:rPr lang="en-US" dirty="0"/>
               <a:t>Abschlussarbeit MySQL - Frank Wünsch</a:t>
             </a:r>
           </a:p>
@@ -4469,7 +4755,7 @@
               <a:rPr lang="en-US" smtClean="0"/>
               <a:t>4</a:t>
             </a:fld>
-            <a:endParaRPr lang="en-US"/>
+            <a:endParaRPr lang="en-US" dirty="0"/>
           </a:p>
         </p:txBody>
       </p:sp>
@@ -4586,7 +4872,16 @@
               <a:buNone/>
             </a:pPr>
             <a:r>
-              <a:rPr lang="de-DE" i="1" dirty="0"/>
+              <a:rPr lang="de-DE" i="1" dirty="0">
+                <a:ln>
+                  <a:solidFill>
+                    <a:srgbClr val="FF994E"/>
+                  </a:solidFill>
+                </a:ln>
+                <a:solidFill>
+                  <a:srgbClr val="FFB57D"/>
+                </a:solidFill>
+              </a:rPr>
               <a:t>Regionale und saisonale Auffälligkeiten in Deutschland</a:t>
             </a:r>
           </a:p>
@@ -4612,7 +4907,16 @@
               <a:buNone/>
             </a:pPr>
             <a:r>
-              <a:rPr lang="de-DE" i="1" dirty="0"/>
+              <a:rPr lang="de-DE" i="1" dirty="0">
+                <a:ln>
+                  <a:solidFill>
+                    <a:srgbClr val="FF994E"/>
+                  </a:solidFill>
+                </a:ln>
+                <a:solidFill>
+                  <a:srgbClr val="FFB57D"/>
+                </a:solidFill>
+              </a:rPr>
               <a:t>Globale &amp; Extremwetter orientierte Analysen</a:t>
             </a:r>
           </a:p>
@@ -4623,15 +4927,7 @@
             </a:pPr>
             <a:r>
               <a:rPr lang="de-DE" dirty="0"/>
-              <a:t>Welche Orte weltweit weisen extreme Temperatur- und Luft-</a:t>
-            </a:r>
-            <a:r>
-              <a:rPr lang="de-DE" dirty="0" err="1"/>
-              <a:t>verschmutzungsprofile</a:t>
-            </a:r>
-            <a:r>
-              <a:rPr lang="de-DE" dirty="0"/>
-              <a:t> auf und welche Wetterfaktoren stehen damit in Zusammenhang?</a:t>
+              <a:t>Welche Orte weltweit weisen extreme Temperatur- und Luft-verschmutzungsprofile auf und welche Wetterfaktoren stehen damit in Zusammenhang?</a:t>
             </a:r>
           </a:p>
         </p:txBody>
@@ -4659,9 +4955,9 @@
           <a:p>
             <a:fld id="{979AD6E7-A48C-4424-B592-37C7B13B8FC0}" type="datetime1">
               <a:rPr lang="de-DE" smtClean="0"/>
-              <a:t>31.01.2026</a:t>
+              <a:t>02.02.2026</a:t>
             </a:fld>
-            <a:endParaRPr lang="en-US"/>
+            <a:endParaRPr lang="en-US" dirty="0"/>
           </a:p>
         </p:txBody>
       </p:sp>
@@ -4687,7 +4983,7 @@
           <a:lstStyle/>
           <a:p>
             <a:r>
-              <a:rPr lang="en-US"/>
+              <a:rPr lang="en-US" dirty="0"/>
               <a:t>Abschlussarbeit MySQL - Frank Wünsch</a:t>
             </a:r>
           </a:p>
@@ -4718,10 +5014,46 @@
               <a:rPr lang="en-US" smtClean="0"/>
               <a:t>5</a:t>
             </a:fld>
-            <a:endParaRPr lang="en-US"/>
-          </a:p>
-        </p:txBody>
-      </p:sp>
+            <a:endParaRPr lang="en-US" dirty="0"/>
+          </a:p>
+        </p:txBody>
+      </p:sp>
+      <p:pic>
+        <p:nvPicPr>
+          <p:cNvPr id="10" name="Grafik 9" descr="Volltreffer Silhouette">
+            <a:extLst>
+              <a:ext uri="{FF2B5EF4-FFF2-40B4-BE49-F238E27FC236}">
+                <a16:creationId xmlns:a16="http://schemas.microsoft.com/office/drawing/2014/main" id="{9D2231CA-982A-4F66-F230-07525E68DD06}"/>
+              </a:ext>
+            </a:extLst>
+          </p:cNvPr>
+          <p:cNvPicPr>
+            <a:picLocks noChangeAspect="1"/>
+          </p:cNvPicPr>
+          <p:nvPr/>
+        </p:nvPicPr>
+        <p:blipFill>
+          <a:blip r:embed="rId2">
+            <a:extLst>
+              <a:ext uri="{96DAC541-7B7A-43D3-8B79-37D633B846F1}">
+                <asvg:svgBlip xmlns:asvg="http://schemas.microsoft.com/office/drawing/2016/SVG/main" r:embed="rId3"/>
+              </a:ext>
+            </a:extLst>
+          </a:blip>
+          <a:stretch>
+            <a:fillRect/>
+          </a:stretch>
+        </p:blipFill>
+        <p:spPr>
+          <a:xfrm>
+            <a:off x="3800573" y="570706"/>
+            <a:ext cx="914400" cy="914400"/>
+          </a:xfrm>
+          <a:prstGeom prst="rect">
+            <a:avLst/>
+          </a:prstGeom>
+        </p:spPr>
+      </p:pic>
     </p:spTree>
     <p:extLst>
       <p:ext uri="{BB962C8B-B14F-4D97-AF65-F5344CB8AC3E}">
@@ -4812,7 +5144,11 @@
           <a:p>
             <a:r>
               <a:rPr lang="de-DE" dirty="0"/>
-              <a:t>Vollständigen Daten im Jahr 2025</a:t>
+              <a:t>Vollständigen Daten im </a:t>
+            </a:r>
+            <a:r>
+              <a:rPr lang="de-DE" b="1" dirty="0"/>
+              <a:t>Jahr 2025</a:t>
             </a:r>
           </a:p>
           <a:p>
@@ -4898,9 +5234,9 @@
           <a:p>
             <a:fld id="{979AD6E7-A48C-4424-B592-37C7B13B8FC0}" type="datetime1">
               <a:rPr lang="de-DE" smtClean="0"/>
-              <a:t>31.01.2026</a:t>
+              <a:t>02.02.2026</a:t>
             </a:fld>
-            <a:endParaRPr lang="en-US"/>
+            <a:endParaRPr lang="en-US" dirty="0"/>
           </a:p>
         </p:txBody>
       </p:sp>
@@ -4926,7 +5262,7 @@
           <a:lstStyle/>
           <a:p>
             <a:r>
-              <a:rPr lang="en-US"/>
+              <a:rPr lang="en-US" dirty="0"/>
               <a:t>Abschlussarbeit MySQL - Frank Wünsch</a:t>
             </a:r>
           </a:p>
@@ -4957,10 +5293,82 @@
               <a:rPr lang="en-US" smtClean="0"/>
               <a:t>6</a:t>
             </a:fld>
-            <a:endParaRPr lang="en-US"/>
-          </a:p>
-        </p:txBody>
-      </p:sp>
+            <a:endParaRPr lang="en-US" dirty="0"/>
+          </a:p>
+        </p:txBody>
+      </p:sp>
+      <p:pic>
+        <p:nvPicPr>
+          <p:cNvPr id="10" name="Grafik 9" descr="Eimer und Wischmopp Silhouette">
+            <a:extLst>
+              <a:ext uri="{FF2B5EF4-FFF2-40B4-BE49-F238E27FC236}">
+                <a16:creationId xmlns:a16="http://schemas.microsoft.com/office/drawing/2014/main" id="{E83BC10A-6E59-6FC9-3458-44D077A16E8F}"/>
+              </a:ext>
+            </a:extLst>
+          </p:cNvPr>
+          <p:cNvPicPr>
+            <a:picLocks noChangeAspect="1"/>
+          </p:cNvPicPr>
+          <p:nvPr/>
+        </p:nvPicPr>
+        <p:blipFill>
+          <a:blip r:embed="rId2">
+            <a:extLst>
+              <a:ext uri="{96DAC541-7B7A-43D3-8B79-37D633B846F1}">
+                <asvg:svgBlip xmlns:asvg="http://schemas.microsoft.com/office/drawing/2016/SVG/main" r:embed="rId3"/>
+              </a:ext>
+            </a:extLst>
+          </a:blip>
+          <a:stretch>
+            <a:fillRect/>
+          </a:stretch>
+        </p:blipFill>
+        <p:spPr>
+          <a:xfrm>
+            <a:off x="9067800" y="1893888"/>
+            <a:ext cx="914400" cy="914400"/>
+          </a:xfrm>
+          <a:prstGeom prst="rect">
+            <a:avLst/>
+          </a:prstGeom>
+        </p:spPr>
+      </p:pic>
+      <p:pic>
+        <p:nvPicPr>
+          <p:cNvPr id="12" name="Grafik 11" descr="Tageskalender Silhouette">
+            <a:extLst>
+              <a:ext uri="{FF2B5EF4-FFF2-40B4-BE49-F238E27FC236}">
+                <a16:creationId xmlns:a16="http://schemas.microsoft.com/office/drawing/2014/main" id="{F09F6FD4-C909-F126-F75F-588F00997980}"/>
+              </a:ext>
+            </a:extLst>
+          </p:cNvPr>
+          <p:cNvPicPr>
+            <a:picLocks noChangeAspect="1"/>
+          </p:cNvPicPr>
+          <p:nvPr/>
+        </p:nvPicPr>
+        <p:blipFill>
+          <a:blip r:embed="rId4">
+            <a:extLst>
+              <a:ext uri="{96DAC541-7B7A-43D3-8B79-37D633B846F1}">
+                <asvg:svgBlip xmlns:asvg="http://schemas.microsoft.com/office/drawing/2016/SVG/main" r:embed="rId5"/>
+              </a:ext>
+            </a:extLst>
+          </a:blip>
+          <a:stretch>
+            <a:fillRect/>
+          </a:stretch>
+        </p:blipFill>
+        <p:spPr>
+          <a:xfrm>
+            <a:off x="9067800" y="4705350"/>
+            <a:ext cx="914400" cy="914400"/>
+          </a:xfrm>
+          <a:prstGeom prst="rect">
+            <a:avLst/>
+          </a:prstGeom>
+        </p:spPr>
+      </p:pic>
     </p:spTree>
     <p:extLst>
       <p:ext uri="{BB962C8B-B14F-4D97-AF65-F5344CB8AC3E}">
@@ -5042,9 +5450,9 @@
           <a:p>
             <a:fld id="{979AD6E7-A48C-4424-B592-37C7B13B8FC0}" type="datetime1">
               <a:rPr lang="de-DE" smtClean="0"/>
-              <a:t>31.01.2026</a:t>
+              <a:t>02.02.2026</a:t>
             </a:fld>
-            <a:endParaRPr lang="en-US"/>
+            <a:endParaRPr lang="en-US" dirty="0"/>
           </a:p>
         </p:txBody>
       </p:sp>
@@ -5070,7 +5478,7 @@
           <a:lstStyle/>
           <a:p>
             <a:r>
-              <a:rPr lang="en-US"/>
+              <a:rPr lang="en-US" dirty="0"/>
               <a:t>Abschlussarbeit MySQL - Frank Wünsch</a:t>
             </a:r>
           </a:p>
@@ -5101,7 +5509,7 @@
               <a:rPr lang="en-US" smtClean="0"/>
               <a:t>7</a:t>
             </a:fld>
-            <a:endParaRPr lang="en-US"/>
+            <a:endParaRPr lang="en-US" dirty="0"/>
           </a:p>
         </p:txBody>
       </p:sp>
@@ -5271,7 +5679,7 @@
           <a:lstStyle/>
           <a:p>
             <a:r>
-              <a:rPr lang="en-US" dirty="0" err="1"/>
+              <a:rPr lang="en-US" dirty="0"/>
               <a:t>Fazit</a:t>
             </a:r>
             <a:endParaRPr lang="de-DE" dirty="0"/>
@@ -5302,55 +5710,35 @@
           <a:lstStyle/>
           <a:p>
             <a:r>
-              <a:rPr lang="de-DE" dirty="0">
-                <a:solidFill>
-                  <a:srgbClr val="00B050"/>
-                </a:solidFill>
-              </a:rPr>
+              <a:rPr lang="de-DE" dirty="0"/>
               <a:t>Datensatz sehr gut geeignet zum Lernen von</a:t>
             </a:r>
           </a:p>
           <a:p>
             <a:pPr lvl="1"/>
             <a:r>
-              <a:rPr lang="de-DE" dirty="0">
-                <a:solidFill>
-                  <a:srgbClr val="00B050"/>
-                </a:solidFill>
-              </a:rPr>
+              <a:rPr lang="de-DE" dirty="0"/>
               <a:t>Umgang mit MySQL</a:t>
             </a:r>
           </a:p>
           <a:p>
             <a:pPr lvl="1"/>
             <a:r>
-              <a:rPr lang="de-DE" dirty="0">
-                <a:solidFill>
-                  <a:srgbClr val="00B050"/>
-                </a:solidFill>
-              </a:rPr>
+              <a:rPr lang="de-DE" dirty="0"/>
               <a:t>Datenanalyse mit KNIME</a:t>
             </a:r>
           </a:p>
           <a:p>
             <a:pPr lvl="1"/>
             <a:r>
-              <a:rPr lang="de-DE" dirty="0">
-                <a:solidFill>
-                  <a:srgbClr val="00B050"/>
-                </a:solidFill>
-              </a:rPr>
+              <a:rPr lang="de-DE" dirty="0"/>
               <a:t>Erstellen von Vorhersagemodellen</a:t>
             </a:r>
           </a:p>
           <a:p>
             <a:pPr lvl="1"/>
             <a:r>
-              <a:rPr lang="de-DE" dirty="0">
-                <a:solidFill>
-                  <a:srgbClr val="00B050"/>
-                </a:solidFill>
-              </a:rPr>
+              <a:rPr lang="de-DE" dirty="0"/>
               <a:t>Visualisierung / Analyse mit Power BI</a:t>
             </a:r>
           </a:p>
@@ -5362,55 +5750,35 @@
           </a:p>
           <a:p>
             <a:r>
-              <a:rPr lang="de-DE" dirty="0">
-                <a:solidFill>
-                  <a:srgbClr val="FF0000"/>
-                </a:solidFill>
-              </a:rPr>
+              <a:rPr lang="de-DE" dirty="0"/>
               <a:t>Datensatz schlecht oder nicht geeignet für</a:t>
             </a:r>
           </a:p>
           <a:p>
             <a:pPr lvl="1"/>
             <a:r>
-              <a:rPr lang="de-DE" dirty="0">
-                <a:solidFill>
-                  <a:srgbClr val="FF0000"/>
-                </a:solidFill>
-              </a:rPr>
+              <a:rPr lang="de-DE" dirty="0"/>
               <a:t>Tiefgreifende Analysen zu</a:t>
             </a:r>
           </a:p>
           <a:p>
             <a:pPr lvl="2"/>
             <a:r>
-              <a:rPr lang="de-DE" dirty="0">
-                <a:solidFill>
-                  <a:srgbClr val="FF0000"/>
-                </a:solidFill>
-              </a:rPr>
+              <a:rPr lang="de-DE" dirty="0"/>
               <a:t>Feuchtigkeit und Niederschlag</a:t>
             </a:r>
           </a:p>
           <a:p>
             <a:pPr lvl="2"/>
             <a:r>
-              <a:rPr lang="de-DE" dirty="0">
-                <a:solidFill>
-                  <a:srgbClr val="FF0000"/>
-                </a:solidFill>
-              </a:rPr>
+              <a:rPr lang="de-DE" dirty="0"/>
               <a:t>Umweltverschmutzung durch Feuerwerke / Waldbrände etc.</a:t>
             </a:r>
           </a:p>
           <a:p>
             <a:pPr lvl="2"/>
             <a:r>
-              <a:rPr lang="de-DE" dirty="0">
-                <a:solidFill>
-                  <a:srgbClr val="FF0000"/>
-                </a:solidFill>
-              </a:rPr>
+              <a:rPr lang="de-DE" dirty="0"/>
               <a:t>Langzeitanalysen zum Wetter</a:t>
             </a:r>
           </a:p>
@@ -5439,9 +5807,9 @@
           <a:p>
             <a:fld id="{979AD6E7-A48C-4424-B592-37C7B13B8FC0}" type="datetime1">
               <a:rPr lang="de-DE" smtClean="0"/>
-              <a:t>31.01.2026</a:t>
+              <a:t>02.02.2026</a:t>
             </a:fld>
-            <a:endParaRPr lang="en-US"/>
+            <a:endParaRPr lang="en-US" dirty="0"/>
           </a:p>
         </p:txBody>
       </p:sp>
@@ -5467,7 +5835,7 @@
           <a:lstStyle/>
           <a:p>
             <a:r>
-              <a:rPr lang="en-US"/>
+              <a:rPr lang="en-US" dirty="0"/>
               <a:t>Abschlussarbeit MySQL - Frank Wünsch</a:t>
             </a:r>
           </a:p>
@@ -5498,10 +5866,82 @@
               <a:rPr lang="en-US" smtClean="0"/>
               <a:t>9</a:t>
             </a:fld>
-            <a:endParaRPr lang="en-US"/>
-          </a:p>
-        </p:txBody>
-      </p:sp>
+            <a:endParaRPr lang="en-US" dirty="0"/>
+          </a:p>
+        </p:txBody>
+      </p:sp>
+      <p:pic>
+        <p:nvPicPr>
+          <p:cNvPr id="10" name="Grafik 9" descr="Daumen hoch-Zeichen mit einfarbiger Füllung">
+            <a:extLst>
+              <a:ext uri="{FF2B5EF4-FFF2-40B4-BE49-F238E27FC236}">
+                <a16:creationId xmlns:a16="http://schemas.microsoft.com/office/drawing/2014/main" id="{0FDEF281-3D5A-4512-71B0-0C6F816D9DF5}"/>
+              </a:ext>
+            </a:extLst>
+          </p:cNvPr>
+          <p:cNvPicPr>
+            <a:picLocks noChangeAspect="1"/>
+          </p:cNvPicPr>
+          <p:nvPr/>
+        </p:nvPicPr>
+        <p:blipFill>
+          <a:blip r:embed="rId2">
+            <a:extLst>
+              <a:ext uri="{96DAC541-7B7A-43D3-8B79-37D633B846F1}">
+                <asvg:svgBlip xmlns:asvg="http://schemas.microsoft.com/office/drawing/2016/SVG/main" r:embed="rId3"/>
+              </a:ext>
+            </a:extLst>
+          </a:blip>
+          <a:stretch>
+            <a:fillRect/>
+          </a:stretch>
+        </p:blipFill>
+        <p:spPr>
+          <a:xfrm>
+            <a:off x="9534525" y="2063749"/>
+            <a:ext cx="1819275" cy="1819275"/>
+          </a:xfrm>
+          <a:prstGeom prst="rect">
+            <a:avLst/>
+          </a:prstGeom>
+        </p:spPr>
+      </p:pic>
+      <p:pic>
+        <p:nvPicPr>
+          <p:cNvPr id="12" name="Grafik 11" descr="Daumen runter mit einfarbiger Füllung">
+            <a:extLst>
+              <a:ext uri="{FF2B5EF4-FFF2-40B4-BE49-F238E27FC236}">
+                <a16:creationId xmlns:a16="http://schemas.microsoft.com/office/drawing/2014/main" id="{EFF7F61E-9C47-E8CB-5BA5-2B13D6A5E7A2}"/>
+              </a:ext>
+            </a:extLst>
+          </p:cNvPr>
+          <p:cNvPicPr>
+            <a:picLocks noChangeAspect="1"/>
+          </p:cNvPicPr>
+          <p:nvPr/>
+        </p:nvPicPr>
+        <p:blipFill>
+          <a:blip r:embed="rId4">
+            <a:extLst>
+              <a:ext uri="{96DAC541-7B7A-43D3-8B79-37D633B846F1}">
+                <asvg:svgBlip xmlns:asvg="http://schemas.microsoft.com/office/drawing/2016/SVG/main" r:embed="rId5"/>
+              </a:ext>
+            </a:extLst>
+          </a:blip>
+          <a:stretch>
+            <a:fillRect/>
+          </a:stretch>
+        </p:blipFill>
+        <p:spPr>
+          <a:xfrm>
+            <a:off x="9534525" y="4171951"/>
+            <a:ext cx="1824037" cy="1824037"/>
+          </a:xfrm>
+          <a:prstGeom prst="rect">
+            <a:avLst/>
+          </a:prstGeom>
+        </p:spPr>
+      </p:pic>
     </p:spTree>
     <p:extLst>
       <p:ext uri="{BB962C8B-B14F-4D97-AF65-F5344CB8AC3E}">
@@ -5532,34 +5972,34 @@
         <a:sysClr val="window" lastClr="FFFFFF"/>
       </a:lt1>
       <a:dk2>
-        <a:srgbClr val="44546A"/>
+        <a:srgbClr val="0E2841"/>
       </a:dk2>
       <a:lt2>
-        <a:srgbClr val="E7E6E6"/>
+        <a:srgbClr val="E8E8E8"/>
       </a:lt2>
       <a:accent1>
-        <a:srgbClr val="4472C4"/>
+        <a:srgbClr val="156082"/>
       </a:accent1>
       <a:accent2>
-        <a:srgbClr val="ED7D31"/>
+        <a:srgbClr val="E97132"/>
       </a:accent2>
       <a:accent3>
-        <a:srgbClr val="A5A5A5"/>
+        <a:srgbClr val="196B24"/>
       </a:accent3>
       <a:accent4>
-        <a:srgbClr val="FFC000"/>
+        <a:srgbClr val="0F9ED5"/>
       </a:accent4>
       <a:accent5>
-        <a:srgbClr val="5B9BD5"/>
+        <a:srgbClr val="A02B93"/>
       </a:accent5>
       <a:accent6>
-        <a:srgbClr val="70AD47"/>
+        <a:srgbClr val="4EA72E"/>
       </a:accent6>
       <a:hlink>
-        <a:srgbClr val="0563C1"/>
+        <a:srgbClr val="467886"/>
       </a:hlink>
       <a:folHlink>
-        <a:srgbClr val="954F72"/>
+        <a:srgbClr val="96607D"/>
       </a:folHlink>
     </a:clrScheme>
     <a:fontScheme name="Office">
@@ -6139,14 +6579,14 @@
     <we:property name="Microsoft.Office.CampaignId" value="&quot;none&quot;"/>
     <we:property name="artifactViewState" value="&quot;live&quot;"/>
     <we:property name="backgroundColor" value="&quot;#FFFFFF&quot;"/>
-    <we:property name="bookmark" value="&quot;H4sIAAAAAAAAA+VY32/cNgz+Vwo/bcBhsC3/Ut+Sa7aHZUGwDH0ZggMtUT4VOtuQ5SSX4P73UfJlTW9tb8lwbZK9STRF8uMnWpTuIqmH3sD6DFYYvY1OccBb1GKJ7ZskmkXtJM4rWWEqK6jzBFSmVFohfe16p7t2iN7eRQ5sg+69HkYw3hYJ/7ycRWDMOTR+psAMOIt6tEPXgtG3OCnTJ2dH3MwivOlNZ8GbvHDg0Ju9InWaUwjJT4w8gnD6Ci9QuEnK8hR5XLO8TkrOWSK5ikltmBRCZJ9V8aaD+3nXOtAtufGyNAGGsairOgcUrIIkVl4+6LYx24A/rv1j3fvkOLxxdXfj81F/IMfe0mZDgASP41KgYmWssrgQFU+kX620cVuH9frkpreUK8rgZG1OyJvOakGeQk4sDlMK7qJ5Z8ZVGJ18Ir/oRivwdwyxnrROuzVZ6mu9EN3YOqtxWFxrt1yo0ZhFGqd55OM7tx3REXQnvXUQL7vruUUKg4KNN5ck+Sp8uB0t/gb9p/jvqSIfHx6QsUW3Doi/BZzLwASkquCKx7wQdcbTUqLEvUwcyStoBWVhl4ajprHYgNtOT74DRz+P7bYE0idQJsDKXbo6K9EeT8S80/a+wtLZDo7nBt4zPIvKvMy55HleqzxhWZVWXL04gh2uaAiO6mkh0Ax6HHbwJt+Y7DPwNTwZnoMRo/k7KafQNiP92smDBP/ze7gyOj49Ovv1hx9JvD1YfjGoHbbk9s07ytNyEMtWOxfdE8gl8lIlkHGWcSV4zYviFRLIXi2BeSZlUTCWYVmmogBV8Zf3i91PYPZqCcxiLgoW87xgSaYY41mavTgCTSeCz0VoXP+XJ+WeFExkS1aKvEgzRm0p5Gku8ow9G7KTeGG6axzc4kE9EuzOGnmtJe4ihqtmsdLtA+0vFG/8zx0wO1Dj/VgM/6EBN3R9mZtxIOJQTpHOu1XdzZdg3b/cvMmBN+8hKd1cHuay8XQKp0uHSBA4yDitErr5CV9l1XOqsaVulo9kBG72M/KZHvWARfY4EN+5yg59RByU1AOW2VNJnOqMq6xkdF3Ic7rjy6SSiYJo36MNhPiPR+covp2Xm2D1oyRaoW1CL9uNbuhB4Dm0GND2U1Qagx5tZ6D+Sm7HNjRp1HPZyf97MKN3HV7CouCEQtK1wT0L/PtYFMLygDd/AfgszyG0EwAA&quot;"/>
+    <we:property name="bookmark" value="&quot;H4sIAAAAAAAAA+VYTW/cNhD9K4FOLbAoRFFfzM3euD3UNYy6yKUwFiNypGXAlQSKsr029r93SK0bZ5tkaxeb2O5NHI3mzZvHkYa6i5QeegPrM1hh9DY6xQFvUcsltm9YNIvayZwoyRLMmCjrUilacObvdr3TXTtEb+8iB7ZB914PIxgfi4x/Xs4iMOYcGr+qwQw4i3q0Q9eC0bc4OdMtZ0fczCK86U1nwYe8cODQh70id1pTCuwnToggnb7CC5RusvIsQRFXPKtYIQRnStQxuQ2TQ8jssy4+dICfd60D3RKMtyUMOMayKqsMUPISWFx7+6DbxmwT/vjsH+veF8fhjau6G1+P6gMB+0ibDRGSIo4LiTUv4jqNc1kKpvzTtTZuC1itT256S7WiCk7R5sS86ayWhBRqYnGYSnAXzTszrsLVySf2i260En/HkOtJ67RbU6S+0gvZja2zGofFtXbLRT0as0jiJIt8fue2IzmC7+S3DuZldz23SGlQsvHmkixfpQ+3o8XfoP+U/71UhPHhgRhbduvA+FvQuQxKQFLnohaxyGWViqRQqHCvEkfqClpJVdiV4ahpLDbgtsuT76DRz2O7bYHkCZJJsGpXrs4qtMeTMO+0ve+wZLbD47mR9wrPoiIrMqFEllV1xnhaJqWoX5zADld0CY76aSHRDHocdviybyz2GfgengLPwcjR/F2UU2ibkV7thKDAv/wePhkdnx6d/frDj2Teflh+MagdtgT75h3VaTnIZaudi+4FFApFUTNIBU9FLUUl8vwVCshfrYBZqlSec55iUSQyh7oUL+8Vu1/A9NUKmMZC5jwWWc5ZWnMu0iR9cQKaTgbMRRhc/5dfyj0lmMRWvJBZnqScxlLIkkxmKX82YrN4YbprHNziQT8S7c4ada0V7jKGq2ax0u0D7y80b/zPHTA70OD9WA7/YQA3dHyZm3Eg4VBNmc67VdXNl2Ddv9y87MCb95CSbi4Pc9h4uoTToUMyBAEqTkpGJz/pu6x8Tj221M3ykYrAzX5FPjOjHrDJHkfiO3fZoT8RBxX1gG32VBGnPhN1WnA6LmQZnfEVKxWrIdr30wZC/sejc5Tfzp+bEPWjJVqhbcIs241u6EHiObQY2PZTVhqDH21noPlKba9tGNJo5rIT/nswo4cOf8KiAOMJbP4CQaKhcYQTAAA=&quot;"/>
     <we:property name="creatorSessionId" value="&quot;3750dfa8-a1bf-4a49-9af8-ead35b5efc5d&quot;"/>
     <we:property name="creatorTenantId" value="&quot;7db25319-c04d-4699-88f4-84306cdd3f56&quot;"/>
     <we:property name="creatorUserId" value="&quot;1003200552DD16A3&quot;"/>
     <we:property name="datasetId" value="&quot;a4825fab-f32a-4358-aacf-34a6b7aed4a1&quot;"/>
     <we:property name="design" value="{&quot;border&quot;:{&quot;isActive&quot;:true,&quot;color&quot;:&quot;#808080&quot;,&quot;width&quot;:1,&quot;transparency&quot;:0,&quot;dash&quot;:&quot;solid&quot;}}"/>
     <we:property name="embedUrl" value="&quot;/reportEmbed?reportId=6cc6ad6e-eac0-4d54-981a-d449ef8bdc94&amp;config=eyJjbHVzdGVyVXJsIjoiaHR0cHM6Ly9XQUJJLUdFUk1BTlktV0VTVC1DRU5UUkFMLVBSSU1BUlktcmVkaXJlY3QuYW5hbHlzaXMud2luZG93cy5uZXQiLCJlbWJlZEZlYXR1cmVzIjp7InVzYWdlTWV0cmljc1ZOZXh0Ijp0cnVlfX0%3D&amp;disableSensitivityBanner=true&amp;storytellingChangeViewModeShortcutKeys=true&quot;"/>
-    <we:property name="initialStateBookmark" value="&quot;H4sIAAAAAAAAA+VY32/cNgz+Vwo/bcChsCz/Ut+Sa9qHZUHQFH0ZAoOWaJ8KnWXIcnKX4P730fZlTW/drslwbZK9STRN8uMnSpRuA6W71sD6DJYYvAlOscMb1HKBzSsWzIJmEmMYqyphKZOVYCJKZBrl9NW2XtumC97cBh5cjf6T7nowgy0S/nE5C8CYc6iHWQWmw1nQoutsA0bf4KRMn7zrcTMLcNUa62AweeHB42D2itRpTiGw15w8gvT6Ci9Q+knKkwhFWPKkZJkQnClRhaTWTQpjZN9UGUyP7ue28aAbcjPIIgYcQ1nmZQIoeQ4srAZ5p5vabAP+8u/HdTskx+PKl3Y15KP8TI4HS5sNAZIiDDOJFc/CKg5TmQumhr8rbfzWYbk+WbWOckUZnKzNCXltnZbkacyJw25KwW0wt6ZfjqOTr+QXtncSP+AY60njtV+TpbbUhbR9453GrrjWflFUvTFFFEZJMMR37izRMepOeutRvLDXc4cUBgUbbi5J8q/w4aZ3+Du0X+O/o4p8fL5HxhbdekT8I+BcjkxAVKWiEqFIZRmLKFOocC8TR+oKGklZ2KXhqK4d1uC305OfwNG7vtmWQPQIyiQ4tUuXdQrd8UTMW+3uKiya7eB4auAHhmdBlmSJUCJJStqmeJxHuaieHcEelzQET/VUSDSd7rsdvOwHk30GQw1PhudgZG/+SsopNHVPWzt5UDBsfvf/DI5Pj85+++VXEm8PlvcGtceG3L56S3ladHLRaO+DOwKFQpFVDGLBY1FJUYo0fYEE8hdLYBIrlaacx5hlkUyhysXz22L3Exi/WALjUMiUhyJJOYsrzkUcxc+OQGPl6LMYG9f/5Um5JwUT2YpnMkmjmFNbCgk19EnMnwzZLCyMvcbOF/fqkWBbZ9S1VriLGK7qYqmbe9r/ULzh31fA7ECN90Mx/IcG3ND1ZW76johDNUU6t8vSzhfg/HcuXnbgxXtISjeXh7lsPJ7C6dIhGYIAFUY5o5ufHKosf0o1ttD14oGMwGo/I9/oUQ9YZA8D8ZOr7NBHxEFJPWCZPZbEqc5EFWecrgtJQnd8xXLFKgj2PdrAGP9x7z3Ft/NyM1r9IgmW6Oqxl7W971qQeA4NjmjbKSqNox4tZ6D+Sm3HbmzSqOdyk/9PYPrxvcj1AybyQRHp0uB36k94N38CJXKryrMTAAA=&quot;"/>
+    <we:property name="initialStateBookmark" value="&quot;H4sIAAAAAAAAA+VY32/bNhD+Vwo9bYAxSKJ+mH1zXG8P+dGgGfoyBMKJPMksaEmgqCRO4P+9R8pZU6+blwxuk+xNOp3uu+8+nnTkXSBV32lYn8EKg7fBCfZ4i0ossXkTBZOgGc1H798fn84+HBdns9MFmdvOqrbpg7d3gQVTo/2o+gG0C0LGPy4nAWh9DrW7q0D3OAk6NH3bgFa3ODrTI2sG3EwCvOl0a8CFvLBg0YW9Ine6J+zoF0aIIKy6wgsUdrSyNEYeliwto5xzFkleheTWjw4+s2+6uNAeft42FlRDMM4WR8AwFOW0TAEFm0IUVs7eq6bW24S/vPv7unNVsXhjy/bG1aP8RMAu0mZDhAQPw1xgxfKwSsJMTHkk3duV0nYLWK4XN52hWlEFx2hzYl63RglC8jUx2I8luAvmrR5W/mrxlf2iHYzAD+hzXTRW2TVF6kpViHZorFHYF9fKLotq0LqIwzgNXH7npiU5vO/ot/bmZXs9N0hpULLh5pIs/0gfbgeDp9B9zf9eKsL49ECMLbu1Z/w96Fx6JSCuMl7xkGeiTHicS5S4V4mZvIJGUBV2ZZjVtcEa7PZ28QM0+nVoti0QP0EyAUbuytUaieZoFOadMvcdFk92eDw38k7hSZCnecolT9OySiOWTOMpr16cwBZXdAmW+qkQqHs19Dt8o+8s9hm4Hh4Dz0GLQf9ZlBNo6oE+7YQgwX38Hr4ZHJ3Mzo5/+pnM2z/KbxqVxYZg37yjOi17sWyUtcG9gFwiz6sIEs4SXgle8ix7hQKyVytgmkiZZYwlmOexyKCa8pf3id0vYPJqBUxCLjIW8jRjUVIxxpM4eXEC6lZ4zMJPrP/LP+WeEoxiS5aLNIsTRmMppHEq0oQ9G7GjsNDtNfa2eNCPRLs1Wl4ribuM4aouVqp54P03zRv+dQVMDjR4P5bDfxjANW1f5nroSTiUY6bzdlW28yUY+y8Xb3TgxXtISTeXh9lsPF3CcdMhIgQOMoynEe38hOuy6XPqsaWql49UBG72K/KNGfWATfY4Ej+4yw79izioqAdss6eKOPYZr5Kc0XYhTWmPL6OpjCoI9h3agM//aLCW8ts5ufFRv1iCFZraz7LtYPsOBJ5Dg55tN2al0PvRcgaar+T22vghjWYuM+J/BD04aH8SFngQSkmVGve84M7HAp+WI7z5DPUvyHetEwAA&quot;"/>
     <we:property name="isFiltersActionButtonVisible" value="true"/>
     <we:property name="isVisualContainerHeaderHidden" value="false"/>
     <we:property name="pageDisplayName" value="&quot;Weltweit&quot;"/>
@@ -6162,21 +6602,21 @@
 </file>
 
 <file path=customXml/item1.xml><?xml version="1.0" encoding="utf-8"?>
+<?mso-contentType ?>
+<FormTemplates xmlns="http://schemas.microsoft.com/sharepoint/v3/contenttype/forms">
+  <Display>DocumentLibraryForm</Display>
+  <Edit>DocumentLibraryForm</Edit>
+  <New>DocumentLibraryForm</New>
+</FormTemplates>
+</file>
+
+<file path=customXml/item2.xml><?xml version="1.0" encoding="utf-8"?>
 <p:properties xmlns:p="http://schemas.microsoft.com/office/2006/metadata/properties" xmlns:xsi="http://www.w3.org/2001/XMLSchema-instance" xmlns:pc="http://schemas.microsoft.com/office/infopath/2007/PartnerControls">
   <documentManagement>
     <Document_x0020_Purpose xmlns="f577acbf-5b0b-4b4f-9948-268e97f8d3a4">Informational</Document_x0020_Purpose>
     <Initiatives xmlns="f577acbf-5b0b-4b4f-9948-268e97f8d3a4"/>
   </documentManagement>
 </p:properties>
-</file>
-
-<file path=customXml/item2.xml><?xml version="1.0" encoding="utf-8"?>
-<?mso-contentType ?>
-<FormTemplates xmlns="http://schemas.microsoft.com/sharepoint/v3/contenttype/forms">
-  <Display>DocumentLibraryForm</Display>
-  <Edit>DocumentLibraryForm</Edit>
-  <New>DocumentLibraryForm</New>
-</FormTemplates>
 </file>
 
 <file path=customXml/item3.xml><?xml version="1.0" encoding="utf-8"?>
@@ -6436,6 +6876,14 @@
 </file>
 
 <file path=customXml/itemProps1.xml><?xml version="1.0" encoding="utf-8"?>
+<ds:datastoreItem xmlns:ds="http://schemas.openxmlformats.org/officeDocument/2006/customXml" ds:itemID="{E21AFCC0-734A-4A90-A597-A1CB34860DCD}">
+  <ds:schemaRefs>
+    <ds:schemaRef ds:uri="http://schemas.microsoft.com/sharepoint/v3/contenttype/forms"/>
+  </ds:schemaRefs>
+</ds:datastoreItem>
+</file>
+
+<file path=customXml/itemProps2.xml><?xml version="1.0" encoding="utf-8"?>
 <ds:datastoreItem xmlns:ds="http://schemas.openxmlformats.org/officeDocument/2006/customXml" ds:itemID="{617AB1FA-2F28-4684-9230-02ACEB6C0B0A}">
   <ds:schemaRefs>
     <ds:schemaRef ds:uri="http://purl.org/dc/elements/1.1/"/>
@@ -6448,14 +6896,6 @@
     <ds:schemaRef ds:uri="http://purl.org/dc/dcmitype/"/>
     <ds:schemaRef ds:uri="http://schemas.microsoft.com/office/infopath/2007/PartnerControls"/>
     <ds:schemaRef ds:uri="http://www.w3.org/XML/1998/namespace"/>
-  </ds:schemaRefs>
-</ds:datastoreItem>
-</file>
-
-<file path=customXml/itemProps2.xml><?xml version="1.0" encoding="utf-8"?>
-<ds:datastoreItem xmlns:ds="http://schemas.openxmlformats.org/officeDocument/2006/customXml" ds:itemID="{E21AFCC0-734A-4A90-A597-A1CB34860DCD}">
-  <ds:schemaRefs>
-    <ds:schemaRef ds:uri="http://schemas.microsoft.com/sharepoint/v3/contenttype/forms"/>
   </ds:schemaRefs>
 </ds:datastoreItem>
 </file>

</xml_diff>

<commit_message>
fix: formatting and typo
</commit_message>
<xml_diff>
--- a/Abschlusspräsentation_MySQL_Frank_Wünsch.pptx
+++ b/Abschlusspräsentation_MySQL_Frank_Wünsch.pptx
@@ -4759,6 +4759,36 @@
           </a:p>
         </p:txBody>
       </p:sp>
+      <p:pic>
+        <p:nvPicPr>
+          <p:cNvPr id="7" name="Grafik 6" descr="Ein Bild, das Text, Screenshot, Schrift, Zahl enthält.&#10;&#10;KI-generierte Inhalte können fehlerhaft sein.">
+            <a:extLst>
+              <a:ext uri="{FF2B5EF4-FFF2-40B4-BE49-F238E27FC236}">
+                <a16:creationId xmlns:a16="http://schemas.microsoft.com/office/drawing/2014/main" id="{95C010C0-8F52-0D86-E355-CF4FF22AABD4}"/>
+              </a:ext>
+            </a:extLst>
+          </p:cNvPr>
+          <p:cNvPicPr>
+            <a:picLocks noChangeAspect="1"/>
+          </p:cNvPicPr>
+          <p:nvPr/>
+        </p:nvPicPr>
+        <p:blipFill>
+          <a:blip r:embed="rId2"/>
+          <a:stretch>
+            <a:fillRect/>
+          </a:stretch>
+        </p:blipFill>
+        <p:spPr>
+          <a:xfrm>
+            <a:off x="838200" y="1690688"/>
+            <a:ext cx="8153400" cy="4195439"/>
+          </a:xfrm>
+          <a:prstGeom prst="rect">
+            <a:avLst/>
+          </a:prstGeom>
+        </p:spPr>
+      </p:pic>
     </p:spTree>
     <p:extLst>
       <p:ext uri="{BB962C8B-B14F-4D97-AF65-F5344CB8AC3E}">
@@ -5505,7 +5535,7 @@
         </p:blipFill>
         <p:spPr>
           <a:xfrm>
-            <a:off x="899328" y="1690688"/>
+            <a:off x="838200" y="1690688"/>
             <a:ext cx="10393343" cy="4225677"/>
           </a:xfrm>
           <a:prstGeom prst="rect">
@@ -5543,8 +5573,8 @@
           <a:chExt cx="0" cy="0"/>
         </a:xfrm>
       </p:grpSpPr>
-      <mc:AlternateContent xmlns:mc="http://schemas.openxmlformats.org/markup-compatibility/2006" xmlns:we="http://schemas.microsoft.com/office/webextensions/webextension/2010/11" xmlns:pca="http://schemas.microsoft.com/office/powerpoint/2013/contentapp">
-        <mc:Choice Requires="we pca">
+      <mc:AlternateContent xmlns:mc="http://schemas.openxmlformats.org/markup-compatibility/2006">
+        <mc:Choice xmlns:we="http://schemas.microsoft.com/office/webextensions/webextension/2010/11" xmlns:pca="http://schemas.microsoft.com/office/powerpoint/2013/contentapp" Requires="we pca">
           <p:graphicFrame>
             <p:nvGraphicFramePr>
               <p:cNvPr id="2" name="Add-in" descr="Add-In-Inhalt für Microsoft Power BI."/>
@@ -5570,7 +5600,7 @@
             </a:graphic>
           </p:graphicFrame>
         </mc:Choice>
-        <mc:Fallback xmlns="">
+        <mc:Fallback>
           <p:pic>
             <p:nvPicPr>
               <p:cNvPr id="2" name="Add-in" descr="Add-In-Inhalt für Microsoft Power BI."/>
@@ -6549,7 +6579,7 @@
     <we:property name="Microsoft.Office.CampaignId" value="&quot;none&quot;"/>
     <we:property name="artifactViewState" value="&quot;live&quot;"/>
     <we:property name="backgroundColor" value="&quot;#FFFFFF&quot;"/>
-    <we:property name="bookmark" value="&quot;H4sIAAAAAAAAA+VYTW/cNhD9K4FOLbAoRFFfzM3euD3UNYy6yKUwFiNypGXAlQSKsr029r93SK0bZ5tkaxeb2O5NHI3mzZvHkYa6i5QeegPrM1hh9DY6xQFvUcsltm9YNIvayZwoyRLMmCjrUilacObvdr3TXTtEb+8iB7ZB914PIxgfi4x/Xs4iMOYcGr+qwQw4i3q0Q9eC0bc4OdMtZ0fczCK86U1nwYe8cODQh70id1pTCuwnToggnb7CC5RusvIsQRFXPKtYIQRnStQxuQ2TQ8jssy4+dICfd60D3RKMtyUMOMayKqsMUPISWFx7+6DbxmwT/vjsH+veF8fhjau6G1+P6gMB+0ibDRGSIo4LiTUv4jqNc1kKpvzTtTZuC1itT256S7WiCk7R5sS86ayWhBRqYnGYSnAXzTszrsLVySf2i260En/HkOtJ67RbU6S+0gvZja2zGofFtXbLRT0as0jiJIt8fue2IzmC7+S3DuZldz23SGlQsvHmkixfpQ+3o8XfoP+U/71UhPHhgRhbduvA+FvQuQxKQFLnohaxyGWViqRQqHCvEkfqClpJVdiV4ahpLDbgtsuT76DRz2O7bYHkCZJJsGpXrs4qtMeTMO+0ve+wZLbD47mR9wrPoiIrMqFEllV1xnhaJqWoX5zADld0CY76aSHRDHocdviybyz2GfgengLPwcjR/F2UU2ibkV7thKDAv/wePhkdnx6d/frDj2Teflh+MagdtgT75h3VaTnIZaudi+4FFApFUTNIBU9FLUUl8vwVCshfrYBZqlSec55iUSQyh7oUL+8Vu1/A9NUKmMZC5jwWWc5ZWnMu0iR9cQKaTgbMRRhc/5dfyj0lmMRWvJBZnqScxlLIkkxmKX82YrN4YbprHNziQT8S7c4ada0V7jKGq2ax0u0D7y80b/zPHTA70OD9WA7/YQA3dHyZm3Eg4VBNmc67VdXNl2Ddv9y87MCb95CSbi4Pc9h4uoTToUMyBAEqTkpGJz/pu6x8Tj221M3ykYrAzX5FPjOjHrDJHkfiO3fZoT8RBxX1gG32VBGnPhN1WnA6LmQZnfEVKxWrIdr30wZC/sejc5Tfzp+bEPWjJVqhbcIs241u6EHiObQY2PZTVhqDH21noPlKba9tGNJo5rIT/nswo4cOf8KiAOMJbP4CQaKhcYQTAAA=&quot;"/>
+    <we:property name="bookmark" value="&quot;H4sIAAAAAAAAA+VYTW/cNhD9K4FOLbAoJFGUxNzsjdtDXcOog1wKYzEih1oGXEmgKHvXhv97R9S6cbZFNk6wju3epNFoPt7TI4e6jZTpOwubM1hh9DY6xR5v0MglNm+SaBY1k1mrUmRVyThTmCmWaJ4X9LTtvGmbPnp7G3lwNfoPph/AjrHI+NflLAJrz6Ee7zTYHmdRh65vG7DmBidneuTdgHezCNedbR2MIS88eBzDXpE73VMJyS+MMoL05govUPrJyniKIq4Yr5JCCJYooWNy6yeHUNl/uoyhQ/p523gwDaUZbWkCDGNZlRUHlKyEJNajvTdNbbcFf3r3/aYbwfG49lW7HvGoPlLiMdLdHTUkRRwXEjUrYp3FuSxFosa3tbF+m7DanKw7R1gRglO0OXVet85IyhQwcdhPENxG89YOq3B18pn9oh2cxD8x1HrSeOM3FKmrzEK2Q+OdwX5xbfxyoQdrF2mc8mis79y1REfwnfw2wbxsr+cOqQwqNr67JMsX24ebweEf0H3e/z1VlOPjAzK23W1Cx0/RzmVgAlKdCy1ikcsqE2mhUOFeJo7UFTSSUNil4aiuHdbgt7cnP4CjX4dmK4H0GyiT4NQuXa1T6I4nYt4Zd6+wdLbTx3NrfmR4FhW84EIJzivNE5aVaSn0iyPY44ouwZOeFhJtb4Z+p9/kick+g1HDU+A5WDnYf0A5haYeaGmnDArGxe/hm9Hx6dHZ7z/9TObtxvKbReOxobRv3hFOy14uG+N9dE+gUCgKnUAmWCa0FJXI81dIIHu1BPJMqTxnLMOiSGUOuhQvb4ndT2D2agnMYiFzFguesyTTjIkszV4cgbaVIeciDK7/y51yDwTb5VZnBaMllnOai1RSqkTD3kEXQpTjwXuK9e9pN0EQoOK0TGjQlTzlsnw2308SL5amXmLvFw80TlC2zqpro3AXRbiqFytYP/D++i15dqBh/tFNfMdUb+lMNLdDT9Shmkqdt6uqnS/B+WeiiIOSend5mCPMd5A4nWUUKyTP04zRiRJGlfGMPSed2fb6kYyYZj8j8ZPK7FE9/GCVJYdX2cEoPaDIvpHCUWNBZp+gj1bo6jDLtoPvO5B4Dg2GyrophMHgRx8e0HylttcuDGk0c7mJ+Q9gh/AzbfwTFoU0IdvfxwmxOoQTAAA=&quot;"/>
     <we:property name="creatorSessionId" value="&quot;3750dfa8-a1bf-4a49-9af8-ead35b5efc5d&quot;"/>
     <we:property name="creatorTenantId" value="&quot;7db25319-c04d-4699-88f4-84306cdd3f56&quot;"/>
     <we:property name="creatorUserId" value="&quot;1003200552DD16A3&quot;"/>
@@ -6572,21 +6602,21 @@
 </file>
 
 <file path=customXml/item1.xml><?xml version="1.0" encoding="utf-8"?>
+<?mso-contentType ?>
+<FormTemplates xmlns="http://schemas.microsoft.com/sharepoint/v3/contenttype/forms">
+  <Display>DocumentLibraryForm</Display>
+  <Edit>DocumentLibraryForm</Edit>
+  <New>DocumentLibraryForm</New>
+</FormTemplates>
+</file>
+
+<file path=customXml/item2.xml><?xml version="1.0" encoding="utf-8"?>
 <p:properties xmlns:p="http://schemas.microsoft.com/office/2006/metadata/properties" xmlns:xsi="http://www.w3.org/2001/XMLSchema-instance" xmlns:pc="http://schemas.microsoft.com/office/infopath/2007/PartnerControls">
   <documentManagement>
     <Document_x0020_Purpose xmlns="f577acbf-5b0b-4b4f-9948-268e97f8d3a4">Informational</Document_x0020_Purpose>
     <Initiatives xmlns="f577acbf-5b0b-4b4f-9948-268e97f8d3a4"/>
   </documentManagement>
 </p:properties>
-</file>
-
-<file path=customXml/item2.xml><?xml version="1.0" encoding="utf-8"?>
-<?mso-contentType ?>
-<FormTemplates xmlns="http://schemas.microsoft.com/sharepoint/v3/contenttype/forms">
-  <Display>DocumentLibraryForm</Display>
-  <Edit>DocumentLibraryForm</Edit>
-  <New>DocumentLibraryForm</New>
-</FormTemplates>
 </file>
 
 <file path=customXml/item3.xml><?xml version="1.0" encoding="utf-8"?>
@@ -6846,6 +6876,14 @@
 </file>
 
 <file path=customXml/itemProps1.xml><?xml version="1.0" encoding="utf-8"?>
+<ds:datastoreItem xmlns:ds="http://schemas.openxmlformats.org/officeDocument/2006/customXml" ds:itemID="{E21AFCC0-734A-4A90-A597-A1CB34860DCD}">
+  <ds:schemaRefs>
+    <ds:schemaRef ds:uri="http://schemas.microsoft.com/sharepoint/v3/contenttype/forms"/>
+  </ds:schemaRefs>
+</ds:datastoreItem>
+</file>
+
+<file path=customXml/itemProps2.xml><?xml version="1.0" encoding="utf-8"?>
 <ds:datastoreItem xmlns:ds="http://schemas.openxmlformats.org/officeDocument/2006/customXml" ds:itemID="{617AB1FA-2F28-4684-9230-02ACEB6C0B0A}">
   <ds:schemaRefs>
     <ds:schemaRef ds:uri="http://purl.org/dc/elements/1.1/"/>
@@ -6858,14 +6896,6 @@
     <ds:schemaRef ds:uri="http://purl.org/dc/dcmitype/"/>
     <ds:schemaRef ds:uri="http://schemas.microsoft.com/office/infopath/2007/PartnerControls"/>
     <ds:schemaRef ds:uri="http://www.w3.org/XML/1998/namespace"/>
-  </ds:schemaRefs>
-</ds:datastoreItem>
-</file>
-
-<file path=customXml/itemProps2.xml><?xml version="1.0" encoding="utf-8"?>
-<ds:datastoreItem xmlns:ds="http://schemas.openxmlformats.org/officeDocument/2006/customXml" ds:itemID="{E21AFCC0-734A-4A90-A597-A1CB34860DCD}">
-  <ds:schemaRefs>
-    <ds:schemaRef ds:uri="http://schemas.microsoft.com/sharepoint/v3/contenttype/forms"/>
   </ds:schemaRefs>
 </ds:datastoreItem>
 </file>

</xml_diff>